<commit_message>
Add hierarchy-test slide: Tatum-led lineups vs Brown-led vs together
2024-25 five-man net ratings from tatum_vs_brown.md: Tatum-led +11.9
(1,212 min) > Brown-led +9.8 (753 min) > together +7.6 (1,411 min),
with shot-diet contrast and the led-minutes/garbage-time caveats on
the slide. Deck is now 9 slides.

Co-Authored-By: Claude Fable 5 <noreply@anthropic.com>
</commit_message>
<xml_diff>
--- a/outputs/Fit_Check_Jaylen_Brown.pptx
+++ b/outputs/Fit_Check_Jaylen_Brown.pptx
@@ -13,6 +13,7 @@
     <p:sldId id="261" r:id="rId12"/>
     <p:sldId id="262" r:id="rId13"/>
     <p:sldId id="263" r:id="rId14"/>
+    <p:sldId id="264" r:id="rId15"/>
   </p:sldIdLst>
   <p:sldSz cx="12191695" cy="6858000" type="screen4x3"/>
   <p:notesSz cx="6858000" cy="9144000"/>
@@ -5233,7 +5234,7 @@
                 </a:solidFill>
                 <a:latin typeface="Calibri"/>
               </a:rPr>
-              <a:t>THE CONTRACT</a:t>
+              <a:t>THE HIERARCHY TEST</a:t>
             </a:r>
           </a:p>
         </p:txBody>
@@ -5275,35 +5276,59 @@
                 </a:solidFill>
                 <a:latin typeface="Cambria"/>
               </a:rPr>
-              <a:t>Max-contract price, below-median-efficiency production</a:t>
-            </a:r>
-          </a:p>
-        </p:txBody>
-      </p:sp>
-      <p:pic>
-        <p:nvPicPr>
-          <p:cNvPr id="4" name="Picture 3" descr="efficiency_comps.png"/>
-          <p:cNvPicPr>
-            <a:picLocks noChangeAspect="1"/>
-          </p:cNvPicPr>
-          <p:nvPr/>
-        </p:nvPicPr>
-        <p:blipFill>
-          <a:blip r:embed="rId2"/>
-          <a:stretch>
-            <a:fillRect/>
-          </a:stretch>
-        </p:blipFill>
-        <p:spPr>
-          <a:xfrm>
-            <a:off x="1097280" y="1508760"/>
-            <a:ext cx="9966960" cy="4111782"/>
-          </a:xfrm>
-          <a:prstGeom prst="rect">
-            <a:avLst/>
-          </a:prstGeom>
-        </p:spPr>
-      </p:pic>
+              <a:t>Tatum-led was the best version of the offense — together was the worst</a:t>
+            </a:r>
+          </a:p>
+        </p:txBody>
+      </p:sp>
+      <p:sp>
+        <p:nvSpPr>
+          <p:cNvPr id="4" name="Rounded Rectangle 3"/>
+          <p:cNvSpPr/>
+          <p:nvPr/>
+        </p:nvSpPr>
+        <p:spPr>
+          <a:xfrm>
+            <a:off x="566928" y="1783080"/>
+            <a:ext cx="3502152" cy="2057400"/>
+          </a:xfrm>
+          <a:prstGeom prst="roundRect">
+            <a:avLst>
+              <a:gd name="adj" fmla="val 8000"/>
+            </a:avLst>
+          </a:prstGeom>
+          <a:solidFill>
+            <a:srgbClr val="FFFFFF"/>
+          </a:solidFill>
+          <a:ln w="12700">
+            <a:solidFill>
+              <a:srgbClr val="D7DAE0"/>
+            </a:solidFill>
+          </a:ln>
+          <a:effectLst/>
+        </p:spPr>
+        <p:style>
+          <a:lnRef idx="1">
+            <a:schemeClr val="accent1"/>
+          </a:lnRef>
+          <a:fillRef idx="3">
+            <a:schemeClr val="accent1"/>
+          </a:fillRef>
+          <a:effectRef idx="2">
+            <a:schemeClr val="accent1"/>
+          </a:effectRef>
+          <a:fontRef idx="minor">
+            <a:schemeClr val="lt1"/>
+          </a:fontRef>
+        </p:style>
+        <p:txBody>
+          <a:bodyPr rtlCol="0" anchor="ctr"/>
+          <a:lstStyle/>
+          <a:p>
+            <a:pPr algn="ctr"/>
+          </a:p>
+        </p:txBody>
+      </p:sp>
       <p:sp>
         <p:nvSpPr>
           <p:cNvPr id="5" name="TextBox 4"/>
@@ -5312,8 +5337,8 @@
         </p:nvSpPr>
         <p:spPr>
           <a:xfrm>
-            <a:off x="566928" y="5806440"/>
-            <a:ext cx="11064240" cy="640080"/>
+            <a:off x="822960" y="1975104"/>
+            <a:ext cx="3044952" cy="822960"/>
           </a:xfrm>
           <a:prstGeom prst="rect">
             <a:avLst/>
@@ -5328,29 +5353,20 @@
           <a:p>
             <a:pPr algn="l">
               <a:lnSpc>
-                <a:spcPct val="110000"/>
-              </a:lnSpc>
-              <a:spcAft>
-                <a:spcPts val="400"/>
-              </a:spcAft>
-            </a:pPr>
-            <a:r>
-              <a:rPr sz="1400" b="0" i="0">
-                <a:solidFill>
-                  <a:srgbClr val="20232A"/>
-                </a:solidFill>
-                <a:latin typeface="Calibri"/>
-              </a:rPr>
-              <a:t>6.9 WS on $53.1M = $7.7M per win share at 34% of the cap, with a 0.573 TS% — below the max-wing median. </a:t>
-            </a:r>
-            <a:r>
-              <a:rPr sz="1400" b="1" i="0">
+                <a:spcPct val="100000"/>
+              </a:lnSpc>
+              <a:spcAft>
+                <a:spcPts val="0"/>
+              </a:spcAft>
+            </a:pPr>
+            <a:r>
+              <a:rPr sz="4200" b="1" i="0">
                 <a:solidFill>
                   <a:srgbClr val="007A33"/>
                 </a:solidFill>
-                <a:latin typeface="Calibri"/>
-              </a:rPr>
-              <a:t>Picks 15-30 buy the same wins at ~$2.1M/WS on rookie deals.</a:t>
+                <a:latin typeface="Cambria"/>
+              </a:rPr>
+              <a:t>+11.9</a:t>
             </a:r>
           </a:p>
         </p:txBody>
@@ -5358,6 +5374,670 @@
       <p:sp>
         <p:nvSpPr>
           <p:cNvPr id="6" name="TextBox 5"/>
+          <p:cNvSpPr txBox="1"/>
+          <p:nvPr/>
+        </p:nvSpPr>
+        <p:spPr>
+          <a:xfrm>
+            <a:off x="841247" y="2834640"/>
+            <a:ext cx="2999232" cy="365760"/>
+          </a:xfrm>
+          <a:prstGeom prst="rect">
+            <a:avLst/>
+          </a:prstGeom>
+          <a:noFill/>
+        </p:spPr>
+        <p:txBody>
+          <a:bodyPr wrap="square" anchor="t" lIns="0" rIns="0" tIns="0" bIns="0">
+            <a:spAutoFit/>
+          </a:bodyPr>
+          <a:lstStyle/>
+          <a:p>
+            <a:pPr algn="l">
+              <a:lnSpc>
+                <a:spcPct val="100000"/>
+              </a:lnSpc>
+              <a:spcAft>
+                <a:spcPts val="0"/>
+              </a:spcAft>
+            </a:pPr>
+            <a:r>
+              <a:rPr sz="1450" b="1" i="0">
+                <a:solidFill>
+                  <a:srgbClr val="0A2A1A"/>
+                </a:solidFill>
+                <a:latin typeface="Calibri"/>
+              </a:rPr>
+              <a:t>Tatum-led (Brown off)</a:t>
+            </a:r>
+          </a:p>
+        </p:txBody>
+      </p:sp>
+      <p:sp>
+        <p:nvSpPr>
+          <p:cNvPr id="7" name="TextBox 6"/>
+          <p:cNvSpPr txBox="1"/>
+          <p:nvPr/>
+        </p:nvSpPr>
+        <p:spPr>
+          <a:xfrm>
+            <a:off x="841247" y="3172968"/>
+            <a:ext cx="2999232" cy="365760"/>
+          </a:xfrm>
+          <a:prstGeom prst="rect">
+            <a:avLst/>
+          </a:prstGeom>
+          <a:noFill/>
+        </p:spPr>
+        <p:txBody>
+          <a:bodyPr wrap="square" anchor="t" lIns="0" rIns="0" tIns="0" bIns="0">
+            <a:spAutoFit/>
+          </a:bodyPr>
+          <a:lstStyle/>
+          <a:p>
+            <a:pPr algn="l">
+              <a:lnSpc>
+                <a:spcPct val="100000"/>
+              </a:lnSpc>
+              <a:spcAft>
+                <a:spcPts val="0"/>
+              </a:spcAft>
+            </a:pPr>
+            <a:r>
+              <a:rPr sz="1200" b="0" i="0">
+                <a:solidFill>
+                  <a:srgbClr val="6B7280"/>
+                </a:solidFill>
+                <a:latin typeface="Calibri"/>
+              </a:rPr>
+              <a:t>1,212 min · 2024-25</a:t>
+            </a:r>
+          </a:p>
+        </p:txBody>
+      </p:sp>
+      <p:sp>
+        <p:nvSpPr>
+          <p:cNvPr id="8" name="Rounded Rectangle 7"/>
+          <p:cNvSpPr/>
+          <p:nvPr/>
+        </p:nvSpPr>
+        <p:spPr>
+          <a:xfrm>
+            <a:off x="4352544" y="1783080"/>
+            <a:ext cx="3502152" cy="2057400"/>
+          </a:xfrm>
+          <a:prstGeom prst="roundRect">
+            <a:avLst>
+              <a:gd name="adj" fmla="val 8000"/>
+            </a:avLst>
+          </a:prstGeom>
+          <a:solidFill>
+            <a:srgbClr val="FFFFFF"/>
+          </a:solidFill>
+          <a:ln w="12700">
+            <a:solidFill>
+              <a:srgbClr val="D7DAE0"/>
+            </a:solidFill>
+          </a:ln>
+          <a:effectLst/>
+        </p:spPr>
+        <p:style>
+          <a:lnRef idx="1">
+            <a:schemeClr val="accent1"/>
+          </a:lnRef>
+          <a:fillRef idx="3">
+            <a:schemeClr val="accent1"/>
+          </a:fillRef>
+          <a:effectRef idx="2">
+            <a:schemeClr val="accent1"/>
+          </a:effectRef>
+          <a:fontRef idx="minor">
+            <a:schemeClr val="lt1"/>
+          </a:fontRef>
+        </p:style>
+        <p:txBody>
+          <a:bodyPr rtlCol="0" anchor="ctr"/>
+          <a:lstStyle/>
+          <a:p>
+            <a:pPr algn="ctr"/>
+          </a:p>
+        </p:txBody>
+      </p:sp>
+      <p:sp>
+        <p:nvSpPr>
+          <p:cNvPr id="9" name="TextBox 8"/>
+          <p:cNvSpPr txBox="1"/>
+          <p:nvPr/>
+        </p:nvSpPr>
+        <p:spPr>
+          <a:xfrm>
+            <a:off x="4608576" y="1975104"/>
+            <a:ext cx="3044952" cy="822960"/>
+          </a:xfrm>
+          <a:prstGeom prst="rect">
+            <a:avLst/>
+          </a:prstGeom>
+          <a:noFill/>
+        </p:spPr>
+        <p:txBody>
+          <a:bodyPr wrap="square" anchor="t" lIns="0" rIns="0" tIns="0" bIns="0">
+            <a:spAutoFit/>
+          </a:bodyPr>
+          <a:lstStyle/>
+          <a:p>
+            <a:pPr algn="l">
+              <a:lnSpc>
+                <a:spcPct val="100000"/>
+              </a:lnSpc>
+              <a:spcAft>
+                <a:spcPts val="0"/>
+              </a:spcAft>
+            </a:pPr>
+            <a:r>
+              <a:rPr sz="4200" b="1" i="0">
+                <a:solidFill>
+                  <a:srgbClr val="0A2A1A"/>
+                </a:solidFill>
+                <a:latin typeface="Cambria"/>
+              </a:rPr>
+              <a:t>+9.8</a:t>
+            </a:r>
+          </a:p>
+        </p:txBody>
+      </p:sp>
+      <p:sp>
+        <p:nvSpPr>
+          <p:cNvPr id="10" name="TextBox 9"/>
+          <p:cNvSpPr txBox="1"/>
+          <p:nvPr/>
+        </p:nvSpPr>
+        <p:spPr>
+          <a:xfrm>
+            <a:off x="4626864" y="2834640"/>
+            <a:ext cx="2999232" cy="365760"/>
+          </a:xfrm>
+          <a:prstGeom prst="rect">
+            <a:avLst/>
+          </a:prstGeom>
+          <a:noFill/>
+        </p:spPr>
+        <p:txBody>
+          <a:bodyPr wrap="square" anchor="t" lIns="0" rIns="0" tIns="0" bIns="0">
+            <a:spAutoFit/>
+          </a:bodyPr>
+          <a:lstStyle/>
+          <a:p>
+            <a:pPr algn="l">
+              <a:lnSpc>
+                <a:spcPct val="100000"/>
+              </a:lnSpc>
+              <a:spcAft>
+                <a:spcPts val="0"/>
+              </a:spcAft>
+            </a:pPr>
+            <a:r>
+              <a:rPr sz="1450" b="1" i="0">
+                <a:solidFill>
+                  <a:srgbClr val="0A2A1A"/>
+                </a:solidFill>
+                <a:latin typeface="Calibri"/>
+              </a:rPr>
+              <a:t>Brown-led (Tatum off)</a:t>
+            </a:r>
+          </a:p>
+        </p:txBody>
+      </p:sp>
+      <p:sp>
+        <p:nvSpPr>
+          <p:cNvPr id="11" name="TextBox 10"/>
+          <p:cNvSpPr txBox="1"/>
+          <p:nvPr/>
+        </p:nvSpPr>
+        <p:spPr>
+          <a:xfrm>
+            <a:off x="4626864" y="3172968"/>
+            <a:ext cx="2999232" cy="365760"/>
+          </a:xfrm>
+          <a:prstGeom prst="rect">
+            <a:avLst/>
+          </a:prstGeom>
+          <a:noFill/>
+        </p:spPr>
+        <p:txBody>
+          <a:bodyPr wrap="square" anchor="t" lIns="0" rIns="0" tIns="0" bIns="0">
+            <a:spAutoFit/>
+          </a:bodyPr>
+          <a:lstStyle/>
+          <a:p>
+            <a:pPr algn="l">
+              <a:lnSpc>
+                <a:spcPct val="100000"/>
+              </a:lnSpc>
+              <a:spcAft>
+                <a:spcPts val="0"/>
+              </a:spcAft>
+            </a:pPr>
+            <a:r>
+              <a:rPr sz="1200" b="0" i="0">
+                <a:solidFill>
+                  <a:srgbClr val="6B7280"/>
+                </a:solidFill>
+                <a:latin typeface="Calibri"/>
+              </a:rPr>
+              <a:t>753 min · 2024-25</a:t>
+            </a:r>
+          </a:p>
+        </p:txBody>
+      </p:sp>
+      <p:sp>
+        <p:nvSpPr>
+          <p:cNvPr id="12" name="Rounded Rectangle 11"/>
+          <p:cNvSpPr/>
+          <p:nvPr/>
+        </p:nvSpPr>
+        <p:spPr>
+          <a:xfrm>
+            <a:off x="8138159" y="1783080"/>
+            <a:ext cx="3502152" cy="2057400"/>
+          </a:xfrm>
+          <a:prstGeom prst="roundRect">
+            <a:avLst>
+              <a:gd name="adj" fmla="val 8000"/>
+            </a:avLst>
+          </a:prstGeom>
+          <a:solidFill>
+            <a:srgbClr val="FFFFFF"/>
+          </a:solidFill>
+          <a:ln w="12700">
+            <a:solidFill>
+              <a:srgbClr val="D7DAE0"/>
+            </a:solidFill>
+          </a:ln>
+          <a:effectLst/>
+        </p:spPr>
+        <p:style>
+          <a:lnRef idx="1">
+            <a:schemeClr val="accent1"/>
+          </a:lnRef>
+          <a:fillRef idx="3">
+            <a:schemeClr val="accent1"/>
+          </a:fillRef>
+          <a:effectRef idx="2">
+            <a:schemeClr val="accent1"/>
+          </a:effectRef>
+          <a:fontRef idx="minor">
+            <a:schemeClr val="lt1"/>
+          </a:fontRef>
+        </p:style>
+        <p:txBody>
+          <a:bodyPr rtlCol="0" anchor="ctr"/>
+          <a:lstStyle/>
+          <a:p>
+            <a:pPr algn="ctr"/>
+          </a:p>
+        </p:txBody>
+      </p:sp>
+      <p:sp>
+        <p:nvSpPr>
+          <p:cNvPr id="13" name="TextBox 12"/>
+          <p:cNvSpPr txBox="1"/>
+          <p:nvPr/>
+        </p:nvSpPr>
+        <p:spPr>
+          <a:xfrm>
+            <a:off x="8394191" y="1975104"/>
+            <a:ext cx="3044952" cy="822960"/>
+          </a:xfrm>
+          <a:prstGeom prst="rect">
+            <a:avLst/>
+          </a:prstGeom>
+          <a:noFill/>
+        </p:spPr>
+        <p:txBody>
+          <a:bodyPr wrap="square" anchor="t" lIns="0" rIns="0" tIns="0" bIns="0">
+            <a:spAutoFit/>
+          </a:bodyPr>
+          <a:lstStyle/>
+          <a:p>
+            <a:pPr algn="l">
+              <a:lnSpc>
+                <a:spcPct val="100000"/>
+              </a:lnSpc>
+              <a:spcAft>
+                <a:spcPts val="0"/>
+              </a:spcAft>
+            </a:pPr>
+            <a:r>
+              <a:rPr sz="4200" b="1" i="0">
+                <a:solidFill>
+                  <a:srgbClr val="B3403A"/>
+                </a:solidFill>
+                <a:latin typeface="Cambria"/>
+              </a:rPr>
+              <a:t>+7.6</a:t>
+            </a:r>
+          </a:p>
+        </p:txBody>
+      </p:sp>
+      <p:sp>
+        <p:nvSpPr>
+          <p:cNvPr id="14" name="TextBox 13"/>
+          <p:cNvSpPr txBox="1"/>
+          <p:nvPr/>
+        </p:nvSpPr>
+        <p:spPr>
+          <a:xfrm>
+            <a:off x="8412480" y="2834640"/>
+            <a:ext cx="2999232" cy="365760"/>
+          </a:xfrm>
+          <a:prstGeom prst="rect">
+            <a:avLst/>
+          </a:prstGeom>
+          <a:noFill/>
+        </p:spPr>
+        <p:txBody>
+          <a:bodyPr wrap="square" anchor="t" lIns="0" rIns="0" tIns="0" bIns="0">
+            <a:spAutoFit/>
+          </a:bodyPr>
+          <a:lstStyle/>
+          <a:p>
+            <a:pPr algn="l">
+              <a:lnSpc>
+                <a:spcPct val="100000"/>
+              </a:lnSpc>
+              <a:spcAft>
+                <a:spcPts val="0"/>
+              </a:spcAft>
+            </a:pPr>
+            <a:r>
+              <a:rPr sz="1450" b="1" i="0">
+                <a:solidFill>
+                  <a:srgbClr val="0A2A1A"/>
+                </a:solidFill>
+                <a:latin typeface="Calibri"/>
+              </a:rPr>
+              <a:t>the two together</a:t>
+            </a:r>
+          </a:p>
+        </p:txBody>
+      </p:sp>
+      <p:sp>
+        <p:nvSpPr>
+          <p:cNvPr id="15" name="TextBox 14"/>
+          <p:cNvSpPr txBox="1"/>
+          <p:nvPr/>
+        </p:nvSpPr>
+        <p:spPr>
+          <a:xfrm>
+            <a:off x="8412480" y="3172968"/>
+            <a:ext cx="2999232" cy="365760"/>
+          </a:xfrm>
+          <a:prstGeom prst="rect">
+            <a:avLst/>
+          </a:prstGeom>
+          <a:noFill/>
+        </p:spPr>
+        <p:txBody>
+          <a:bodyPr wrap="square" anchor="t" lIns="0" rIns="0" tIns="0" bIns="0">
+            <a:spAutoFit/>
+          </a:bodyPr>
+          <a:lstStyle/>
+          <a:p>
+            <a:pPr algn="l">
+              <a:lnSpc>
+                <a:spcPct val="100000"/>
+              </a:lnSpc>
+              <a:spcAft>
+                <a:spcPts val="0"/>
+              </a:spcAft>
+            </a:pPr>
+            <a:r>
+              <a:rPr sz="1200" b="0" i="0">
+                <a:solidFill>
+                  <a:srgbClr val="6B7280"/>
+                </a:solidFill>
+                <a:latin typeface="Calibri"/>
+              </a:rPr>
+              <a:t>1,411 min · 2024-25</a:t>
+            </a:r>
+          </a:p>
+        </p:txBody>
+      </p:sp>
+      <p:sp>
+        <p:nvSpPr>
+          <p:cNvPr id="16" name="TextBox 15"/>
+          <p:cNvSpPr txBox="1"/>
+          <p:nvPr/>
+        </p:nvSpPr>
+        <p:spPr>
+          <a:xfrm>
+            <a:off x="566928" y="4160520"/>
+            <a:ext cx="11064240" cy="365760"/>
+          </a:xfrm>
+          <a:prstGeom prst="rect">
+            <a:avLst/>
+          </a:prstGeom>
+          <a:noFill/>
+        </p:spPr>
+        <p:txBody>
+          <a:bodyPr wrap="square" anchor="t" lIns="0" rIns="0" tIns="0" bIns="0">
+            <a:spAutoFit/>
+          </a:bodyPr>
+          <a:lstStyle/>
+          <a:p>
+            <a:pPr algn="l">
+              <a:lnSpc>
+                <a:spcPct val="100000"/>
+              </a:lnSpc>
+              <a:spcAft>
+                <a:spcPts val="0"/>
+              </a:spcAft>
+            </a:pPr>
+            <a:r>
+              <a:rPr sz="1350" b="1" i="0">
+                <a:solidFill>
+                  <a:srgbClr val="0A2A1A"/>
+                </a:solidFill>
+                <a:latin typeface="Calibri"/>
+              </a:rPr>
+              <a:t>Net rating of five-man lineups, the healthy season — first-option basketball beat load-sharing.</a:t>
+            </a:r>
+          </a:p>
+        </p:txBody>
+      </p:sp>
+      <p:sp>
+        <p:nvSpPr>
+          <p:cNvPr id="17" name="Oval 16"/>
+          <p:cNvSpPr/>
+          <p:nvPr/>
+        </p:nvSpPr>
+        <p:spPr>
+          <a:xfrm>
+            <a:off x="640080" y="4745736"/>
+            <a:ext cx="146304" cy="146304"/>
+          </a:xfrm>
+          <a:prstGeom prst="ellipse">
+            <a:avLst/>
+          </a:prstGeom>
+          <a:solidFill>
+            <a:srgbClr val="007A33"/>
+          </a:solidFill>
+          <a:ln>
+            <a:noFill/>
+          </a:ln>
+          <a:effectLst/>
+        </p:spPr>
+        <p:style>
+          <a:lnRef idx="1">
+            <a:schemeClr val="accent1"/>
+          </a:lnRef>
+          <a:fillRef idx="3">
+            <a:schemeClr val="accent1"/>
+          </a:fillRef>
+          <a:effectRef idx="2">
+            <a:schemeClr val="accent1"/>
+          </a:effectRef>
+          <a:fontRef idx="minor">
+            <a:schemeClr val="lt1"/>
+          </a:fontRef>
+        </p:style>
+        <p:txBody>
+          <a:bodyPr rtlCol="0" anchor="ctr"/>
+          <a:lstStyle/>
+          <a:p>
+            <a:pPr algn="ctr"/>
+          </a:p>
+        </p:txBody>
+      </p:sp>
+      <p:sp>
+        <p:nvSpPr>
+          <p:cNvPr id="18" name="TextBox 17"/>
+          <p:cNvSpPr txBox="1"/>
+          <p:nvPr/>
+        </p:nvSpPr>
+        <p:spPr>
+          <a:xfrm>
+            <a:off x="932688" y="4709160"/>
+            <a:ext cx="10607040" cy="777240"/>
+          </a:xfrm>
+          <a:prstGeom prst="rect">
+            <a:avLst/>
+          </a:prstGeom>
+          <a:noFill/>
+        </p:spPr>
+        <p:txBody>
+          <a:bodyPr wrap="square" anchor="t" lIns="0" rIns="0" tIns="0" bIns="0">
+            <a:spAutoFit/>
+          </a:bodyPr>
+          <a:lstStyle/>
+          <a:p>
+            <a:pPr algn="l">
+              <a:lnSpc>
+                <a:spcPct val="108000"/>
+              </a:lnSpc>
+              <a:spcAft>
+                <a:spcPts val="200"/>
+              </a:spcAft>
+            </a:pPr>
+            <a:r>
+              <a:rPr sz="1350" b="1" i="0">
+                <a:solidFill>
+                  <a:srgbClr val="0A2A1A"/>
+                </a:solidFill>
+                <a:latin typeface="Calibri"/>
+              </a:rPr>
+              <a:t>Tatum's diet IS the system  </a:t>
+            </a:r>
+            <a:r>
+              <a:rPr sz="1250" b="0" i="0">
+                <a:solidFill>
+                  <a:srgbClr val="6B7280"/>
+                </a:solidFill>
+                <a:latin typeface="Calibri"/>
+              </a:rPr>
+              <a:t>Half his shots are threes (0.498 vs Brown's 0.262) and his long-two rate is 0.059 vs Brown's 0.142. His self-creation terminates in the anchor shot; Brown's terminated in the shot the system avoids.</a:t>
+            </a:r>
+          </a:p>
+        </p:txBody>
+      </p:sp>
+      <p:sp>
+        <p:nvSpPr>
+          <p:cNvPr id="19" name="Oval 18"/>
+          <p:cNvSpPr/>
+          <p:nvPr/>
+        </p:nvSpPr>
+        <p:spPr>
+          <a:xfrm>
+            <a:off x="640080" y="5586984"/>
+            <a:ext cx="146304" cy="146304"/>
+          </a:xfrm>
+          <a:prstGeom prst="ellipse">
+            <a:avLst/>
+          </a:prstGeom>
+          <a:solidFill>
+            <a:srgbClr val="BA9653"/>
+          </a:solidFill>
+          <a:ln>
+            <a:noFill/>
+          </a:ln>
+          <a:effectLst/>
+        </p:spPr>
+        <p:style>
+          <a:lnRef idx="1">
+            <a:schemeClr val="accent1"/>
+          </a:lnRef>
+          <a:fillRef idx="3">
+            <a:schemeClr val="accent1"/>
+          </a:fillRef>
+          <a:effectRef idx="2">
+            <a:schemeClr val="accent1"/>
+          </a:effectRef>
+          <a:fontRef idx="minor">
+            <a:schemeClr val="lt1"/>
+          </a:fontRef>
+        </p:style>
+        <p:txBody>
+          <a:bodyPr rtlCol="0" anchor="ctr"/>
+          <a:lstStyle/>
+          <a:p>
+            <a:pPr algn="ctr"/>
+          </a:p>
+        </p:txBody>
+      </p:sp>
+      <p:sp>
+        <p:nvSpPr>
+          <p:cNvPr id="20" name="TextBox 19"/>
+          <p:cNvSpPr txBox="1"/>
+          <p:nvPr/>
+        </p:nvSpPr>
+        <p:spPr>
+          <a:xfrm>
+            <a:off x="932688" y="5550408"/>
+            <a:ext cx="10607040" cy="777240"/>
+          </a:xfrm>
+          <a:prstGeom prst="rect">
+            <a:avLst/>
+          </a:prstGeom>
+          <a:noFill/>
+        </p:spPr>
+        <p:txBody>
+          <a:bodyPr wrap="square" anchor="t" lIns="0" rIns="0" tIns="0" bIns="0">
+            <a:spAutoFit/>
+          </a:bodyPr>
+          <a:lstStyle/>
+          <a:p>
+            <a:pPr algn="l">
+              <a:lnSpc>
+                <a:spcPct val="108000"/>
+              </a:lnSpc>
+              <a:spcAft>
+                <a:spcPts val="200"/>
+              </a:spcAft>
+            </a:pPr>
+            <a:r>
+              <a:rPr sz="1350" b="1" i="0">
+                <a:solidFill>
+                  <a:srgbClr val="0A2A1A"/>
+                </a:solidFill>
+                <a:latin typeface="Calibri"/>
+              </a:rPr>
+              <a:t>Read the caveats before quoting  </a:t>
+            </a:r>
+            <a:r>
+              <a:rPr sz="1250" b="0" i="0">
+                <a:solidFill>
+                  <a:srgbClr val="6B7280"/>
+                </a:solidFill>
+                <a:latin typeface="Calibri"/>
+              </a:rPr>
+              <a:t>'Led' minutes include bench-heavy and garbage-time units, and 2025-26 is an injury-season shard (204 Tatum-led minutes). The 2024-25 comparison is the clean one — and it still favors the hierarchy.</a:t>
+            </a:r>
+          </a:p>
+        </p:txBody>
+      </p:sp>
+      <p:sp>
+        <p:nvSpPr>
+          <p:cNvPr id="21" name="TextBox 20"/>
           <p:cNvSpPr txBox="1"/>
           <p:nvPr/>
         </p:nvSpPr>
@@ -5469,7 +6149,7 @@
                 </a:solidFill>
                 <a:latin typeface="Calibri"/>
               </a:rPr>
-              <a:t>THE RETURN</a:t>
+              <a:t>THE CONTRACT</a:t>
             </a:r>
           </a:p>
         </p:txBody>
@@ -5511,59 +6191,35 @@
                 </a:solidFill>
                 <a:latin typeface="Cambria"/>
               </a:rPr>
-              <a:t>George is the cleaner stylistic fit — and the picks are the point</a:t>
-            </a:r>
-          </a:p>
-        </p:txBody>
-      </p:sp>
-      <p:sp>
-        <p:nvSpPr>
-          <p:cNvPr id="4" name="Rounded Rectangle 3"/>
-          <p:cNvSpPr/>
-          <p:nvPr/>
-        </p:nvSpPr>
-        <p:spPr>
-          <a:xfrm>
-            <a:off x="566928" y="1783080"/>
-            <a:ext cx="6583680" cy="3977639"/>
-          </a:xfrm>
-          <a:prstGeom prst="roundRect">
-            <a:avLst>
-              <a:gd name="adj" fmla="val 8000"/>
-            </a:avLst>
-          </a:prstGeom>
-          <a:solidFill>
-            <a:srgbClr val="FFFFFF"/>
-          </a:solidFill>
-          <a:ln w="12700">
-            <a:solidFill>
-              <a:srgbClr val="D7DAE0"/>
-            </a:solidFill>
-          </a:ln>
-          <a:effectLst/>
-        </p:spPr>
-        <p:style>
-          <a:lnRef idx="1">
-            <a:schemeClr val="accent1"/>
-          </a:lnRef>
-          <a:fillRef idx="3">
-            <a:schemeClr val="accent1"/>
-          </a:fillRef>
-          <a:effectRef idx="2">
-            <a:schemeClr val="accent1"/>
-          </a:effectRef>
-          <a:fontRef idx="minor">
-            <a:schemeClr val="lt1"/>
-          </a:fontRef>
-        </p:style>
-        <p:txBody>
-          <a:bodyPr rtlCol="0" anchor="ctr"/>
-          <a:lstStyle/>
-          <a:p>
-            <a:pPr algn="ctr"/>
-          </a:p>
-        </p:txBody>
-      </p:sp>
+              <a:t>Max-contract price, below-median-efficiency production</a:t>
+            </a:r>
+          </a:p>
+        </p:txBody>
+      </p:sp>
+      <p:pic>
+        <p:nvPicPr>
+          <p:cNvPr id="4" name="Picture 3" descr="efficiency_comps.png"/>
+          <p:cNvPicPr>
+            <a:picLocks noChangeAspect="1"/>
+          </p:cNvPicPr>
+          <p:nvPr/>
+        </p:nvPicPr>
+        <p:blipFill>
+          <a:blip r:embed="rId2"/>
+          <a:stretch>
+            <a:fillRect/>
+          </a:stretch>
+        </p:blipFill>
+        <p:spPr>
+          <a:xfrm>
+            <a:off x="1097280" y="1508760"/>
+            <a:ext cx="9966960" cy="4111782"/>
+          </a:xfrm>
+          <a:prstGeom prst="rect">
+            <a:avLst/>
+          </a:prstGeom>
+        </p:spPr>
+      </p:pic>
       <p:sp>
         <p:nvSpPr>
           <p:cNvPr id="5" name="TextBox 4"/>
@@ -5572,8 +6228,8 @@
         </p:nvSpPr>
         <p:spPr>
           <a:xfrm>
-            <a:off x="859536" y="1993392"/>
-            <a:ext cx="6035040" cy="365760"/>
+            <a:off x="566928" y="5806440"/>
+            <a:ext cx="11064240" cy="640080"/>
           </a:xfrm>
           <a:prstGeom prst="rect">
             <a:avLst/>
@@ -5588,20 +6244,29 @@
           <a:p>
             <a:pPr algn="l">
               <a:lnSpc>
-                <a:spcPct val="100000"/>
-              </a:lnSpc>
-              <a:spcAft>
-                <a:spcPts val="0"/>
-              </a:spcAft>
-            </a:pPr>
-            <a:r>
-              <a:rPr sz="1500" b="1" i="0">
-                <a:solidFill>
-                  <a:srgbClr val="0A2A1A"/>
-                </a:solidFill>
-                <a:latin typeface="Cambria"/>
-              </a:rPr>
-              <a:t>2025-26 shot profile</a:t>
+                <a:spcPct val="110000"/>
+              </a:lnSpc>
+              <a:spcAft>
+                <a:spcPts val="400"/>
+              </a:spcAft>
+            </a:pPr>
+            <a:r>
+              <a:rPr sz="1400" b="0" i="0">
+                <a:solidFill>
+                  <a:srgbClr val="20232A"/>
+                </a:solidFill>
+                <a:latin typeface="Calibri"/>
+              </a:rPr>
+              <a:t>6.9 WS on $53.1M = $7.7M per win share at 34% of the cap, with a 0.573 TS% — below the max-wing median. </a:t>
+            </a:r>
+            <a:r>
+              <a:rPr sz="1400" b="1" i="0">
+                <a:solidFill>
+                  <a:srgbClr val="007A33"/>
+                </a:solidFill>
+                <a:latin typeface="Calibri"/>
+              </a:rPr>
+              <a:t>Picks 15-30 buy the same wins at ~$2.1M/WS on rookie deals.</a:t>
             </a:r>
           </a:p>
         </p:txBody>
@@ -5609,995 +6274,6 @@
       <p:sp>
         <p:nvSpPr>
           <p:cNvPr id="6" name="TextBox 5"/>
-          <p:cNvSpPr txBox="1"/>
-          <p:nvPr/>
-        </p:nvSpPr>
-        <p:spPr>
-          <a:xfrm>
-            <a:off x="3566160" y="2395728"/>
-            <a:ext cx="1737360" cy="274320"/>
-          </a:xfrm>
-          <a:prstGeom prst="rect">
-            <a:avLst/>
-          </a:prstGeom>
-          <a:noFill/>
-        </p:spPr>
-        <p:txBody>
-          <a:bodyPr wrap="square" anchor="t" lIns="0" rIns="0" tIns="0" bIns="0">
-            <a:spAutoFit/>
-          </a:bodyPr>
-          <a:lstStyle/>
-          <a:p>
-            <a:pPr algn="l">
-              <a:lnSpc>
-                <a:spcPct val="100000"/>
-              </a:lnSpc>
-              <a:spcAft>
-                <a:spcPts val="0"/>
-              </a:spcAft>
-            </a:pPr>
-            <a:r>
-              <a:rPr sz="1150" b="1" i="0">
-                <a:solidFill>
-                  <a:srgbClr val="6B7280"/>
-                </a:solidFill>
-                <a:latin typeface="Calibri"/>
-              </a:rPr>
-              <a:t>BROWN</a:t>
-            </a:r>
-          </a:p>
-        </p:txBody>
-      </p:sp>
-      <p:sp>
-        <p:nvSpPr>
-          <p:cNvPr id="7" name="TextBox 6"/>
-          <p:cNvSpPr txBox="1"/>
-          <p:nvPr/>
-        </p:nvSpPr>
-        <p:spPr>
-          <a:xfrm>
-            <a:off x="5394960" y="2395728"/>
-            <a:ext cx="1737360" cy="274320"/>
-          </a:xfrm>
-          <a:prstGeom prst="rect">
-            <a:avLst/>
-          </a:prstGeom>
-          <a:noFill/>
-        </p:spPr>
-        <p:txBody>
-          <a:bodyPr wrap="square" anchor="t" lIns="0" rIns="0" tIns="0" bIns="0">
-            <a:spAutoFit/>
-          </a:bodyPr>
-          <a:lstStyle/>
-          <a:p>
-            <a:pPr algn="l">
-              <a:lnSpc>
-                <a:spcPct val="100000"/>
-              </a:lnSpc>
-              <a:spcAft>
-                <a:spcPts val="0"/>
-              </a:spcAft>
-            </a:pPr>
-            <a:r>
-              <a:rPr sz="1150" b="1" i="0">
-                <a:solidFill>
-                  <a:srgbClr val="007A33"/>
-                </a:solidFill>
-                <a:latin typeface="Calibri"/>
-              </a:rPr>
-              <a:t>GEORGE</a:t>
-            </a:r>
-          </a:p>
-        </p:txBody>
-      </p:sp>
-      <p:sp>
-        <p:nvSpPr>
-          <p:cNvPr id="8" name="TextBox 7"/>
-          <p:cNvSpPr txBox="1"/>
-          <p:nvPr/>
-        </p:nvSpPr>
-        <p:spPr>
-          <a:xfrm>
-            <a:off x="859536" y="2743200"/>
-            <a:ext cx="2651760" cy="320040"/>
-          </a:xfrm>
-          <a:prstGeom prst="rect">
-            <a:avLst/>
-          </a:prstGeom>
-          <a:noFill/>
-        </p:spPr>
-        <p:txBody>
-          <a:bodyPr wrap="square" anchor="t" lIns="0" rIns="0" tIns="0" bIns="0">
-            <a:spAutoFit/>
-          </a:bodyPr>
-          <a:lstStyle/>
-          <a:p>
-            <a:pPr algn="l">
-              <a:lnSpc>
-                <a:spcPct val="100000"/>
-              </a:lnSpc>
-              <a:spcAft>
-                <a:spcPts val="0"/>
-              </a:spcAft>
-            </a:pPr>
-            <a:r>
-              <a:rPr sz="1300" b="0" i="0">
-                <a:solidFill>
-                  <a:srgbClr val="20232A"/>
-                </a:solidFill>
-                <a:latin typeface="Calibri"/>
-              </a:rPr>
-              <a:t>3PT rate</a:t>
-            </a:r>
-          </a:p>
-        </p:txBody>
-      </p:sp>
-      <p:sp>
-        <p:nvSpPr>
-          <p:cNvPr id="9" name="TextBox 8"/>
-          <p:cNvSpPr txBox="1"/>
-          <p:nvPr/>
-        </p:nvSpPr>
-        <p:spPr>
-          <a:xfrm>
-            <a:off x="3566160" y="2743200"/>
-            <a:ext cx="1737360" cy="320040"/>
-          </a:xfrm>
-          <a:prstGeom prst="rect">
-            <a:avLst/>
-          </a:prstGeom>
-          <a:noFill/>
-        </p:spPr>
-        <p:txBody>
-          <a:bodyPr wrap="square" anchor="t" lIns="0" rIns="0" tIns="0" bIns="0">
-            <a:spAutoFit/>
-          </a:bodyPr>
-          <a:lstStyle/>
-          <a:p>
-            <a:pPr algn="l">
-              <a:lnSpc>
-                <a:spcPct val="100000"/>
-              </a:lnSpc>
-              <a:spcAft>
-                <a:spcPts val="0"/>
-              </a:spcAft>
-            </a:pPr>
-            <a:r>
-              <a:rPr sz="1350" b="1" i="0">
-                <a:solidFill>
-                  <a:srgbClr val="6B7280"/>
-                </a:solidFill>
-                <a:latin typeface="Calibri"/>
-              </a:rPr>
-              <a:t>0.262</a:t>
-            </a:r>
-          </a:p>
-        </p:txBody>
-      </p:sp>
-      <p:sp>
-        <p:nvSpPr>
-          <p:cNvPr id="10" name="TextBox 9"/>
-          <p:cNvSpPr txBox="1"/>
-          <p:nvPr/>
-        </p:nvSpPr>
-        <p:spPr>
-          <a:xfrm>
-            <a:off x="5394960" y="2743200"/>
-            <a:ext cx="1737360" cy="320040"/>
-          </a:xfrm>
-          <a:prstGeom prst="rect">
-            <a:avLst/>
-          </a:prstGeom>
-          <a:noFill/>
-        </p:spPr>
-        <p:txBody>
-          <a:bodyPr wrap="square" anchor="t" lIns="0" rIns="0" tIns="0" bIns="0">
-            <a:spAutoFit/>
-          </a:bodyPr>
-          <a:lstStyle/>
-          <a:p>
-            <a:pPr algn="l">
-              <a:lnSpc>
-                <a:spcPct val="100000"/>
-              </a:lnSpc>
-              <a:spcAft>
-                <a:spcPts val="0"/>
-              </a:spcAft>
-            </a:pPr>
-            <a:r>
-              <a:rPr sz="1350" b="1" i="0">
-                <a:solidFill>
-                  <a:srgbClr val="007A33"/>
-                </a:solidFill>
-                <a:latin typeface="Calibri"/>
-              </a:rPr>
-              <a:t>0.497</a:t>
-            </a:r>
-          </a:p>
-        </p:txBody>
-      </p:sp>
-      <p:sp>
-        <p:nvSpPr>
-          <p:cNvPr id="11" name="TextBox 10"/>
-          <p:cNvSpPr txBox="1"/>
-          <p:nvPr/>
-        </p:nvSpPr>
-        <p:spPr>
-          <a:xfrm>
-            <a:off x="859536" y="3291840"/>
-            <a:ext cx="2651760" cy="320040"/>
-          </a:xfrm>
-          <a:prstGeom prst="rect">
-            <a:avLst/>
-          </a:prstGeom>
-          <a:noFill/>
-        </p:spPr>
-        <p:txBody>
-          <a:bodyPr wrap="square" anchor="t" lIns="0" rIns="0" tIns="0" bIns="0">
-            <a:spAutoFit/>
-          </a:bodyPr>
-          <a:lstStyle/>
-          <a:p>
-            <a:pPr algn="l">
-              <a:lnSpc>
-                <a:spcPct val="100000"/>
-              </a:lnSpc>
-              <a:spcAft>
-                <a:spcPts val="0"/>
-              </a:spcAft>
-            </a:pPr>
-            <a:r>
-              <a:rPr sz="1300" b="0" i="0">
-                <a:solidFill>
-                  <a:srgbClr val="20232A"/>
-                </a:solidFill>
-                <a:latin typeface="Calibri"/>
-              </a:rPr>
-              <a:t>Catch-&amp;-shoot rate</a:t>
-            </a:r>
-          </a:p>
-        </p:txBody>
-      </p:sp>
-      <p:sp>
-        <p:nvSpPr>
-          <p:cNvPr id="12" name="TextBox 11"/>
-          <p:cNvSpPr txBox="1"/>
-          <p:nvPr/>
-        </p:nvSpPr>
-        <p:spPr>
-          <a:xfrm>
-            <a:off x="3566160" y="3291840"/>
-            <a:ext cx="1737360" cy="320040"/>
-          </a:xfrm>
-          <a:prstGeom prst="rect">
-            <a:avLst/>
-          </a:prstGeom>
-          <a:noFill/>
-        </p:spPr>
-        <p:txBody>
-          <a:bodyPr wrap="square" anchor="t" lIns="0" rIns="0" tIns="0" bIns="0">
-            <a:spAutoFit/>
-          </a:bodyPr>
-          <a:lstStyle/>
-          <a:p>
-            <a:pPr algn="l">
-              <a:lnSpc>
-                <a:spcPct val="100000"/>
-              </a:lnSpc>
-              <a:spcAft>
-                <a:spcPts val="0"/>
-              </a:spcAft>
-            </a:pPr>
-            <a:r>
-              <a:rPr sz="1350" b="1" i="0">
-                <a:solidFill>
-                  <a:srgbClr val="6B7280"/>
-                </a:solidFill>
-                <a:latin typeface="Calibri"/>
-              </a:rPr>
-              <a:t>0.163</a:t>
-            </a:r>
-          </a:p>
-        </p:txBody>
-      </p:sp>
-      <p:sp>
-        <p:nvSpPr>
-          <p:cNvPr id="13" name="TextBox 12"/>
-          <p:cNvSpPr txBox="1"/>
-          <p:nvPr/>
-        </p:nvSpPr>
-        <p:spPr>
-          <a:xfrm>
-            <a:off x="5394960" y="3291840"/>
-            <a:ext cx="1737360" cy="320040"/>
-          </a:xfrm>
-          <a:prstGeom prst="rect">
-            <a:avLst/>
-          </a:prstGeom>
-          <a:noFill/>
-        </p:spPr>
-        <p:txBody>
-          <a:bodyPr wrap="square" anchor="t" lIns="0" rIns="0" tIns="0" bIns="0">
-            <a:spAutoFit/>
-          </a:bodyPr>
-          <a:lstStyle/>
-          <a:p>
-            <a:pPr algn="l">
-              <a:lnSpc>
-                <a:spcPct val="100000"/>
-              </a:lnSpc>
-              <a:spcAft>
-                <a:spcPts val="0"/>
-              </a:spcAft>
-            </a:pPr>
-            <a:r>
-              <a:rPr sz="1350" b="1" i="0">
-                <a:solidFill>
-                  <a:srgbClr val="007A33"/>
-                </a:solidFill>
-                <a:latin typeface="Calibri"/>
-              </a:rPr>
-              <a:t>0.409</a:t>
-            </a:r>
-          </a:p>
-        </p:txBody>
-      </p:sp>
-      <p:sp>
-        <p:nvSpPr>
-          <p:cNvPr id="14" name="TextBox 13"/>
-          <p:cNvSpPr txBox="1"/>
-          <p:nvPr/>
-        </p:nvSpPr>
-        <p:spPr>
-          <a:xfrm>
-            <a:off x="859536" y="3840480"/>
-            <a:ext cx="2651760" cy="320040"/>
-          </a:xfrm>
-          <a:prstGeom prst="rect">
-            <a:avLst/>
-          </a:prstGeom>
-          <a:noFill/>
-        </p:spPr>
-        <p:txBody>
-          <a:bodyPr wrap="square" anchor="t" lIns="0" rIns="0" tIns="0" bIns="0">
-            <a:spAutoFit/>
-          </a:bodyPr>
-          <a:lstStyle/>
-          <a:p>
-            <a:pPr algn="l">
-              <a:lnSpc>
-                <a:spcPct val="100000"/>
-              </a:lnSpc>
-              <a:spcAft>
-                <a:spcPts val="0"/>
-              </a:spcAft>
-            </a:pPr>
-            <a:r>
-              <a:rPr sz="1300" b="0" i="0">
-                <a:solidFill>
-                  <a:srgbClr val="20232A"/>
-                </a:solidFill>
-                <a:latin typeface="Calibri"/>
-              </a:rPr>
-              <a:t>Iso / 3+ dribble rate</a:t>
-            </a:r>
-          </a:p>
-        </p:txBody>
-      </p:sp>
-      <p:sp>
-        <p:nvSpPr>
-          <p:cNvPr id="15" name="TextBox 14"/>
-          <p:cNvSpPr txBox="1"/>
-          <p:nvPr/>
-        </p:nvSpPr>
-        <p:spPr>
-          <a:xfrm>
-            <a:off x="3566160" y="3840480"/>
-            <a:ext cx="1737360" cy="320040"/>
-          </a:xfrm>
-          <a:prstGeom prst="rect">
-            <a:avLst/>
-          </a:prstGeom>
-          <a:noFill/>
-        </p:spPr>
-        <p:txBody>
-          <a:bodyPr wrap="square" anchor="t" lIns="0" rIns="0" tIns="0" bIns="0">
-            <a:spAutoFit/>
-          </a:bodyPr>
-          <a:lstStyle/>
-          <a:p>
-            <a:pPr algn="l">
-              <a:lnSpc>
-                <a:spcPct val="100000"/>
-              </a:lnSpc>
-              <a:spcAft>
-                <a:spcPts val="0"/>
-              </a:spcAft>
-            </a:pPr>
-            <a:r>
-              <a:rPr sz="1350" b="1" i="0">
-                <a:solidFill>
-                  <a:srgbClr val="6B7280"/>
-                </a:solidFill>
-                <a:latin typeface="Calibri"/>
-              </a:rPr>
-              <a:t>0.639</a:t>
-            </a:r>
-          </a:p>
-        </p:txBody>
-      </p:sp>
-      <p:sp>
-        <p:nvSpPr>
-          <p:cNvPr id="16" name="TextBox 15"/>
-          <p:cNvSpPr txBox="1"/>
-          <p:nvPr/>
-        </p:nvSpPr>
-        <p:spPr>
-          <a:xfrm>
-            <a:off x="5394960" y="3840480"/>
-            <a:ext cx="1737360" cy="320040"/>
-          </a:xfrm>
-          <a:prstGeom prst="rect">
-            <a:avLst/>
-          </a:prstGeom>
-          <a:noFill/>
-        </p:spPr>
-        <p:txBody>
-          <a:bodyPr wrap="square" anchor="t" lIns="0" rIns="0" tIns="0" bIns="0">
-            <a:spAutoFit/>
-          </a:bodyPr>
-          <a:lstStyle/>
-          <a:p>
-            <a:pPr algn="l">
-              <a:lnSpc>
-                <a:spcPct val="100000"/>
-              </a:lnSpc>
-              <a:spcAft>
-                <a:spcPts val="0"/>
-              </a:spcAft>
-            </a:pPr>
-            <a:r>
-              <a:rPr sz="1350" b="1" i="0">
-                <a:solidFill>
-                  <a:srgbClr val="007A33"/>
-                </a:solidFill>
-                <a:latin typeface="Calibri"/>
-              </a:rPr>
-              <a:t>0.404</a:t>
-            </a:r>
-          </a:p>
-        </p:txBody>
-      </p:sp>
-      <p:sp>
-        <p:nvSpPr>
-          <p:cNvPr id="17" name="TextBox 16"/>
-          <p:cNvSpPr txBox="1"/>
-          <p:nvPr/>
-        </p:nvSpPr>
-        <p:spPr>
-          <a:xfrm>
-            <a:off x="859536" y="4389120"/>
-            <a:ext cx="2651760" cy="320040"/>
-          </a:xfrm>
-          <a:prstGeom prst="rect">
-            <a:avLst/>
-          </a:prstGeom>
-          <a:noFill/>
-        </p:spPr>
-        <p:txBody>
-          <a:bodyPr wrap="square" anchor="t" lIns="0" rIns="0" tIns="0" bIns="0">
-            <a:spAutoFit/>
-          </a:bodyPr>
-          <a:lstStyle/>
-          <a:p>
-            <a:pPr algn="l">
-              <a:lnSpc>
-                <a:spcPct val="100000"/>
-              </a:lnSpc>
-              <a:spcAft>
-                <a:spcPts val="0"/>
-              </a:spcAft>
-            </a:pPr>
-            <a:r>
-              <a:rPr sz="1300" b="0" i="0">
-                <a:solidFill>
-                  <a:srgbClr val="20232A"/>
-                </a:solidFill>
-                <a:latin typeface="Calibri"/>
-              </a:rPr>
-              <a:t>Contested-shot rate</a:t>
-            </a:r>
-          </a:p>
-        </p:txBody>
-      </p:sp>
-      <p:sp>
-        <p:nvSpPr>
-          <p:cNvPr id="18" name="TextBox 17"/>
-          <p:cNvSpPr txBox="1"/>
-          <p:nvPr/>
-        </p:nvSpPr>
-        <p:spPr>
-          <a:xfrm>
-            <a:off x="3566160" y="4389120"/>
-            <a:ext cx="1737360" cy="320040"/>
-          </a:xfrm>
-          <a:prstGeom prst="rect">
-            <a:avLst/>
-          </a:prstGeom>
-          <a:noFill/>
-        </p:spPr>
-        <p:txBody>
-          <a:bodyPr wrap="square" anchor="t" lIns="0" rIns="0" tIns="0" bIns="0">
-            <a:spAutoFit/>
-          </a:bodyPr>
-          <a:lstStyle/>
-          <a:p>
-            <a:pPr algn="l">
-              <a:lnSpc>
-                <a:spcPct val="100000"/>
-              </a:lnSpc>
-              <a:spcAft>
-                <a:spcPts val="0"/>
-              </a:spcAft>
-            </a:pPr>
-            <a:r>
-              <a:rPr sz="1350" b="1" i="0">
-                <a:solidFill>
-                  <a:srgbClr val="6B7280"/>
-                </a:solidFill>
-                <a:latin typeface="Calibri"/>
-              </a:rPr>
-              <a:t>0.517</a:t>
-            </a:r>
-          </a:p>
-        </p:txBody>
-      </p:sp>
-      <p:sp>
-        <p:nvSpPr>
-          <p:cNvPr id="19" name="TextBox 18"/>
-          <p:cNvSpPr txBox="1"/>
-          <p:nvPr/>
-        </p:nvSpPr>
-        <p:spPr>
-          <a:xfrm>
-            <a:off x="5394960" y="4389120"/>
-            <a:ext cx="1737360" cy="320040"/>
-          </a:xfrm>
-          <a:prstGeom prst="rect">
-            <a:avLst/>
-          </a:prstGeom>
-          <a:noFill/>
-        </p:spPr>
-        <p:txBody>
-          <a:bodyPr wrap="square" anchor="t" lIns="0" rIns="0" tIns="0" bIns="0">
-            <a:spAutoFit/>
-          </a:bodyPr>
-          <a:lstStyle/>
-          <a:p>
-            <a:pPr algn="l">
-              <a:lnSpc>
-                <a:spcPct val="100000"/>
-              </a:lnSpc>
-              <a:spcAft>
-                <a:spcPts val="0"/>
-              </a:spcAft>
-            </a:pPr>
-            <a:r>
-              <a:rPr sz="1350" b="1" i="0">
-                <a:solidFill>
-                  <a:srgbClr val="007A33"/>
-                </a:solidFill>
-                <a:latin typeface="Calibri"/>
-              </a:rPr>
-              <a:t>0.370</a:t>
-            </a:r>
-          </a:p>
-        </p:txBody>
-      </p:sp>
-      <p:sp>
-        <p:nvSpPr>
-          <p:cNvPr id="20" name="TextBox 19"/>
-          <p:cNvSpPr txBox="1"/>
-          <p:nvPr/>
-        </p:nvSpPr>
-        <p:spPr>
-          <a:xfrm>
-            <a:off x="859536" y="4937759"/>
-            <a:ext cx="2651760" cy="320040"/>
-          </a:xfrm>
-          <a:prstGeom prst="rect">
-            <a:avLst/>
-          </a:prstGeom>
-          <a:noFill/>
-        </p:spPr>
-        <p:txBody>
-          <a:bodyPr wrap="square" anchor="t" lIns="0" rIns="0" tIns="0" bIns="0">
-            <a:spAutoFit/>
-          </a:bodyPr>
-          <a:lstStyle/>
-          <a:p>
-            <a:pPr algn="l">
-              <a:lnSpc>
-                <a:spcPct val="100000"/>
-              </a:lnSpc>
-              <a:spcAft>
-                <a:spcPts val="0"/>
-              </a:spcAft>
-            </a:pPr>
-            <a:r>
-              <a:rPr sz="1300" b="0" i="0">
-                <a:solidFill>
-                  <a:srgbClr val="20232A"/>
-                </a:solidFill>
-                <a:latin typeface="Calibri"/>
-              </a:rPr>
-              <a:t>Bad-shot index</a:t>
-            </a:r>
-          </a:p>
-        </p:txBody>
-      </p:sp>
-      <p:sp>
-        <p:nvSpPr>
-          <p:cNvPr id="21" name="TextBox 20"/>
-          <p:cNvSpPr txBox="1"/>
-          <p:nvPr/>
-        </p:nvSpPr>
-        <p:spPr>
-          <a:xfrm>
-            <a:off x="3566160" y="4937759"/>
-            <a:ext cx="1737360" cy="320040"/>
-          </a:xfrm>
-          <a:prstGeom prst="rect">
-            <a:avLst/>
-          </a:prstGeom>
-          <a:noFill/>
-        </p:spPr>
-        <p:txBody>
-          <a:bodyPr wrap="square" anchor="t" lIns="0" rIns="0" tIns="0" bIns="0">
-            <a:spAutoFit/>
-          </a:bodyPr>
-          <a:lstStyle/>
-          <a:p>
-            <a:pPr algn="l">
-              <a:lnSpc>
-                <a:spcPct val="100000"/>
-              </a:lnSpc>
-              <a:spcAft>
-                <a:spcPts val="0"/>
-              </a:spcAft>
-            </a:pPr>
-            <a:r>
-              <a:rPr sz="1350" b="1" i="0">
-                <a:solidFill>
-                  <a:srgbClr val="6B7280"/>
-                </a:solidFill>
-                <a:latin typeface="Calibri"/>
-              </a:rPr>
-              <a:t>0.379</a:t>
-            </a:r>
-          </a:p>
-        </p:txBody>
-      </p:sp>
-      <p:sp>
-        <p:nvSpPr>
-          <p:cNvPr id="22" name="TextBox 21"/>
-          <p:cNvSpPr txBox="1"/>
-          <p:nvPr/>
-        </p:nvSpPr>
-        <p:spPr>
-          <a:xfrm>
-            <a:off x="5394960" y="4937759"/>
-            <a:ext cx="1737360" cy="320040"/>
-          </a:xfrm>
-          <a:prstGeom prst="rect">
-            <a:avLst/>
-          </a:prstGeom>
-          <a:noFill/>
-        </p:spPr>
-        <p:txBody>
-          <a:bodyPr wrap="square" anchor="t" lIns="0" rIns="0" tIns="0" bIns="0">
-            <a:spAutoFit/>
-          </a:bodyPr>
-          <a:lstStyle/>
-          <a:p>
-            <a:pPr algn="l">
-              <a:lnSpc>
-                <a:spcPct val="100000"/>
-              </a:lnSpc>
-              <a:spcAft>
-                <a:spcPts val="0"/>
-              </a:spcAft>
-            </a:pPr>
-            <a:r>
-              <a:rPr sz="1350" b="1" i="0">
-                <a:solidFill>
-                  <a:srgbClr val="007A33"/>
-                </a:solidFill>
-                <a:latin typeface="Calibri"/>
-              </a:rPr>
-              <a:t>0.273</a:t>
-            </a:r>
-          </a:p>
-        </p:txBody>
-      </p:sp>
-      <p:sp>
-        <p:nvSpPr>
-          <p:cNvPr id="23" name="TextBox 22"/>
-          <p:cNvSpPr txBox="1"/>
-          <p:nvPr/>
-        </p:nvSpPr>
-        <p:spPr>
-          <a:xfrm>
-            <a:off x="859536" y="5138928"/>
-            <a:ext cx="6035040" cy="457200"/>
-          </a:xfrm>
-          <a:prstGeom prst="rect">
-            <a:avLst/>
-          </a:prstGeom>
-          <a:noFill/>
-        </p:spPr>
-        <p:txBody>
-          <a:bodyPr wrap="square" anchor="t" lIns="0" rIns="0" tIns="0" bIns="0">
-            <a:spAutoFit/>
-          </a:bodyPr>
-          <a:lstStyle/>
-          <a:p>
-            <a:pPr algn="l">
-              <a:lnSpc>
-                <a:spcPct val="105000"/>
-              </a:lnSpc>
-              <a:spcAft>
-                <a:spcPts val="400"/>
-              </a:spcAft>
-            </a:pPr>
-            <a:r>
-              <a:rPr sz="1150" b="0" i="1">
-                <a:solidFill>
-                  <a:srgbClr val="6B7280"/>
-                </a:solidFill>
-                <a:latin typeface="Calibri"/>
-              </a:rPr>
-              <a:t>George takes the shots the system is built to generate — he plugs in instead of stopping it.</a:t>
-            </a:r>
-          </a:p>
-        </p:txBody>
-      </p:sp>
-      <p:sp>
-        <p:nvSpPr>
-          <p:cNvPr id="24" name="Rounded Rectangle 23"/>
-          <p:cNvSpPr/>
-          <p:nvPr/>
-        </p:nvSpPr>
-        <p:spPr>
-          <a:xfrm>
-            <a:off x="7452360" y="1783080"/>
-            <a:ext cx="4160520" cy="3977639"/>
-          </a:xfrm>
-          <a:prstGeom prst="roundRect">
-            <a:avLst>
-              <a:gd name="adj" fmla="val 8000"/>
-            </a:avLst>
-          </a:prstGeom>
-          <a:solidFill>
-            <a:srgbClr val="0A2A1A"/>
-          </a:solidFill>
-          <a:ln>
-            <a:noFill/>
-          </a:ln>
-          <a:effectLst/>
-        </p:spPr>
-        <p:style>
-          <a:lnRef idx="1">
-            <a:schemeClr val="accent1"/>
-          </a:lnRef>
-          <a:fillRef idx="3">
-            <a:schemeClr val="accent1"/>
-          </a:fillRef>
-          <a:effectRef idx="2">
-            <a:schemeClr val="accent1"/>
-          </a:effectRef>
-          <a:fontRef idx="minor">
-            <a:schemeClr val="lt1"/>
-          </a:fontRef>
-        </p:style>
-        <p:txBody>
-          <a:bodyPr rtlCol="0" anchor="ctr"/>
-          <a:lstStyle/>
-          <a:p>
-            <a:pPr algn="ctr"/>
-          </a:p>
-        </p:txBody>
-      </p:sp>
-      <p:sp>
-        <p:nvSpPr>
-          <p:cNvPr id="25" name="TextBox 24"/>
-          <p:cNvSpPr txBox="1"/>
-          <p:nvPr/>
-        </p:nvSpPr>
-        <p:spPr>
-          <a:xfrm>
-            <a:off x="7726679" y="2011680"/>
-            <a:ext cx="3657600" cy="365760"/>
-          </a:xfrm>
-          <a:prstGeom prst="rect">
-            <a:avLst/>
-          </a:prstGeom>
-          <a:noFill/>
-        </p:spPr>
-        <p:txBody>
-          <a:bodyPr wrap="square" anchor="t" lIns="0" rIns="0" tIns="0" bIns="0">
-            <a:spAutoFit/>
-          </a:bodyPr>
-          <a:lstStyle/>
-          <a:p>
-            <a:pPr algn="l">
-              <a:lnSpc>
-                <a:spcPct val="100000"/>
-              </a:lnSpc>
-              <a:spcAft>
-                <a:spcPts val="0"/>
-              </a:spcAft>
-            </a:pPr>
-            <a:r>
-              <a:rPr sz="1250" b="1" i="0">
-                <a:solidFill>
-                  <a:srgbClr val="BCD3C6"/>
-                </a:solidFill>
-                <a:latin typeface="Calibri"/>
-              </a:rPr>
-              <a:t>PLUS THE PICKS</a:t>
-            </a:r>
-          </a:p>
-        </p:txBody>
-      </p:sp>
-      <p:sp>
-        <p:nvSpPr>
-          <p:cNvPr id="26" name="TextBox 25"/>
-          <p:cNvSpPr txBox="1"/>
-          <p:nvPr/>
-        </p:nvSpPr>
-        <p:spPr>
-          <a:xfrm>
-            <a:off x="7726679" y="2468880"/>
-            <a:ext cx="3657600" cy="914400"/>
-          </a:xfrm>
-          <a:prstGeom prst="rect">
-            <a:avLst/>
-          </a:prstGeom>
-          <a:noFill/>
-        </p:spPr>
-        <p:txBody>
-          <a:bodyPr wrap="square" anchor="t" lIns="0" rIns="0" tIns="0" bIns="0">
-            <a:spAutoFit/>
-          </a:bodyPr>
-          <a:lstStyle/>
-          <a:p>
-            <a:pPr algn="l">
-              <a:lnSpc>
-                <a:spcPct val="105000"/>
-              </a:lnSpc>
-              <a:spcAft>
-                <a:spcPts val="200"/>
-              </a:spcAft>
-            </a:pPr>
-            <a:r>
-              <a:rPr sz="2000" b="1" i="0">
-                <a:solidFill>
-                  <a:srgbClr val="FFFFFF"/>
-                </a:solidFill>
-                <a:latin typeface="Cambria"/>
-              </a:rPr>
-              <a:t>2028 first + 2031</a:t>
-            </a:r>
-          </a:p>
-          <a:p>
-            <a:pPr algn="l">
-              <a:lnSpc>
-                <a:spcPct val="105000"/>
-              </a:lnSpc>
-              <a:spcAft>
-                <a:spcPts val="200"/>
-              </a:spcAft>
-            </a:pPr>
-            <a:r>
-              <a:rPr sz="2000" b="1" i="0">
-                <a:solidFill>
-                  <a:srgbClr val="FFFFFF"/>
-                </a:solidFill>
-                <a:latin typeface="Cambria"/>
-              </a:rPr>
-              <a:t>unprotected first</a:t>
-            </a:r>
-          </a:p>
-        </p:txBody>
-      </p:sp>
-      <p:sp>
-        <p:nvSpPr>
-          <p:cNvPr id="27" name="TextBox 26"/>
-          <p:cNvSpPr txBox="1"/>
-          <p:nvPr/>
-        </p:nvSpPr>
-        <p:spPr>
-          <a:xfrm>
-            <a:off x="7726679" y="3520440"/>
-            <a:ext cx="3657600" cy="1463040"/>
-          </a:xfrm>
-          <a:prstGeom prst="rect">
-            <a:avLst/>
-          </a:prstGeom>
-          <a:noFill/>
-        </p:spPr>
-        <p:txBody>
-          <a:bodyPr wrap="square" anchor="t" lIns="0" rIns="0" tIns="0" bIns="0">
-            <a:spAutoFit/>
-          </a:bodyPr>
-          <a:lstStyle/>
-          <a:p>
-            <a:pPr algn="l">
-              <a:lnSpc>
-                <a:spcPct val="115000"/>
-              </a:lnSpc>
-              <a:spcAft>
-                <a:spcPts val="400"/>
-              </a:spcAft>
-            </a:pPr>
-            <a:r>
-              <a:rPr sz="1250" b="0" i="0">
-                <a:solidFill>
-                  <a:srgbClr val="CFE0D6"/>
-                </a:solidFill>
-                <a:latin typeface="Calibri"/>
-              </a:rPr>
-              <a:t>Under the post-2019 flattened lottery — exact odds enumerated across all 24,024 seed permutations — late-lottery firsts convey materially more top-4 equity than the old system.</a:t>
-            </a:r>
-          </a:p>
-        </p:txBody>
-      </p:sp>
-      <p:sp>
-        <p:nvSpPr>
-          <p:cNvPr id="28" name="TextBox 27"/>
-          <p:cNvSpPr txBox="1"/>
-          <p:nvPr/>
-        </p:nvSpPr>
-        <p:spPr>
-          <a:xfrm>
-            <a:off x="7726679" y="5074920"/>
-            <a:ext cx="3657600" cy="548640"/>
-          </a:xfrm>
-          <a:prstGeom prst="rect">
-            <a:avLst/>
-          </a:prstGeom>
-          <a:noFill/>
-        </p:spPr>
-        <p:txBody>
-          <a:bodyPr wrap="square" anchor="t" lIns="0" rIns="0" tIns="0" bIns="0">
-            <a:spAutoFit/>
-          </a:bodyPr>
-          <a:lstStyle/>
-          <a:p>
-            <a:pPr algn="l">
-              <a:lnSpc>
-                <a:spcPct val="108000"/>
-              </a:lnSpc>
-              <a:spcAft>
-                <a:spcPts val="400"/>
-              </a:spcAft>
-            </a:pPr>
-            <a:r>
-              <a:rPr sz="1150" b="0" i="1">
-                <a:solidFill>
-                  <a:srgbClr val="9AB2A4"/>
-                </a:solidFill>
-                <a:latin typeface="Calibri"/>
-              </a:rPr>
-              <a:t>Cheap, controllable, tradeable — the assets a capped-out roster can't otherwise get.</a:t>
-            </a:r>
-          </a:p>
-        </p:txBody>
-      </p:sp>
-      <p:sp>
-        <p:nvSpPr>
-          <p:cNvPr id="29" name="TextBox 28"/>
           <p:cNvSpPr txBox="1"/>
           <p:nvPr/>
         </p:nvSpPr>
@@ -6709,7 +6385,7 @@
                 </a:solidFill>
                 <a:latin typeface="Calibri"/>
               </a:rPr>
-              <a:t>WHERE THE CASE IS WEAKEST</a:t>
+              <a:t>THE RETURN</a:t>
             </a:r>
           </a:p>
         </p:txBody>
@@ -6751,7 +6427,7 @@
                 </a:solidFill>
                 <a:latin typeface="Cambria"/>
               </a:rPr>
-              <a:t>The counter-evidence, on the record</a:t>
+              <a:t>George is the cleaner stylistic fit — and the picks are the point</a:t>
             </a:r>
           </a:p>
         </p:txBody>
@@ -6764,8 +6440,8 @@
         </p:nvSpPr>
         <p:spPr>
           <a:xfrm>
-            <a:off x="566928" y="1874519"/>
-            <a:ext cx="3502152" cy="3017520"/>
+            <a:off x="566928" y="1783080"/>
+            <a:ext cx="6583680" cy="3977639"/>
           </a:xfrm>
           <a:prstGeom prst="roundRect">
             <a:avLst>
@@ -6806,20 +6482,820 @@
       </p:sp>
       <p:sp>
         <p:nvSpPr>
-          <p:cNvPr id="5" name="Oval 4"/>
+          <p:cNvPr id="5" name="TextBox 4"/>
+          <p:cNvSpPr txBox="1"/>
+          <p:nvPr/>
+        </p:nvSpPr>
+        <p:spPr>
+          <a:xfrm>
+            <a:off x="859536" y="1993392"/>
+            <a:ext cx="6035040" cy="365760"/>
+          </a:xfrm>
+          <a:prstGeom prst="rect">
+            <a:avLst/>
+          </a:prstGeom>
+          <a:noFill/>
+        </p:spPr>
+        <p:txBody>
+          <a:bodyPr wrap="square" anchor="t" lIns="0" rIns="0" tIns="0" bIns="0">
+            <a:spAutoFit/>
+          </a:bodyPr>
+          <a:lstStyle/>
+          <a:p>
+            <a:pPr algn="l">
+              <a:lnSpc>
+                <a:spcPct val="100000"/>
+              </a:lnSpc>
+              <a:spcAft>
+                <a:spcPts val="0"/>
+              </a:spcAft>
+            </a:pPr>
+            <a:r>
+              <a:rPr sz="1500" b="1" i="0">
+                <a:solidFill>
+                  <a:srgbClr val="0A2A1A"/>
+                </a:solidFill>
+                <a:latin typeface="Cambria"/>
+              </a:rPr>
+              <a:t>2025-26 shot profile</a:t>
+            </a:r>
+          </a:p>
+        </p:txBody>
+      </p:sp>
+      <p:sp>
+        <p:nvSpPr>
+          <p:cNvPr id="6" name="TextBox 5"/>
+          <p:cNvSpPr txBox="1"/>
+          <p:nvPr/>
+        </p:nvSpPr>
+        <p:spPr>
+          <a:xfrm>
+            <a:off x="3566160" y="2395728"/>
+            <a:ext cx="1737360" cy="274320"/>
+          </a:xfrm>
+          <a:prstGeom prst="rect">
+            <a:avLst/>
+          </a:prstGeom>
+          <a:noFill/>
+        </p:spPr>
+        <p:txBody>
+          <a:bodyPr wrap="square" anchor="t" lIns="0" rIns="0" tIns="0" bIns="0">
+            <a:spAutoFit/>
+          </a:bodyPr>
+          <a:lstStyle/>
+          <a:p>
+            <a:pPr algn="l">
+              <a:lnSpc>
+                <a:spcPct val="100000"/>
+              </a:lnSpc>
+              <a:spcAft>
+                <a:spcPts val="0"/>
+              </a:spcAft>
+            </a:pPr>
+            <a:r>
+              <a:rPr sz="1150" b="1" i="0">
+                <a:solidFill>
+                  <a:srgbClr val="6B7280"/>
+                </a:solidFill>
+                <a:latin typeface="Calibri"/>
+              </a:rPr>
+              <a:t>BROWN</a:t>
+            </a:r>
+          </a:p>
+        </p:txBody>
+      </p:sp>
+      <p:sp>
+        <p:nvSpPr>
+          <p:cNvPr id="7" name="TextBox 6"/>
+          <p:cNvSpPr txBox="1"/>
+          <p:nvPr/>
+        </p:nvSpPr>
+        <p:spPr>
+          <a:xfrm>
+            <a:off x="5394960" y="2395728"/>
+            <a:ext cx="1737360" cy="274320"/>
+          </a:xfrm>
+          <a:prstGeom prst="rect">
+            <a:avLst/>
+          </a:prstGeom>
+          <a:noFill/>
+        </p:spPr>
+        <p:txBody>
+          <a:bodyPr wrap="square" anchor="t" lIns="0" rIns="0" tIns="0" bIns="0">
+            <a:spAutoFit/>
+          </a:bodyPr>
+          <a:lstStyle/>
+          <a:p>
+            <a:pPr algn="l">
+              <a:lnSpc>
+                <a:spcPct val="100000"/>
+              </a:lnSpc>
+              <a:spcAft>
+                <a:spcPts val="0"/>
+              </a:spcAft>
+            </a:pPr>
+            <a:r>
+              <a:rPr sz="1150" b="1" i="0">
+                <a:solidFill>
+                  <a:srgbClr val="007A33"/>
+                </a:solidFill>
+                <a:latin typeface="Calibri"/>
+              </a:rPr>
+              <a:t>GEORGE</a:t>
+            </a:r>
+          </a:p>
+        </p:txBody>
+      </p:sp>
+      <p:sp>
+        <p:nvSpPr>
+          <p:cNvPr id="8" name="TextBox 7"/>
+          <p:cNvSpPr txBox="1"/>
+          <p:nvPr/>
+        </p:nvSpPr>
+        <p:spPr>
+          <a:xfrm>
+            <a:off x="859536" y="2743200"/>
+            <a:ext cx="2651760" cy="320040"/>
+          </a:xfrm>
+          <a:prstGeom prst="rect">
+            <a:avLst/>
+          </a:prstGeom>
+          <a:noFill/>
+        </p:spPr>
+        <p:txBody>
+          <a:bodyPr wrap="square" anchor="t" lIns="0" rIns="0" tIns="0" bIns="0">
+            <a:spAutoFit/>
+          </a:bodyPr>
+          <a:lstStyle/>
+          <a:p>
+            <a:pPr algn="l">
+              <a:lnSpc>
+                <a:spcPct val="100000"/>
+              </a:lnSpc>
+              <a:spcAft>
+                <a:spcPts val="0"/>
+              </a:spcAft>
+            </a:pPr>
+            <a:r>
+              <a:rPr sz="1300" b="0" i="0">
+                <a:solidFill>
+                  <a:srgbClr val="20232A"/>
+                </a:solidFill>
+                <a:latin typeface="Calibri"/>
+              </a:rPr>
+              <a:t>3PT rate</a:t>
+            </a:r>
+          </a:p>
+        </p:txBody>
+      </p:sp>
+      <p:sp>
+        <p:nvSpPr>
+          <p:cNvPr id="9" name="TextBox 8"/>
+          <p:cNvSpPr txBox="1"/>
+          <p:nvPr/>
+        </p:nvSpPr>
+        <p:spPr>
+          <a:xfrm>
+            <a:off x="3566160" y="2743200"/>
+            <a:ext cx="1737360" cy="320040"/>
+          </a:xfrm>
+          <a:prstGeom prst="rect">
+            <a:avLst/>
+          </a:prstGeom>
+          <a:noFill/>
+        </p:spPr>
+        <p:txBody>
+          <a:bodyPr wrap="square" anchor="t" lIns="0" rIns="0" tIns="0" bIns="0">
+            <a:spAutoFit/>
+          </a:bodyPr>
+          <a:lstStyle/>
+          <a:p>
+            <a:pPr algn="l">
+              <a:lnSpc>
+                <a:spcPct val="100000"/>
+              </a:lnSpc>
+              <a:spcAft>
+                <a:spcPts val="0"/>
+              </a:spcAft>
+            </a:pPr>
+            <a:r>
+              <a:rPr sz="1350" b="1" i="0">
+                <a:solidFill>
+                  <a:srgbClr val="6B7280"/>
+                </a:solidFill>
+                <a:latin typeface="Calibri"/>
+              </a:rPr>
+              <a:t>0.262</a:t>
+            </a:r>
+          </a:p>
+        </p:txBody>
+      </p:sp>
+      <p:sp>
+        <p:nvSpPr>
+          <p:cNvPr id="10" name="TextBox 9"/>
+          <p:cNvSpPr txBox="1"/>
+          <p:nvPr/>
+        </p:nvSpPr>
+        <p:spPr>
+          <a:xfrm>
+            <a:off x="5394960" y="2743200"/>
+            <a:ext cx="1737360" cy="320040"/>
+          </a:xfrm>
+          <a:prstGeom prst="rect">
+            <a:avLst/>
+          </a:prstGeom>
+          <a:noFill/>
+        </p:spPr>
+        <p:txBody>
+          <a:bodyPr wrap="square" anchor="t" lIns="0" rIns="0" tIns="0" bIns="0">
+            <a:spAutoFit/>
+          </a:bodyPr>
+          <a:lstStyle/>
+          <a:p>
+            <a:pPr algn="l">
+              <a:lnSpc>
+                <a:spcPct val="100000"/>
+              </a:lnSpc>
+              <a:spcAft>
+                <a:spcPts val="0"/>
+              </a:spcAft>
+            </a:pPr>
+            <a:r>
+              <a:rPr sz="1350" b="1" i="0">
+                <a:solidFill>
+                  <a:srgbClr val="007A33"/>
+                </a:solidFill>
+                <a:latin typeface="Calibri"/>
+              </a:rPr>
+              <a:t>0.497</a:t>
+            </a:r>
+          </a:p>
+        </p:txBody>
+      </p:sp>
+      <p:sp>
+        <p:nvSpPr>
+          <p:cNvPr id="11" name="TextBox 10"/>
+          <p:cNvSpPr txBox="1"/>
+          <p:nvPr/>
+        </p:nvSpPr>
+        <p:spPr>
+          <a:xfrm>
+            <a:off x="859536" y="3291840"/>
+            <a:ext cx="2651760" cy="320040"/>
+          </a:xfrm>
+          <a:prstGeom prst="rect">
+            <a:avLst/>
+          </a:prstGeom>
+          <a:noFill/>
+        </p:spPr>
+        <p:txBody>
+          <a:bodyPr wrap="square" anchor="t" lIns="0" rIns="0" tIns="0" bIns="0">
+            <a:spAutoFit/>
+          </a:bodyPr>
+          <a:lstStyle/>
+          <a:p>
+            <a:pPr algn="l">
+              <a:lnSpc>
+                <a:spcPct val="100000"/>
+              </a:lnSpc>
+              <a:spcAft>
+                <a:spcPts val="0"/>
+              </a:spcAft>
+            </a:pPr>
+            <a:r>
+              <a:rPr sz="1300" b="0" i="0">
+                <a:solidFill>
+                  <a:srgbClr val="20232A"/>
+                </a:solidFill>
+                <a:latin typeface="Calibri"/>
+              </a:rPr>
+              <a:t>Catch-&amp;-shoot rate</a:t>
+            </a:r>
+          </a:p>
+        </p:txBody>
+      </p:sp>
+      <p:sp>
+        <p:nvSpPr>
+          <p:cNvPr id="12" name="TextBox 11"/>
+          <p:cNvSpPr txBox="1"/>
+          <p:nvPr/>
+        </p:nvSpPr>
+        <p:spPr>
+          <a:xfrm>
+            <a:off x="3566160" y="3291840"/>
+            <a:ext cx="1737360" cy="320040"/>
+          </a:xfrm>
+          <a:prstGeom prst="rect">
+            <a:avLst/>
+          </a:prstGeom>
+          <a:noFill/>
+        </p:spPr>
+        <p:txBody>
+          <a:bodyPr wrap="square" anchor="t" lIns="0" rIns="0" tIns="0" bIns="0">
+            <a:spAutoFit/>
+          </a:bodyPr>
+          <a:lstStyle/>
+          <a:p>
+            <a:pPr algn="l">
+              <a:lnSpc>
+                <a:spcPct val="100000"/>
+              </a:lnSpc>
+              <a:spcAft>
+                <a:spcPts val="0"/>
+              </a:spcAft>
+            </a:pPr>
+            <a:r>
+              <a:rPr sz="1350" b="1" i="0">
+                <a:solidFill>
+                  <a:srgbClr val="6B7280"/>
+                </a:solidFill>
+                <a:latin typeface="Calibri"/>
+              </a:rPr>
+              <a:t>0.163</a:t>
+            </a:r>
+          </a:p>
+        </p:txBody>
+      </p:sp>
+      <p:sp>
+        <p:nvSpPr>
+          <p:cNvPr id="13" name="TextBox 12"/>
+          <p:cNvSpPr txBox="1"/>
+          <p:nvPr/>
+        </p:nvSpPr>
+        <p:spPr>
+          <a:xfrm>
+            <a:off x="5394960" y="3291840"/>
+            <a:ext cx="1737360" cy="320040"/>
+          </a:xfrm>
+          <a:prstGeom prst="rect">
+            <a:avLst/>
+          </a:prstGeom>
+          <a:noFill/>
+        </p:spPr>
+        <p:txBody>
+          <a:bodyPr wrap="square" anchor="t" lIns="0" rIns="0" tIns="0" bIns="0">
+            <a:spAutoFit/>
+          </a:bodyPr>
+          <a:lstStyle/>
+          <a:p>
+            <a:pPr algn="l">
+              <a:lnSpc>
+                <a:spcPct val="100000"/>
+              </a:lnSpc>
+              <a:spcAft>
+                <a:spcPts val="0"/>
+              </a:spcAft>
+            </a:pPr>
+            <a:r>
+              <a:rPr sz="1350" b="1" i="0">
+                <a:solidFill>
+                  <a:srgbClr val="007A33"/>
+                </a:solidFill>
+                <a:latin typeface="Calibri"/>
+              </a:rPr>
+              <a:t>0.409</a:t>
+            </a:r>
+          </a:p>
+        </p:txBody>
+      </p:sp>
+      <p:sp>
+        <p:nvSpPr>
+          <p:cNvPr id="14" name="TextBox 13"/>
+          <p:cNvSpPr txBox="1"/>
+          <p:nvPr/>
+        </p:nvSpPr>
+        <p:spPr>
+          <a:xfrm>
+            <a:off x="859536" y="3840480"/>
+            <a:ext cx="2651760" cy="320040"/>
+          </a:xfrm>
+          <a:prstGeom prst="rect">
+            <a:avLst/>
+          </a:prstGeom>
+          <a:noFill/>
+        </p:spPr>
+        <p:txBody>
+          <a:bodyPr wrap="square" anchor="t" lIns="0" rIns="0" tIns="0" bIns="0">
+            <a:spAutoFit/>
+          </a:bodyPr>
+          <a:lstStyle/>
+          <a:p>
+            <a:pPr algn="l">
+              <a:lnSpc>
+                <a:spcPct val="100000"/>
+              </a:lnSpc>
+              <a:spcAft>
+                <a:spcPts val="0"/>
+              </a:spcAft>
+            </a:pPr>
+            <a:r>
+              <a:rPr sz="1300" b="0" i="0">
+                <a:solidFill>
+                  <a:srgbClr val="20232A"/>
+                </a:solidFill>
+                <a:latin typeface="Calibri"/>
+              </a:rPr>
+              <a:t>Iso / 3+ dribble rate</a:t>
+            </a:r>
+          </a:p>
+        </p:txBody>
+      </p:sp>
+      <p:sp>
+        <p:nvSpPr>
+          <p:cNvPr id="15" name="TextBox 14"/>
+          <p:cNvSpPr txBox="1"/>
+          <p:nvPr/>
+        </p:nvSpPr>
+        <p:spPr>
+          <a:xfrm>
+            <a:off x="3566160" y="3840480"/>
+            <a:ext cx="1737360" cy="320040"/>
+          </a:xfrm>
+          <a:prstGeom prst="rect">
+            <a:avLst/>
+          </a:prstGeom>
+          <a:noFill/>
+        </p:spPr>
+        <p:txBody>
+          <a:bodyPr wrap="square" anchor="t" lIns="0" rIns="0" tIns="0" bIns="0">
+            <a:spAutoFit/>
+          </a:bodyPr>
+          <a:lstStyle/>
+          <a:p>
+            <a:pPr algn="l">
+              <a:lnSpc>
+                <a:spcPct val="100000"/>
+              </a:lnSpc>
+              <a:spcAft>
+                <a:spcPts val="0"/>
+              </a:spcAft>
+            </a:pPr>
+            <a:r>
+              <a:rPr sz="1350" b="1" i="0">
+                <a:solidFill>
+                  <a:srgbClr val="6B7280"/>
+                </a:solidFill>
+                <a:latin typeface="Calibri"/>
+              </a:rPr>
+              <a:t>0.639</a:t>
+            </a:r>
+          </a:p>
+        </p:txBody>
+      </p:sp>
+      <p:sp>
+        <p:nvSpPr>
+          <p:cNvPr id="16" name="TextBox 15"/>
+          <p:cNvSpPr txBox="1"/>
+          <p:nvPr/>
+        </p:nvSpPr>
+        <p:spPr>
+          <a:xfrm>
+            <a:off x="5394960" y="3840480"/>
+            <a:ext cx="1737360" cy="320040"/>
+          </a:xfrm>
+          <a:prstGeom prst="rect">
+            <a:avLst/>
+          </a:prstGeom>
+          <a:noFill/>
+        </p:spPr>
+        <p:txBody>
+          <a:bodyPr wrap="square" anchor="t" lIns="0" rIns="0" tIns="0" bIns="0">
+            <a:spAutoFit/>
+          </a:bodyPr>
+          <a:lstStyle/>
+          <a:p>
+            <a:pPr algn="l">
+              <a:lnSpc>
+                <a:spcPct val="100000"/>
+              </a:lnSpc>
+              <a:spcAft>
+                <a:spcPts val="0"/>
+              </a:spcAft>
+            </a:pPr>
+            <a:r>
+              <a:rPr sz="1350" b="1" i="0">
+                <a:solidFill>
+                  <a:srgbClr val="007A33"/>
+                </a:solidFill>
+                <a:latin typeface="Calibri"/>
+              </a:rPr>
+              <a:t>0.404</a:t>
+            </a:r>
+          </a:p>
+        </p:txBody>
+      </p:sp>
+      <p:sp>
+        <p:nvSpPr>
+          <p:cNvPr id="17" name="TextBox 16"/>
+          <p:cNvSpPr txBox="1"/>
+          <p:nvPr/>
+        </p:nvSpPr>
+        <p:spPr>
+          <a:xfrm>
+            <a:off x="859536" y="4389120"/>
+            <a:ext cx="2651760" cy="320040"/>
+          </a:xfrm>
+          <a:prstGeom prst="rect">
+            <a:avLst/>
+          </a:prstGeom>
+          <a:noFill/>
+        </p:spPr>
+        <p:txBody>
+          <a:bodyPr wrap="square" anchor="t" lIns="0" rIns="0" tIns="0" bIns="0">
+            <a:spAutoFit/>
+          </a:bodyPr>
+          <a:lstStyle/>
+          <a:p>
+            <a:pPr algn="l">
+              <a:lnSpc>
+                <a:spcPct val="100000"/>
+              </a:lnSpc>
+              <a:spcAft>
+                <a:spcPts val="0"/>
+              </a:spcAft>
+            </a:pPr>
+            <a:r>
+              <a:rPr sz="1300" b="0" i="0">
+                <a:solidFill>
+                  <a:srgbClr val="20232A"/>
+                </a:solidFill>
+                <a:latin typeface="Calibri"/>
+              </a:rPr>
+              <a:t>Contested-shot rate</a:t>
+            </a:r>
+          </a:p>
+        </p:txBody>
+      </p:sp>
+      <p:sp>
+        <p:nvSpPr>
+          <p:cNvPr id="18" name="TextBox 17"/>
+          <p:cNvSpPr txBox="1"/>
+          <p:nvPr/>
+        </p:nvSpPr>
+        <p:spPr>
+          <a:xfrm>
+            <a:off x="3566160" y="4389120"/>
+            <a:ext cx="1737360" cy="320040"/>
+          </a:xfrm>
+          <a:prstGeom prst="rect">
+            <a:avLst/>
+          </a:prstGeom>
+          <a:noFill/>
+        </p:spPr>
+        <p:txBody>
+          <a:bodyPr wrap="square" anchor="t" lIns="0" rIns="0" tIns="0" bIns="0">
+            <a:spAutoFit/>
+          </a:bodyPr>
+          <a:lstStyle/>
+          <a:p>
+            <a:pPr algn="l">
+              <a:lnSpc>
+                <a:spcPct val="100000"/>
+              </a:lnSpc>
+              <a:spcAft>
+                <a:spcPts val="0"/>
+              </a:spcAft>
+            </a:pPr>
+            <a:r>
+              <a:rPr sz="1350" b="1" i="0">
+                <a:solidFill>
+                  <a:srgbClr val="6B7280"/>
+                </a:solidFill>
+                <a:latin typeface="Calibri"/>
+              </a:rPr>
+              <a:t>0.517</a:t>
+            </a:r>
+          </a:p>
+        </p:txBody>
+      </p:sp>
+      <p:sp>
+        <p:nvSpPr>
+          <p:cNvPr id="19" name="TextBox 18"/>
+          <p:cNvSpPr txBox="1"/>
+          <p:nvPr/>
+        </p:nvSpPr>
+        <p:spPr>
+          <a:xfrm>
+            <a:off x="5394960" y="4389120"/>
+            <a:ext cx="1737360" cy="320040"/>
+          </a:xfrm>
+          <a:prstGeom prst="rect">
+            <a:avLst/>
+          </a:prstGeom>
+          <a:noFill/>
+        </p:spPr>
+        <p:txBody>
+          <a:bodyPr wrap="square" anchor="t" lIns="0" rIns="0" tIns="0" bIns="0">
+            <a:spAutoFit/>
+          </a:bodyPr>
+          <a:lstStyle/>
+          <a:p>
+            <a:pPr algn="l">
+              <a:lnSpc>
+                <a:spcPct val="100000"/>
+              </a:lnSpc>
+              <a:spcAft>
+                <a:spcPts val="0"/>
+              </a:spcAft>
+            </a:pPr>
+            <a:r>
+              <a:rPr sz="1350" b="1" i="0">
+                <a:solidFill>
+                  <a:srgbClr val="007A33"/>
+                </a:solidFill>
+                <a:latin typeface="Calibri"/>
+              </a:rPr>
+              <a:t>0.370</a:t>
+            </a:r>
+          </a:p>
+        </p:txBody>
+      </p:sp>
+      <p:sp>
+        <p:nvSpPr>
+          <p:cNvPr id="20" name="TextBox 19"/>
+          <p:cNvSpPr txBox="1"/>
+          <p:nvPr/>
+        </p:nvSpPr>
+        <p:spPr>
+          <a:xfrm>
+            <a:off x="859536" y="4937759"/>
+            <a:ext cx="2651760" cy="320040"/>
+          </a:xfrm>
+          <a:prstGeom prst="rect">
+            <a:avLst/>
+          </a:prstGeom>
+          <a:noFill/>
+        </p:spPr>
+        <p:txBody>
+          <a:bodyPr wrap="square" anchor="t" lIns="0" rIns="0" tIns="0" bIns="0">
+            <a:spAutoFit/>
+          </a:bodyPr>
+          <a:lstStyle/>
+          <a:p>
+            <a:pPr algn="l">
+              <a:lnSpc>
+                <a:spcPct val="100000"/>
+              </a:lnSpc>
+              <a:spcAft>
+                <a:spcPts val="0"/>
+              </a:spcAft>
+            </a:pPr>
+            <a:r>
+              <a:rPr sz="1300" b="0" i="0">
+                <a:solidFill>
+                  <a:srgbClr val="20232A"/>
+                </a:solidFill>
+                <a:latin typeface="Calibri"/>
+              </a:rPr>
+              <a:t>Bad-shot index</a:t>
+            </a:r>
+          </a:p>
+        </p:txBody>
+      </p:sp>
+      <p:sp>
+        <p:nvSpPr>
+          <p:cNvPr id="21" name="TextBox 20"/>
+          <p:cNvSpPr txBox="1"/>
+          <p:nvPr/>
+        </p:nvSpPr>
+        <p:spPr>
+          <a:xfrm>
+            <a:off x="3566160" y="4937759"/>
+            <a:ext cx="1737360" cy="320040"/>
+          </a:xfrm>
+          <a:prstGeom prst="rect">
+            <a:avLst/>
+          </a:prstGeom>
+          <a:noFill/>
+        </p:spPr>
+        <p:txBody>
+          <a:bodyPr wrap="square" anchor="t" lIns="0" rIns="0" tIns="0" bIns="0">
+            <a:spAutoFit/>
+          </a:bodyPr>
+          <a:lstStyle/>
+          <a:p>
+            <a:pPr algn="l">
+              <a:lnSpc>
+                <a:spcPct val="100000"/>
+              </a:lnSpc>
+              <a:spcAft>
+                <a:spcPts val="0"/>
+              </a:spcAft>
+            </a:pPr>
+            <a:r>
+              <a:rPr sz="1350" b="1" i="0">
+                <a:solidFill>
+                  <a:srgbClr val="6B7280"/>
+                </a:solidFill>
+                <a:latin typeface="Calibri"/>
+              </a:rPr>
+              <a:t>0.379</a:t>
+            </a:r>
+          </a:p>
+        </p:txBody>
+      </p:sp>
+      <p:sp>
+        <p:nvSpPr>
+          <p:cNvPr id="22" name="TextBox 21"/>
+          <p:cNvSpPr txBox="1"/>
+          <p:nvPr/>
+        </p:nvSpPr>
+        <p:spPr>
+          <a:xfrm>
+            <a:off x="5394960" y="4937759"/>
+            <a:ext cx="1737360" cy="320040"/>
+          </a:xfrm>
+          <a:prstGeom prst="rect">
+            <a:avLst/>
+          </a:prstGeom>
+          <a:noFill/>
+        </p:spPr>
+        <p:txBody>
+          <a:bodyPr wrap="square" anchor="t" lIns="0" rIns="0" tIns="0" bIns="0">
+            <a:spAutoFit/>
+          </a:bodyPr>
+          <a:lstStyle/>
+          <a:p>
+            <a:pPr algn="l">
+              <a:lnSpc>
+                <a:spcPct val="100000"/>
+              </a:lnSpc>
+              <a:spcAft>
+                <a:spcPts val="0"/>
+              </a:spcAft>
+            </a:pPr>
+            <a:r>
+              <a:rPr sz="1350" b="1" i="0">
+                <a:solidFill>
+                  <a:srgbClr val="007A33"/>
+                </a:solidFill>
+                <a:latin typeface="Calibri"/>
+              </a:rPr>
+              <a:t>0.273</a:t>
+            </a:r>
+          </a:p>
+        </p:txBody>
+      </p:sp>
+      <p:sp>
+        <p:nvSpPr>
+          <p:cNvPr id="23" name="TextBox 22"/>
+          <p:cNvSpPr txBox="1"/>
+          <p:nvPr/>
+        </p:nvSpPr>
+        <p:spPr>
+          <a:xfrm>
+            <a:off x="859536" y="5138928"/>
+            <a:ext cx="6035040" cy="457200"/>
+          </a:xfrm>
+          <a:prstGeom prst="rect">
+            <a:avLst/>
+          </a:prstGeom>
+          <a:noFill/>
+        </p:spPr>
+        <p:txBody>
+          <a:bodyPr wrap="square" anchor="t" lIns="0" rIns="0" tIns="0" bIns="0">
+            <a:spAutoFit/>
+          </a:bodyPr>
+          <a:lstStyle/>
+          <a:p>
+            <a:pPr algn="l">
+              <a:lnSpc>
+                <a:spcPct val="105000"/>
+              </a:lnSpc>
+              <a:spcAft>
+                <a:spcPts val="400"/>
+              </a:spcAft>
+            </a:pPr>
+            <a:r>
+              <a:rPr sz="1150" b="0" i="1">
+                <a:solidFill>
+                  <a:srgbClr val="6B7280"/>
+                </a:solidFill>
+                <a:latin typeface="Calibri"/>
+              </a:rPr>
+              <a:t>George takes the shots the system is built to generate — he plugs in instead of stopping it.</a:t>
+            </a:r>
+          </a:p>
+        </p:txBody>
+      </p:sp>
+      <p:sp>
+        <p:nvSpPr>
+          <p:cNvPr id="24" name="Rounded Rectangle 23"/>
           <p:cNvSpPr/>
           <p:nvPr/>
         </p:nvSpPr>
         <p:spPr>
           <a:xfrm>
-            <a:off x="841247" y="2130552"/>
-            <a:ext cx="384048" cy="384048"/>
-          </a:xfrm>
-          <a:prstGeom prst="ellipse">
-            <a:avLst/>
+            <a:off x="7452360" y="1783080"/>
+            <a:ext cx="4160520" cy="3977639"/>
+          </a:xfrm>
+          <a:prstGeom prst="roundRect">
+            <a:avLst>
+              <a:gd name="adj" fmla="val 8000"/>
+            </a:avLst>
           </a:prstGeom>
           <a:solidFill>
-            <a:srgbClr val="BA9653"/>
+            <a:srgbClr val="0A2A1A"/>
           </a:solidFill>
           <a:ln>
             <a:noFill/>
@@ -6841,32 +7317,23 @@
           </a:fontRef>
         </p:style>
         <p:txBody>
-          <a:bodyPr rtlCol="0" anchor="ctr" wrap="none"/>
+          <a:bodyPr rtlCol="0" anchor="ctr"/>
           <a:lstStyle/>
           <a:p>
             <a:pPr algn="ctr"/>
-            <a:r>
-              <a:rPr sz="1600" b="1">
-                <a:solidFill>
-                  <a:srgbClr val="FFFFFF"/>
-                </a:solidFill>
-                <a:latin typeface="Cambria"/>
-              </a:rPr>
-              <a:t>1</a:t>
-            </a:r>
-          </a:p>
-        </p:txBody>
-      </p:sp>
-      <p:sp>
-        <p:nvSpPr>
-          <p:cNvPr id="6" name="TextBox 5"/>
+          </a:p>
+        </p:txBody>
+      </p:sp>
+      <p:sp>
+        <p:nvSpPr>
+          <p:cNvPr id="25" name="TextBox 24"/>
           <p:cNvSpPr txBox="1"/>
           <p:nvPr/>
         </p:nvSpPr>
         <p:spPr>
           <a:xfrm>
-            <a:off x="841247" y="2715768"/>
-            <a:ext cx="2999232" cy="457200"/>
+            <a:off x="7726679" y="2011680"/>
+            <a:ext cx="3657600" cy="365760"/>
           </a:xfrm>
           <a:prstGeom prst="rect">
             <a:avLst/>
@@ -6888,27 +7355,27 @@
               </a:spcAft>
             </a:pPr>
             <a:r>
-              <a:rPr sz="1600" b="1" i="0">
-                <a:solidFill>
-                  <a:srgbClr val="0A2A1A"/>
-                </a:solidFill>
-                <a:latin typeface="Cambria"/>
-              </a:rPr>
-              <a:t>The Tatum confound</a:t>
-            </a:r>
-          </a:p>
-        </p:txBody>
-      </p:sp>
-      <p:sp>
-        <p:nvSpPr>
-          <p:cNvPr id="7" name="TextBox 6"/>
+              <a:rPr sz="1250" b="1" i="0">
+                <a:solidFill>
+                  <a:srgbClr val="BCD3C6"/>
+                </a:solidFill>
+                <a:latin typeface="Calibri"/>
+              </a:rPr>
+              <a:t>PLUS THE PICKS</a:t>
+            </a:r>
+          </a:p>
+        </p:txBody>
+      </p:sp>
+      <p:sp>
+        <p:nvSpPr>
+          <p:cNvPr id="26" name="TextBox 25"/>
           <p:cNvSpPr txBox="1"/>
           <p:nvPr/>
         </p:nvSpPr>
         <p:spPr>
           <a:xfrm>
-            <a:off x="841247" y="3200400"/>
-            <a:ext cx="2999232" cy="1554480"/>
+            <a:off x="7726679" y="2468880"/>
+            <a:ext cx="3657600" cy="914400"/>
           </a:xfrm>
           <a:prstGeom prst="rect">
             <a:avLst/>
@@ -6923,33 +7390,297 @@
           <a:p>
             <a:pPr algn="l">
               <a:lnSpc>
-                <a:spcPct val="112000"/>
+                <a:spcPct val="105000"/>
+              </a:lnSpc>
+              <a:spcAft>
+                <a:spcPts val="200"/>
+              </a:spcAft>
+            </a:pPr>
+            <a:r>
+              <a:rPr sz="2000" b="1" i="0">
+                <a:solidFill>
+                  <a:srgbClr val="FFFFFF"/>
+                </a:solidFill>
+                <a:latin typeface="Cambria"/>
+              </a:rPr>
+              <a:t>2028 first + 2031</a:t>
+            </a:r>
+          </a:p>
+          <a:p>
+            <a:pPr algn="l">
+              <a:lnSpc>
+                <a:spcPct val="105000"/>
+              </a:lnSpc>
+              <a:spcAft>
+                <a:spcPts val="200"/>
+              </a:spcAft>
+            </a:pPr>
+            <a:r>
+              <a:rPr sz="2000" b="1" i="0">
+                <a:solidFill>
+                  <a:srgbClr val="FFFFFF"/>
+                </a:solidFill>
+                <a:latin typeface="Cambria"/>
+              </a:rPr>
+              <a:t>unprotected first</a:t>
+            </a:r>
+          </a:p>
+        </p:txBody>
+      </p:sp>
+      <p:sp>
+        <p:nvSpPr>
+          <p:cNvPr id="27" name="TextBox 26"/>
+          <p:cNvSpPr txBox="1"/>
+          <p:nvPr/>
+        </p:nvSpPr>
+        <p:spPr>
+          <a:xfrm>
+            <a:off x="7726679" y="3520440"/>
+            <a:ext cx="3657600" cy="1463040"/>
+          </a:xfrm>
+          <a:prstGeom prst="rect">
+            <a:avLst/>
+          </a:prstGeom>
+          <a:noFill/>
+        </p:spPr>
+        <p:txBody>
+          <a:bodyPr wrap="square" anchor="t" lIns="0" rIns="0" tIns="0" bIns="0">
+            <a:spAutoFit/>
+          </a:bodyPr>
+          <a:lstStyle/>
+          <a:p>
+            <a:pPr algn="l">
+              <a:lnSpc>
+                <a:spcPct val="115000"/>
               </a:lnSpc>
               <a:spcAft>
                 <a:spcPts val="400"/>
               </a:spcAft>
             </a:pPr>
             <a:r>
-              <a:rPr sz="1280" b="0" i="0">
+              <a:rPr sz="1250" b="0" i="0">
+                <a:solidFill>
+                  <a:srgbClr val="CFE0D6"/>
+                </a:solidFill>
+                <a:latin typeface="Calibri"/>
+              </a:rPr>
+              <a:t>Under the post-2019 flattened lottery — exact odds enumerated across all 24,024 seed permutations — late-lottery firsts convey materially more top-4 equity than the old system.</a:t>
+            </a:r>
+          </a:p>
+        </p:txBody>
+      </p:sp>
+      <p:sp>
+        <p:nvSpPr>
+          <p:cNvPr id="28" name="TextBox 27"/>
+          <p:cNvSpPr txBox="1"/>
+          <p:nvPr/>
+        </p:nvSpPr>
+        <p:spPr>
+          <a:xfrm>
+            <a:off x="7726679" y="5074920"/>
+            <a:ext cx="3657600" cy="548640"/>
+          </a:xfrm>
+          <a:prstGeom prst="rect">
+            <a:avLst/>
+          </a:prstGeom>
+          <a:noFill/>
+        </p:spPr>
+        <p:txBody>
+          <a:bodyPr wrap="square" anchor="t" lIns="0" rIns="0" tIns="0" bIns="0">
+            <a:spAutoFit/>
+          </a:bodyPr>
+          <a:lstStyle/>
+          <a:p>
+            <a:pPr algn="l">
+              <a:lnSpc>
+                <a:spcPct val="108000"/>
+              </a:lnSpc>
+              <a:spcAft>
+                <a:spcPts val="400"/>
+              </a:spcAft>
+            </a:pPr>
+            <a:r>
+              <a:rPr sz="1150" b="0" i="1">
+                <a:solidFill>
+                  <a:srgbClr val="9AB2A4"/>
+                </a:solidFill>
+                <a:latin typeface="Calibri"/>
+              </a:rPr>
+              <a:t>Cheap, controllable, tradeable — the assets a capped-out roster can't otherwise get.</a:t>
+            </a:r>
+          </a:p>
+        </p:txBody>
+      </p:sp>
+      <p:sp>
+        <p:nvSpPr>
+          <p:cNvPr id="29" name="TextBox 28"/>
+          <p:cNvSpPr txBox="1"/>
+          <p:nvPr/>
+        </p:nvSpPr>
+        <p:spPr>
+          <a:xfrm>
+            <a:off x="566928" y="6510528"/>
+            <a:ext cx="11064240" cy="274320"/>
+          </a:xfrm>
+          <a:prstGeom prst="rect">
+            <a:avLst/>
+          </a:prstGeom>
+          <a:noFill/>
+        </p:spPr>
+        <p:txBody>
+          <a:bodyPr wrap="square" anchor="t" lIns="0" rIns="0" tIns="0" bIns="0">
+            <a:spAutoFit/>
+          </a:bodyPr>
+          <a:lstStyle/>
+          <a:p>
+            <a:pPr algn="l">
+              <a:lnSpc>
+                <a:spcPct val="100000"/>
+              </a:lnSpc>
+              <a:spcAft>
+                <a:spcPts val="0"/>
+              </a:spcAft>
+            </a:pPr>
+            <a:r>
+              <a:rPr sz="900" b="0" i="0">
                 <a:solidFill>
                   <a:srgbClr val="6B7280"/>
                 </a:solidFill>
                 <a:latin typeface="Calibri"/>
               </a:rPr>
-              <a:t>The 2025-26 with/without splits are contaminated by Tatum's injury absence. The direction survives; the magnitude is uncertain.</a:t>
-            </a:r>
-          </a:p>
-        </p:txBody>
-      </p:sp>
-      <p:sp>
-        <p:nvSpPr>
-          <p:cNvPr id="8" name="Rounded Rectangle 7"/>
+              <a:t>Fit Check · Jaylen Brown Trade Audit</a:t>
+            </a:r>
+            <a:r>
+              <a:rPr sz="900" b="0" i="0">
+                <a:solidFill>
+                  <a:srgbClr val="6B7280"/>
+                </a:solidFill>
+                <a:latin typeface="Calibri"/>
+              </a:rPr>
+              <a:t>      Data: nba_api / Basketball-Reference · 2024-25 &amp; 2025-26 · July 2026</a:t>
+            </a:r>
+          </a:p>
+        </p:txBody>
+      </p:sp>
+    </p:spTree>
+  </p:cSld>
+  <p:clrMapOvr>
+    <a:masterClrMapping/>
+  </p:clrMapOvr>
+</p:sld>
+</file>
+
+<file path=ppt/slides/slide8.xml><?xml version="1.0" encoding="utf-8"?>
+<p:sld xmlns:a="http://schemas.openxmlformats.org/drawingml/2006/main" xmlns:p="http://schemas.openxmlformats.org/presentationml/2006/main" xmlns:r="http://schemas.openxmlformats.org/officeDocument/2006/relationships">
+  <p:cSld>
+    <p:bg>
+      <p:bgPr>
+        <a:solidFill>
+          <a:srgbClr val="F4F5F7"/>
+        </a:solidFill>
+        <a:effectLst/>
+      </p:bgPr>
+    </p:bg>
+    <p:spTree>
+      <p:nvGrpSpPr>
+        <p:cNvPr id="1" name=""/>
+        <p:cNvGrpSpPr/>
+        <p:nvPr/>
+      </p:nvGrpSpPr>
+      <p:grpSpPr/>
+      <p:sp>
+        <p:nvSpPr>
+          <p:cNvPr id="2" name="TextBox 1"/>
+          <p:cNvSpPr txBox="1"/>
+          <p:nvPr/>
+        </p:nvSpPr>
+        <p:spPr>
+          <a:xfrm>
+            <a:off x="566928" y="384048"/>
+            <a:ext cx="10058400" cy="274320"/>
+          </a:xfrm>
+          <a:prstGeom prst="rect">
+            <a:avLst/>
+          </a:prstGeom>
+          <a:noFill/>
+        </p:spPr>
+        <p:txBody>
+          <a:bodyPr wrap="square" anchor="t" lIns="0" rIns="0" tIns="0" bIns="0">
+            <a:spAutoFit/>
+          </a:bodyPr>
+          <a:lstStyle/>
+          <a:p>
+            <a:pPr algn="l">
+              <a:lnSpc>
+                <a:spcPct val="100000"/>
+              </a:lnSpc>
+              <a:spcAft>
+                <a:spcPts val="0"/>
+              </a:spcAft>
+            </a:pPr>
+            <a:r>
+              <a:rPr sz="1250" b="1" i="0">
+                <a:solidFill>
+                  <a:srgbClr val="007A33"/>
+                </a:solidFill>
+                <a:latin typeface="Calibri"/>
+              </a:rPr>
+              <a:t>WHERE THE CASE IS WEAKEST</a:t>
+            </a:r>
+          </a:p>
+        </p:txBody>
+      </p:sp>
+      <p:sp>
+        <p:nvSpPr>
+          <p:cNvPr id="3" name="TextBox 2"/>
+          <p:cNvSpPr txBox="1"/>
+          <p:nvPr/>
+        </p:nvSpPr>
+        <p:spPr>
+          <a:xfrm>
+            <a:off x="566928" y="658368"/>
+            <a:ext cx="11064240" cy="868680"/>
+          </a:xfrm>
+          <a:prstGeom prst="rect">
+            <a:avLst/>
+          </a:prstGeom>
+          <a:noFill/>
+        </p:spPr>
+        <p:txBody>
+          <a:bodyPr wrap="square" anchor="t" lIns="0" rIns="0" tIns="0" bIns="0">
+            <a:spAutoFit/>
+          </a:bodyPr>
+          <a:lstStyle/>
+          <a:p>
+            <a:pPr algn="l">
+              <a:lnSpc>
+                <a:spcPct val="100000"/>
+              </a:lnSpc>
+              <a:spcAft>
+                <a:spcPts val="0"/>
+              </a:spcAft>
+            </a:pPr>
+            <a:r>
+              <a:rPr sz="3000" b="1" i="0">
+                <a:solidFill>
+                  <a:srgbClr val="0A2A1A"/>
+                </a:solidFill>
+                <a:latin typeface="Cambria"/>
+              </a:rPr>
+              <a:t>The counter-evidence, on the record</a:t>
+            </a:r>
+          </a:p>
+        </p:txBody>
+      </p:sp>
+      <p:sp>
+        <p:nvSpPr>
+          <p:cNvPr id="4" name="Rounded Rectangle 3"/>
           <p:cNvSpPr/>
           <p:nvPr/>
         </p:nvSpPr>
         <p:spPr>
           <a:xfrm>
-            <a:off x="4352544" y="1874519"/>
+            <a:off x="566928" y="1874519"/>
             <a:ext cx="3502152" cy="3017520"/>
           </a:xfrm>
           <a:prstGeom prst="roundRect">
@@ -6991,13 +7722,13 @@
       </p:sp>
       <p:sp>
         <p:nvSpPr>
-          <p:cNvPr id="9" name="Oval 8"/>
+          <p:cNvPr id="5" name="Oval 4"/>
           <p:cNvSpPr/>
           <p:nvPr/>
         </p:nvSpPr>
         <p:spPr>
           <a:xfrm>
-            <a:off x="4626864" y="2130552"/>
+            <a:off x="841247" y="2130552"/>
             <a:ext cx="384048" cy="384048"/>
           </a:xfrm>
           <a:prstGeom prst="ellipse">
@@ -7037,20 +7768,20 @@
                 </a:solidFill>
                 <a:latin typeface="Cambria"/>
               </a:rPr>
-              <a:t>2</a:t>
-            </a:r>
-          </a:p>
-        </p:txBody>
-      </p:sp>
-      <p:sp>
-        <p:nvSpPr>
-          <p:cNvPr id="10" name="TextBox 9"/>
+              <a:t>1</a:t>
+            </a:r>
+          </a:p>
+        </p:txBody>
+      </p:sp>
+      <p:sp>
+        <p:nvSpPr>
+          <p:cNvPr id="6" name="TextBox 5"/>
           <p:cNvSpPr txBox="1"/>
           <p:nvPr/>
         </p:nvSpPr>
         <p:spPr>
           <a:xfrm>
-            <a:off x="4626864" y="2715768"/>
+            <a:off x="841247" y="2715768"/>
             <a:ext cx="2999232" cy="457200"/>
           </a:xfrm>
           <a:prstGeom prst="rect">
@@ -7079,20 +7810,20 @@
                 </a:solidFill>
                 <a:latin typeface="Cambria"/>
               </a:rPr>
-              <a:t>Win Shares are blunt</a:t>
-            </a:r>
-          </a:p>
-        </p:txBody>
-      </p:sp>
-      <p:sp>
-        <p:nvSpPr>
-          <p:cNvPr id="11" name="TextBox 10"/>
+              <a:t>The Tatum confound</a:t>
+            </a:r>
+          </a:p>
+        </p:txBody>
+      </p:sp>
+      <p:sp>
+        <p:nvSpPr>
+          <p:cNvPr id="7" name="TextBox 6"/>
           <p:cNvSpPr txBox="1"/>
           <p:nvPr/>
         </p:nvSpPr>
         <p:spPr>
           <a:xfrm>
-            <a:off x="4626864" y="3200400"/>
+            <a:off x="841247" y="3200400"/>
             <a:ext cx="2999232" cy="1554480"/>
           </a:xfrm>
           <a:prstGeom prst="rect">
@@ -7121,20 +7852,20 @@
                 </a:solidFill>
                 <a:latin typeface="Calibri"/>
               </a:rPr>
-              <a:t>Cost-per-WS is a crude value metric — it's used because it spans both seasons and the full comp cohort, not because it's perfect.</a:t>
-            </a:r>
-          </a:p>
-        </p:txBody>
-      </p:sp>
-      <p:sp>
-        <p:nvSpPr>
-          <p:cNvPr id="12" name="Rounded Rectangle 11"/>
+              <a:t>The 2025-26 with/without splits are contaminated by Tatum's injury absence. The direction survives; the magnitude is uncertain.</a:t>
+            </a:r>
+          </a:p>
+        </p:txBody>
+      </p:sp>
+      <p:sp>
+        <p:nvSpPr>
+          <p:cNvPr id="8" name="Rounded Rectangle 7"/>
           <p:cNvSpPr/>
           <p:nvPr/>
         </p:nvSpPr>
         <p:spPr>
           <a:xfrm>
-            <a:off x="8138159" y="1874519"/>
+            <a:off x="4352544" y="1874519"/>
             <a:ext cx="3502152" cy="3017520"/>
           </a:xfrm>
           <a:prstGeom prst="roundRect">
@@ -7176,20 +7907,20 @@
       </p:sp>
       <p:sp>
         <p:nvSpPr>
-          <p:cNvPr id="13" name="Oval 12"/>
+          <p:cNvPr id="9" name="Oval 8"/>
           <p:cNvSpPr/>
           <p:nvPr/>
         </p:nvSpPr>
         <p:spPr>
           <a:xfrm>
-            <a:off x="8412480" y="2130552"/>
+            <a:off x="4626864" y="2130552"/>
             <a:ext cx="384048" cy="384048"/>
           </a:xfrm>
           <a:prstGeom prst="ellipse">
             <a:avLst/>
           </a:prstGeom>
           <a:solidFill>
-            <a:srgbClr val="B3403A"/>
+            <a:srgbClr val="BA9653"/>
           </a:solidFill>
           <a:ln>
             <a:noFill/>
@@ -7222,6 +7953,191 @@
                 </a:solidFill>
                 <a:latin typeface="Cambria"/>
               </a:rPr>
+              <a:t>2</a:t>
+            </a:r>
+          </a:p>
+        </p:txBody>
+      </p:sp>
+      <p:sp>
+        <p:nvSpPr>
+          <p:cNvPr id="10" name="TextBox 9"/>
+          <p:cNvSpPr txBox="1"/>
+          <p:nvPr/>
+        </p:nvSpPr>
+        <p:spPr>
+          <a:xfrm>
+            <a:off x="4626864" y="2715768"/>
+            <a:ext cx="2999232" cy="457200"/>
+          </a:xfrm>
+          <a:prstGeom prst="rect">
+            <a:avLst/>
+          </a:prstGeom>
+          <a:noFill/>
+        </p:spPr>
+        <p:txBody>
+          <a:bodyPr wrap="square" anchor="t" lIns="0" rIns="0" tIns="0" bIns="0">
+            <a:spAutoFit/>
+          </a:bodyPr>
+          <a:lstStyle/>
+          <a:p>
+            <a:pPr algn="l">
+              <a:lnSpc>
+                <a:spcPct val="100000"/>
+              </a:lnSpc>
+              <a:spcAft>
+                <a:spcPts val="0"/>
+              </a:spcAft>
+            </a:pPr>
+            <a:r>
+              <a:rPr sz="1600" b="1" i="0">
+                <a:solidFill>
+                  <a:srgbClr val="0A2A1A"/>
+                </a:solidFill>
+                <a:latin typeface="Cambria"/>
+              </a:rPr>
+              <a:t>Win Shares are blunt</a:t>
+            </a:r>
+          </a:p>
+        </p:txBody>
+      </p:sp>
+      <p:sp>
+        <p:nvSpPr>
+          <p:cNvPr id="11" name="TextBox 10"/>
+          <p:cNvSpPr txBox="1"/>
+          <p:nvPr/>
+        </p:nvSpPr>
+        <p:spPr>
+          <a:xfrm>
+            <a:off x="4626864" y="3200400"/>
+            <a:ext cx="2999232" cy="1554480"/>
+          </a:xfrm>
+          <a:prstGeom prst="rect">
+            <a:avLst/>
+          </a:prstGeom>
+          <a:noFill/>
+        </p:spPr>
+        <p:txBody>
+          <a:bodyPr wrap="square" anchor="t" lIns="0" rIns="0" tIns="0" bIns="0">
+            <a:spAutoFit/>
+          </a:bodyPr>
+          <a:lstStyle/>
+          <a:p>
+            <a:pPr algn="l">
+              <a:lnSpc>
+                <a:spcPct val="112000"/>
+              </a:lnSpc>
+              <a:spcAft>
+                <a:spcPts val="400"/>
+              </a:spcAft>
+            </a:pPr>
+            <a:r>
+              <a:rPr sz="1280" b="0" i="0">
+                <a:solidFill>
+                  <a:srgbClr val="6B7280"/>
+                </a:solidFill>
+                <a:latin typeface="Calibri"/>
+              </a:rPr>
+              <a:t>Cost-per-WS is a crude value metric — it's used because it spans both seasons and the full comp cohort, not because it's perfect.</a:t>
+            </a:r>
+          </a:p>
+        </p:txBody>
+      </p:sp>
+      <p:sp>
+        <p:nvSpPr>
+          <p:cNvPr id="12" name="Rounded Rectangle 11"/>
+          <p:cNvSpPr/>
+          <p:nvPr/>
+        </p:nvSpPr>
+        <p:spPr>
+          <a:xfrm>
+            <a:off x="8138159" y="1874519"/>
+            <a:ext cx="3502152" cy="3017520"/>
+          </a:xfrm>
+          <a:prstGeom prst="roundRect">
+            <a:avLst>
+              <a:gd name="adj" fmla="val 8000"/>
+            </a:avLst>
+          </a:prstGeom>
+          <a:solidFill>
+            <a:srgbClr val="FFFFFF"/>
+          </a:solidFill>
+          <a:ln w="12700">
+            <a:solidFill>
+              <a:srgbClr val="D7DAE0"/>
+            </a:solidFill>
+          </a:ln>
+          <a:effectLst/>
+        </p:spPr>
+        <p:style>
+          <a:lnRef idx="1">
+            <a:schemeClr val="accent1"/>
+          </a:lnRef>
+          <a:fillRef idx="3">
+            <a:schemeClr val="accent1"/>
+          </a:fillRef>
+          <a:effectRef idx="2">
+            <a:schemeClr val="accent1"/>
+          </a:effectRef>
+          <a:fontRef idx="minor">
+            <a:schemeClr val="lt1"/>
+          </a:fontRef>
+        </p:style>
+        <p:txBody>
+          <a:bodyPr rtlCol="0" anchor="ctr"/>
+          <a:lstStyle/>
+          <a:p>
+            <a:pPr algn="ctr"/>
+          </a:p>
+        </p:txBody>
+      </p:sp>
+      <p:sp>
+        <p:nvSpPr>
+          <p:cNvPr id="13" name="Oval 12"/>
+          <p:cNvSpPr/>
+          <p:nvPr/>
+        </p:nvSpPr>
+        <p:spPr>
+          <a:xfrm>
+            <a:off x="8412480" y="2130552"/>
+            <a:ext cx="384048" cy="384048"/>
+          </a:xfrm>
+          <a:prstGeom prst="ellipse">
+            <a:avLst/>
+          </a:prstGeom>
+          <a:solidFill>
+            <a:srgbClr val="B3403A"/>
+          </a:solidFill>
+          <a:ln>
+            <a:noFill/>
+          </a:ln>
+          <a:effectLst/>
+        </p:spPr>
+        <p:style>
+          <a:lnRef idx="1">
+            <a:schemeClr val="accent1"/>
+          </a:lnRef>
+          <a:fillRef idx="3">
+            <a:schemeClr val="accent1"/>
+          </a:fillRef>
+          <a:effectRef idx="2">
+            <a:schemeClr val="accent1"/>
+          </a:effectRef>
+          <a:fontRef idx="minor">
+            <a:schemeClr val="lt1"/>
+          </a:fontRef>
+        </p:style>
+        <p:txBody>
+          <a:bodyPr rtlCol="0" anchor="ctr" wrap="none"/>
+          <a:lstStyle/>
+          <a:p>
+            <a:pPr algn="ctr"/>
+            <a:r>
+              <a:rPr sz="1600" b="1">
+                <a:solidFill>
+                  <a:srgbClr val="FFFFFF"/>
+                </a:solidFill>
+                <a:latin typeface="Cambria"/>
+              </a:rPr>
               <a:t>3</a:t>
             </a:r>
           </a:p>
@@ -7421,7 +8337,7 @@
 </p:sld>
 </file>
 
-<file path=ppt/slides/slide8.xml><?xml version="1.0" encoding="utf-8"?>
+<file path=ppt/slides/slide9.xml><?xml version="1.0" encoding="utf-8"?>
 <p:sld xmlns:a="http://schemas.openxmlformats.org/drawingml/2006/main" xmlns:p="http://schemas.openxmlformats.org/presentationml/2006/main" xmlns:r="http://schemas.openxmlformats.org/officeDocument/2006/relationships">
   <p:cSld>
     <p:bg>

</xml_diff>

<commit_message>
Deck: hierarchy slide now uses the full 2x2 + observed 16-game data
Slide 5 rebuilt around the four-configuration engine test figure and the
observed 13-3 (+11.8) record with Tatum's usage-up/efficiency-flat line
and the labeled +4.7-7.0 win projection. Counter-evidence slide upgraded
with the sharper findings: Brown's solo-carry cells, the defensive
assignment gap (19% vs 8% on #1 options), and the live-ball turnover
analysis that exonerates him.

Co-Authored-By: Claude Fable 5 <noreply@anthropic.com>
</commit_message>
<xml_diff>
--- a/outputs/Fit_Check_Jaylen_Brown.pptx
+++ b/outputs/Fit_Check_Jaylen_Brown.pptx
@@ -5276,34 +5276,54 @@
                 </a:solidFill>
                 <a:latin typeface="Cambria"/>
               </a:rPr>
-              <a:t>Tatum-led was the best version of the offense — together was the worst</a:t>
-            </a:r>
-          </a:p>
-        </p:txBody>
-      </p:sp>
-      <p:sp>
-        <p:nvSpPr>
-          <p:cNvPr id="4" name="Rounded Rectangle 3"/>
+              <a:t>First-option Tatum beat load-sharing — on the floor and in the standings</a:t>
+            </a:r>
+          </a:p>
+        </p:txBody>
+      </p:sp>
+      <p:pic>
+        <p:nvPicPr>
+          <p:cNvPr id="4" name="Picture 3" descr="tatum_first_option.png"/>
+          <p:cNvPicPr>
+            <a:picLocks noChangeAspect="1"/>
+          </p:cNvPicPr>
+          <p:nvPr/>
+        </p:nvPicPr>
+        <p:blipFill>
+          <a:blip r:embed="rId2"/>
+          <a:stretch>
+            <a:fillRect/>
+          </a:stretch>
+        </p:blipFill>
+        <p:spPr>
+          <a:xfrm>
+            <a:off x="457200" y="1554480"/>
+            <a:ext cx="6766560" cy="2783447"/>
+          </a:xfrm>
+          <a:prstGeom prst="rect">
+            <a:avLst/>
+          </a:prstGeom>
+        </p:spPr>
+      </p:pic>
+      <p:sp>
+        <p:nvSpPr>
+          <p:cNvPr id="5" name="Oval 4"/>
           <p:cNvSpPr/>
           <p:nvPr/>
         </p:nvSpPr>
         <p:spPr>
           <a:xfrm>
-            <a:off x="566928" y="1783080"/>
-            <a:ext cx="3502152" cy="2057400"/>
-          </a:xfrm>
-          <a:prstGeom prst="roundRect">
-            <a:avLst>
-              <a:gd name="adj" fmla="val 8000"/>
-            </a:avLst>
+            <a:off x="7589520" y="1773936"/>
+            <a:ext cx="146304" cy="146304"/>
+          </a:xfrm>
+          <a:prstGeom prst="ellipse">
+            <a:avLst/>
           </a:prstGeom>
           <a:solidFill>
-            <a:srgbClr val="FFFFFF"/>
+            <a:srgbClr val="007A33"/>
           </a:solidFill>
-          <a:ln w="12700">
-            <a:solidFill>
-              <a:srgbClr val="D7DAE0"/>
-            </a:solidFill>
+          <a:ln>
+            <a:noFill/>
           </a:ln>
           <a:effectLst/>
         </p:spPr>
@@ -5331,14 +5351,14 @@
       </p:sp>
       <p:sp>
         <p:nvSpPr>
-          <p:cNvPr id="5" name="TextBox 4"/>
+          <p:cNvPr id="6" name="TextBox 5"/>
           <p:cNvSpPr txBox="1"/>
           <p:nvPr/>
         </p:nvSpPr>
         <p:spPr>
           <a:xfrm>
-            <a:off x="822960" y="1975104"/>
-            <a:ext cx="3044952" cy="822960"/>
+            <a:off x="7882128" y="1737360"/>
+            <a:ext cx="4069080" cy="1143000"/>
           </a:xfrm>
           <a:prstGeom prst="rect">
             <a:avLst/>
@@ -5353,131 +5373,62 @@
           <a:p>
             <a:pPr algn="l">
               <a:lnSpc>
-                <a:spcPct val="100000"/>
-              </a:lnSpc>
-              <a:spcAft>
-                <a:spcPts val="0"/>
-              </a:spcAft>
-            </a:pPr>
-            <a:r>
-              <a:rPr sz="4200" b="1" i="0">
-                <a:solidFill>
-                  <a:srgbClr val="007A33"/>
-                </a:solidFill>
-                <a:latin typeface="Cambria"/>
-              </a:rPr>
-              <a:t>+11.9</a:t>
-            </a:r>
-          </a:p>
-        </p:txBody>
-      </p:sp>
-      <p:sp>
-        <p:nvSpPr>
-          <p:cNvPr id="6" name="TextBox 5"/>
-          <p:cNvSpPr txBox="1"/>
-          <p:nvPr/>
-        </p:nvSpPr>
-        <p:spPr>
-          <a:xfrm>
-            <a:off x="841247" y="2834640"/>
-            <a:ext cx="2999232" cy="365760"/>
-          </a:xfrm>
-          <a:prstGeom prst="rect">
-            <a:avLst/>
-          </a:prstGeom>
-          <a:noFill/>
-        </p:spPr>
-        <p:txBody>
-          <a:bodyPr wrap="square" anchor="t" lIns="0" rIns="0" tIns="0" bIns="0">
-            <a:spAutoFit/>
-          </a:bodyPr>
-          <a:lstStyle/>
-          <a:p>
-            <a:pPr algn="l">
-              <a:lnSpc>
-                <a:spcPct val="100000"/>
-              </a:lnSpc>
-              <a:spcAft>
-                <a:spcPts val="0"/>
-              </a:spcAft>
-            </a:pPr>
-            <a:r>
-              <a:rPr sz="1450" b="1" i="0">
+                <a:spcPct val="106000"/>
+              </a:lnSpc>
+              <a:spcAft>
+                <a:spcPts val="200"/>
+              </a:spcAft>
+            </a:pPr>
+            <a:r>
+              <a:rPr sz="1400" b="1" i="0">
                 <a:solidFill>
                   <a:srgbClr val="0A2A1A"/>
                 </a:solidFill>
                 <a:latin typeface="Calibri"/>
               </a:rPr>
-              <a:t>Tatum-led (Brown off)</a:t>
-            </a:r>
-          </a:p>
-        </p:txBody>
-      </p:sp>
-      <p:sp>
-        <p:nvSpPr>
-          <p:cNvPr id="7" name="TextBox 6"/>
-          <p:cNvSpPr txBox="1"/>
-          <p:nvPr/>
-        </p:nvSpPr>
-        <p:spPr>
-          <a:xfrm>
-            <a:off x="841247" y="3172968"/>
-            <a:ext cx="2999232" cy="365760"/>
-          </a:xfrm>
-          <a:prstGeom prst="rect">
-            <a:avLst/>
-          </a:prstGeom>
-          <a:noFill/>
-        </p:spPr>
-        <p:txBody>
-          <a:bodyPr wrap="square" anchor="t" lIns="0" rIns="0" tIns="0" bIns="0">
-            <a:spAutoFit/>
-          </a:bodyPr>
-          <a:lstStyle/>
-          <a:p>
-            <a:pPr algn="l">
-              <a:lnSpc>
-                <a:spcPct val="100000"/>
-              </a:lnSpc>
-              <a:spcAft>
-                <a:spcPts val="0"/>
-              </a:spcAft>
-            </a:pPr>
-            <a:r>
-              <a:rPr sz="1200" b="0" i="0">
+              <a:t>13-3 (+11.8) when Brown sat</a:t>
+            </a:r>
+          </a:p>
+          <a:p>
+            <a:pPr algn="l">
+              <a:lnSpc>
+                <a:spcPct val="106000"/>
+              </a:lnSpc>
+              <a:spcAft>
+                <a:spcPts val="200"/>
+              </a:spcAft>
+            </a:pPr>
+            <a:r>
+              <a:rPr sz="1220" b="0" i="0">
                 <a:solidFill>
                   <a:srgbClr val="6B7280"/>
                 </a:solidFill>
                 <a:latin typeface="Calibri"/>
               </a:rPr>
-              <a:t>1,212 min · 2024-25</a:t>
-            </a:r>
-          </a:p>
-        </p:txBody>
-      </p:sp>
-      <p:sp>
-        <p:nvSpPr>
-          <p:cNvPr id="8" name="Rounded Rectangle 7"/>
+              <a:t>16 games in 2024-25. Full 2×2: Tatum-led lineups +11.9 &gt; Brown-led +9.8 &gt; together +7.6 &gt; neither +3.5 (control).</a:t>
+            </a:r>
+          </a:p>
+        </p:txBody>
+      </p:sp>
+      <p:sp>
+        <p:nvSpPr>
+          <p:cNvPr id="7" name="Oval 6"/>
           <p:cNvSpPr/>
           <p:nvPr/>
         </p:nvSpPr>
         <p:spPr>
           <a:xfrm>
-            <a:off x="4352544" y="1783080"/>
-            <a:ext cx="3502152" cy="2057400"/>
-          </a:xfrm>
-          <a:prstGeom prst="roundRect">
-            <a:avLst>
-              <a:gd name="adj" fmla="val 8000"/>
-            </a:avLst>
+            <a:off x="7589520" y="3090672"/>
+            <a:ext cx="146304" cy="146304"/>
+          </a:xfrm>
+          <a:prstGeom prst="ellipse">
+            <a:avLst/>
           </a:prstGeom>
           <a:solidFill>
-            <a:srgbClr val="FFFFFF"/>
+            <a:srgbClr val="0A2A1A"/>
           </a:solidFill>
-          <a:ln w="12700">
-            <a:solidFill>
-              <a:srgbClr val="D7DAE0"/>
-            </a:solidFill>
+          <a:ln>
+            <a:noFill/>
           </a:ln>
           <a:effectLst/>
         </p:spPr>
@@ -5505,14 +5456,14 @@
       </p:sp>
       <p:sp>
         <p:nvSpPr>
-          <p:cNvPr id="9" name="TextBox 8"/>
+          <p:cNvPr id="8" name="TextBox 7"/>
           <p:cNvSpPr txBox="1"/>
           <p:nvPr/>
         </p:nvSpPr>
         <p:spPr>
           <a:xfrm>
-            <a:off x="4608576" y="1975104"/>
-            <a:ext cx="3044952" cy="822960"/>
+            <a:off x="7882128" y="3054096"/>
+            <a:ext cx="4069080" cy="1143000"/>
           </a:xfrm>
           <a:prstGeom prst="rect">
             <a:avLst/>
@@ -5527,131 +5478,62 @@
           <a:p>
             <a:pPr algn="l">
               <a:lnSpc>
-                <a:spcPct val="100000"/>
-              </a:lnSpc>
-              <a:spcAft>
-                <a:spcPts val="0"/>
-              </a:spcAft>
-            </a:pPr>
-            <a:r>
-              <a:rPr sz="4200" b="1" i="0">
+                <a:spcPct val="106000"/>
+              </a:lnSpc>
+              <a:spcAft>
+                <a:spcPts val="200"/>
+              </a:spcAft>
+            </a:pPr>
+            <a:r>
+              <a:rPr sz="1400" b="1" i="0">
                 <a:solidFill>
                   <a:srgbClr val="0A2A1A"/>
                 </a:solidFill>
-                <a:latin typeface="Cambria"/>
-              </a:rPr>
-              <a:t>+9.8</a:t>
-            </a:r>
-          </a:p>
-        </p:txBody>
-      </p:sp>
-      <p:sp>
-        <p:nvSpPr>
-          <p:cNvPr id="10" name="TextBox 9"/>
-          <p:cNvSpPr txBox="1"/>
-          <p:nvPr/>
-        </p:nvSpPr>
-        <p:spPr>
-          <a:xfrm>
-            <a:off x="4626864" y="2834640"/>
-            <a:ext cx="2999232" cy="365760"/>
-          </a:xfrm>
-          <a:prstGeom prst="rect">
-            <a:avLst/>
-          </a:prstGeom>
-          <a:noFill/>
-        </p:spPr>
-        <p:txBody>
-          <a:bodyPr wrap="square" anchor="t" lIns="0" rIns="0" tIns="0" bIns="0">
-            <a:spAutoFit/>
-          </a:bodyPr>
-          <a:lstStyle/>
-          <a:p>
-            <a:pPr algn="l">
-              <a:lnSpc>
-                <a:spcPct val="100000"/>
-              </a:lnSpc>
-              <a:spcAft>
-                <a:spcPts val="0"/>
-              </a:spcAft>
-            </a:pPr>
-            <a:r>
-              <a:rPr sz="1450" b="1" i="0">
-                <a:solidFill>
-                  <a:srgbClr val="0A2A1A"/>
-                </a:solidFill>
-                <a:latin typeface="Calibri"/>
-              </a:rPr>
-              <a:t>Brown-led (Tatum off)</a:t>
-            </a:r>
-          </a:p>
-        </p:txBody>
-      </p:sp>
-      <p:sp>
-        <p:nvSpPr>
-          <p:cNvPr id="11" name="TextBox 10"/>
-          <p:cNvSpPr txBox="1"/>
-          <p:nvPr/>
-        </p:nvSpPr>
-        <p:spPr>
-          <a:xfrm>
-            <a:off x="4626864" y="3172968"/>
-            <a:ext cx="2999232" cy="365760"/>
-          </a:xfrm>
-          <a:prstGeom prst="rect">
-            <a:avLst/>
-          </a:prstGeom>
-          <a:noFill/>
-        </p:spPr>
-        <p:txBody>
-          <a:bodyPr wrap="square" anchor="t" lIns="0" rIns="0" tIns="0" bIns="0">
-            <a:spAutoFit/>
-          </a:bodyPr>
-          <a:lstStyle/>
-          <a:p>
-            <a:pPr algn="l">
-              <a:lnSpc>
-                <a:spcPct val="100000"/>
-              </a:lnSpc>
-              <a:spcAft>
-                <a:spcPts val="0"/>
-              </a:spcAft>
-            </a:pPr>
-            <a:r>
-              <a:rPr sz="1200" b="0" i="0">
+                <a:latin typeface="Calibri"/>
+              </a:rPr>
+              <a:t>Usage up, efficiency flat</a:t>
+            </a:r>
+          </a:p>
+          <a:p>
+            <a:pPr algn="l">
+              <a:lnSpc>
+                <a:spcPct val="106000"/>
+              </a:lnSpc>
+              <a:spcAft>
+                <a:spcPts val="200"/>
+              </a:spcAft>
+            </a:pPr>
+            <a:r>
+              <a:rPr sz="1220" b="0" i="0">
                 <a:solidFill>
                   <a:srgbClr val="6B7280"/>
                 </a:solidFill>
                 <a:latin typeface="Calibri"/>
               </a:rPr>
-              <a:t>753 min · 2024-25</a:t>
-            </a:r>
-          </a:p>
-        </p:txBody>
-      </p:sp>
-      <p:sp>
-        <p:nvSpPr>
-          <p:cNvPr id="12" name="Rounded Rectangle 11"/>
+              <a:t>Tatum without Brown: 28.8 pts / 7.8 reb on .584 TS at 34.5% usage — he absorbed +4.1 usage points and lost nothing.</a:t>
+            </a:r>
+          </a:p>
+        </p:txBody>
+      </p:sp>
+      <p:sp>
+        <p:nvSpPr>
+          <p:cNvPr id="9" name="Oval 8"/>
           <p:cNvSpPr/>
           <p:nvPr/>
         </p:nvSpPr>
         <p:spPr>
           <a:xfrm>
-            <a:off x="8138159" y="1783080"/>
-            <a:ext cx="3502152" cy="2057400"/>
-          </a:xfrm>
-          <a:prstGeom prst="roundRect">
-            <a:avLst>
-              <a:gd name="adj" fmla="val 8000"/>
-            </a:avLst>
+            <a:off x="7589520" y="4407407"/>
+            <a:ext cx="146304" cy="146304"/>
+          </a:xfrm>
+          <a:prstGeom prst="ellipse">
+            <a:avLst/>
           </a:prstGeom>
           <a:solidFill>
-            <a:srgbClr val="FFFFFF"/>
+            <a:srgbClr val="BA9653"/>
           </a:solidFill>
-          <a:ln w="12700">
-            <a:solidFill>
-              <a:srgbClr val="D7DAE0"/>
-            </a:solidFill>
+          <a:ln>
+            <a:noFill/>
           </a:ln>
           <a:effectLst/>
         </p:spPr>
@@ -5679,14 +5561,14 @@
       </p:sp>
       <p:sp>
         <p:nvSpPr>
-          <p:cNvPr id="13" name="TextBox 12"/>
+          <p:cNvPr id="10" name="TextBox 9"/>
           <p:cNvSpPr txBox="1"/>
           <p:nvPr/>
         </p:nvSpPr>
         <p:spPr>
           <a:xfrm>
-            <a:off x="8394191" y="1975104"/>
-            <a:ext cx="3044952" cy="822960"/>
+            <a:off x="7882128" y="4370831"/>
+            <a:ext cx="4069080" cy="1143000"/>
           </a:xfrm>
           <a:prstGeom prst="rect">
             <a:avLst/>
@@ -5701,34 +5583,53 @@
           <a:p>
             <a:pPr algn="l">
               <a:lnSpc>
-                <a:spcPct val="100000"/>
-              </a:lnSpc>
-              <a:spcAft>
-                <a:spcPts val="0"/>
-              </a:spcAft>
-            </a:pPr>
-            <a:r>
-              <a:rPr sz="4200" b="1" i="0">
-                <a:solidFill>
-                  <a:srgbClr val="B3403A"/>
-                </a:solidFill>
-                <a:latin typeface="Cambria"/>
-              </a:rPr>
-              <a:t>+7.6</a:t>
-            </a:r>
-          </a:p>
-        </p:txBody>
-      </p:sp>
-      <p:sp>
-        <p:nvSpPr>
-          <p:cNvPr id="14" name="TextBox 13"/>
+                <a:spcPct val="106000"/>
+              </a:lnSpc>
+              <a:spcAft>
+                <a:spcPts val="200"/>
+              </a:spcAft>
+            </a:pPr>
+            <a:r>
+              <a:rPr sz="1400" b="1" i="0">
+                <a:solidFill>
+                  <a:srgbClr val="0A2A1A"/>
+                </a:solidFill>
+                <a:latin typeface="Calibri"/>
+              </a:rPr>
+              <a:t>Worth ~5-7 wins a season</a:t>
+            </a:r>
+          </a:p>
+          <a:p>
+            <a:pPr algn="l">
+              <a:lnSpc>
+                <a:spcPct val="106000"/>
+              </a:lnSpc>
+              <a:spcAft>
+                <a:spcPts val="200"/>
+              </a:spcAft>
+            </a:pPr>
+            <a:r>
+              <a:rPr sz="1220" b="0" i="0">
+                <a:solidFill>
+                  <a:srgbClr val="6B7280"/>
+                </a:solidFill>
+                <a:latin typeface="Calibri"/>
+              </a:rPr>
+              <a:t>Projection, not observation: the +4.3 lineup gap, shrunk 40-60% for bench/garbage contamination → +1.7-2.6 team net → +4.7-7.0 wins. Assumptions documented in the memo.</a:t>
+            </a:r>
+          </a:p>
+        </p:txBody>
+      </p:sp>
+      <p:sp>
+        <p:nvSpPr>
+          <p:cNvPr id="11" name="TextBox 10"/>
           <p:cNvSpPr txBox="1"/>
           <p:nvPr/>
         </p:nvSpPr>
         <p:spPr>
           <a:xfrm>
-            <a:off x="8412480" y="2834640"/>
-            <a:ext cx="2999232" cy="365760"/>
+            <a:off x="566928" y="4617720"/>
+            <a:ext cx="6766560" cy="1188720"/>
           </a:xfrm>
           <a:prstGeom prst="rect">
             <a:avLst/>
@@ -5743,34 +5644,52 @@
           <a:p>
             <a:pPr algn="l">
               <a:lnSpc>
-                <a:spcPct val="100000"/>
-              </a:lnSpc>
-              <a:spcAft>
-                <a:spcPts val="0"/>
-              </a:spcAft>
-            </a:pPr>
-            <a:r>
-              <a:rPr sz="1450" b="1" i="0">
-                <a:solidFill>
-                  <a:srgbClr val="0A2A1A"/>
-                </a:solidFill>
-                <a:latin typeface="Calibri"/>
-              </a:rPr>
-              <a:t>the two together</a:t>
-            </a:r>
-          </a:p>
-        </p:txBody>
-      </p:sp>
-      <p:sp>
-        <p:nvSpPr>
-          <p:cNvPr id="15" name="TextBox 14"/>
+                <a:spcPct val="112000"/>
+              </a:lnSpc>
+              <a:spcAft>
+                <a:spcPts val="400"/>
+              </a:spcAft>
+            </a:pPr>
+            <a:r>
+              <a:rPr sz="1300" b="0" i="0">
+                <a:solidFill>
+                  <a:srgbClr val="20232A"/>
+                </a:solidFill>
+                <a:latin typeface="Calibri"/>
+              </a:rPr>
+              <a:t>Tatum's projected solo season: </a:t>
+            </a:r>
+            <a:r>
+              <a:rPr sz="1300" b="1" i="0">
+                <a:solidFill>
+                  <a:srgbClr val="007A33"/>
+                </a:solidFill>
+                <a:latin typeface="Calibri"/>
+              </a:rPr>
+              <a:t>27.2-28.8 pts · 7.8-8.9 reb · 5.1-6.2 ast · .566-.584 TS </a:t>
+            </a:r>
+            <a:r>
+              <a:rPr sz="1300" b="0" i="0">
+                <a:solidFill>
+                  <a:srgbClr val="6B7280"/>
+                </a:solidFill>
+                <a:latin typeface="Calibri"/>
+              </a:rPr>
+              <a:t>— stated as a range from the observed 16-game sample and a documented usage-tradeoff model, because false precision is how decks lie.</a:t>
+            </a:r>
+          </a:p>
+        </p:txBody>
+      </p:sp>
+      <p:sp>
+        <p:nvSpPr>
+          <p:cNvPr id="12" name="TextBox 11"/>
           <p:cNvSpPr txBox="1"/>
           <p:nvPr/>
         </p:nvSpPr>
         <p:spPr>
           <a:xfrm>
-            <a:off x="8412480" y="3172968"/>
-            <a:ext cx="2999232" cy="365760"/>
+            <a:off x="566928" y="5989320"/>
+            <a:ext cx="11064240" cy="411480"/>
           </a:xfrm>
           <a:prstGeom prst="rect">
             <a:avLst/>
@@ -5785,259 +5704,27 @@
           <a:p>
             <a:pPr algn="l">
               <a:lnSpc>
-                <a:spcPct val="100000"/>
-              </a:lnSpc>
-              <a:spcAft>
-                <a:spcPts val="0"/>
-              </a:spcAft>
-            </a:pPr>
-            <a:r>
-              <a:rPr sz="1200" b="0" i="0">
+                <a:spcPct val="105000"/>
+              </a:lnSpc>
+              <a:spcAft>
+                <a:spcPts val="400"/>
+              </a:spcAft>
+            </a:pPr>
+            <a:r>
+              <a:rPr sz="1150" b="0" i="1">
                 <a:solidFill>
                   <a:srgbClr val="6B7280"/>
                 </a:solidFill>
                 <a:latin typeface="Calibri"/>
               </a:rPr>
-              <a:t>1,411 min · 2024-25</a:t>
-            </a:r>
-          </a:p>
-        </p:txBody>
-      </p:sp>
-      <p:sp>
-        <p:nvSpPr>
-          <p:cNvPr id="16" name="TextBox 15"/>
-          <p:cNvSpPr txBox="1"/>
-          <p:nvPr/>
-        </p:nvSpPr>
-        <p:spPr>
-          <a:xfrm>
-            <a:off x="566928" y="4160520"/>
-            <a:ext cx="11064240" cy="365760"/>
-          </a:xfrm>
-          <a:prstGeom prst="rect">
-            <a:avLst/>
-          </a:prstGeom>
-          <a:noFill/>
-        </p:spPr>
-        <p:txBody>
-          <a:bodyPr wrap="square" anchor="t" lIns="0" rIns="0" tIns="0" bIns="0">
-            <a:spAutoFit/>
-          </a:bodyPr>
-          <a:lstStyle/>
-          <a:p>
-            <a:pPr algn="l">
-              <a:lnSpc>
-                <a:spcPct val="100000"/>
-              </a:lnSpc>
-              <a:spcAft>
-                <a:spcPts val="0"/>
-              </a:spcAft>
-            </a:pPr>
-            <a:r>
-              <a:rPr sz="1350" b="1" i="0">
-                <a:solidFill>
-                  <a:srgbClr val="0A2A1A"/>
-                </a:solidFill>
-                <a:latin typeface="Calibri"/>
-              </a:rPr>
-              <a:t>Net rating of five-man lineups, the healthy season — first-option basketball beat load-sharing.</a:t>
-            </a:r>
-          </a:p>
-        </p:txBody>
-      </p:sp>
-      <p:sp>
-        <p:nvSpPr>
-          <p:cNvPr id="17" name="Oval 16"/>
-          <p:cNvSpPr/>
-          <p:nvPr/>
-        </p:nvSpPr>
-        <p:spPr>
-          <a:xfrm>
-            <a:off x="640080" y="4745736"/>
-            <a:ext cx="146304" cy="146304"/>
-          </a:xfrm>
-          <a:prstGeom prst="ellipse">
-            <a:avLst/>
-          </a:prstGeom>
-          <a:solidFill>
-            <a:srgbClr val="007A33"/>
-          </a:solidFill>
-          <a:ln>
-            <a:noFill/>
-          </a:ln>
-          <a:effectLst/>
-        </p:spPr>
-        <p:style>
-          <a:lnRef idx="1">
-            <a:schemeClr val="accent1"/>
-          </a:lnRef>
-          <a:fillRef idx="3">
-            <a:schemeClr val="accent1"/>
-          </a:fillRef>
-          <a:effectRef idx="2">
-            <a:schemeClr val="accent1"/>
-          </a:effectRef>
-          <a:fontRef idx="minor">
-            <a:schemeClr val="lt1"/>
-          </a:fontRef>
-        </p:style>
-        <p:txBody>
-          <a:bodyPr rtlCol="0" anchor="ctr"/>
-          <a:lstStyle/>
-          <a:p>
-            <a:pPr algn="ctr"/>
-          </a:p>
-        </p:txBody>
-      </p:sp>
-      <p:sp>
-        <p:nvSpPr>
-          <p:cNvPr id="18" name="TextBox 17"/>
-          <p:cNvSpPr txBox="1"/>
-          <p:nvPr/>
-        </p:nvSpPr>
-        <p:spPr>
-          <a:xfrm>
-            <a:off x="932688" y="4709160"/>
-            <a:ext cx="10607040" cy="777240"/>
-          </a:xfrm>
-          <a:prstGeom prst="rect">
-            <a:avLst/>
-          </a:prstGeom>
-          <a:noFill/>
-        </p:spPr>
-        <p:txBody>
-          <a:bodyPr wrap="square" anchor="t" lIns="0" rIns="0" tIns="0" bIns="0">
-            <a:spAutoFit/>
-          </a:bodyPr>
-          <a:lstStyle/>
-          <a:p>
-            <a:pPr algn="l">
-              <a:lnSpc>
-                <a:spcPct val="108000"/>
-              </a:lnSpc>
-              <a:spcAft>
-                <a:spcPts val="200"/>
-              </a:spcAft>
-            </a:pPr>
-            <a:r>
-              <a:rPr sz="1350" b="1" i="0">
-                <a:solidFill>
-                  <a:srgbClr val="0A2A1A"/>
-                </a:solidFill>
-                <a:latin typeface="Calibri"/>
-              </a:rPr>
-              <a:t>Tatum's diet IS the system  </a:t>
-            </a:r>
-            <a:r>
-              <a:rPr sz="1250" b="0" i="0">
-                <a:solidFill>
-                  <a:srgbClr val="6B7280"/>
-                </a:solidFill>
-                <a:latin typeface="Calibri"/>
-              </a:rPr>
-              <a:t>Half his shots are threes (0.498 vs Brown's 0.262) and his long-two rate is 0.059 vs Brown's 0.142. His self-creation terminates in the anchor shot; Brown's terminated in the shot the system avoids.</a:t>
-            </a:r>
-          </a:p>
-        </p:txBody>
-      </p:sp>
-      <p:sp>
-        <p:nvSpPr>
-          <p:cNvPr id="19" name="Oval 18"/>
-          <p:cNvSpPr/>
-          <p:nvPr/>
-        </p:nvSpPr>
-        <p:spPr>
-          <a:xfrm>
-            <a:off x="640080" y="5586984"/>
-            <a:ext cx="146304" cy="146304"/>
-          </a:xfrm>
-          <a:prstGeom prst="ellipse">
-            <a:avLst/>
-          </a:prstGeom>
-          <a:solidFill>
-            <a:srgbClr val="BA9653"/>
-          </a:solidFill>
-          <a:ln>
-            <a:noFill/>
-          </a:ln>
-          <a:effectLst/>
-        </p:spPr>
-        <p:style>
-          <a:lnRef idx="1">
-            <a:schemeClr val="accent1"/>
-          </a:lnRef>
-          <a:fillRef idx="3">
-            <a:schemeClr val="accent1"/>
-          </a:fillRef>
-          <a:effectRef idx="2">
-            <a:schemeClr val="accent1"/>
-          </a:effectRef>
-          <a:fontRef idx="minor">
-            <a:schemeClr val="lt1"/>
-          </a:fontRef>
-        </p:style>
-        <p:txBody>
-          <a:bodyPr rtlCol="0" anchor="ctr"/>
-          <a:lstStyle/>
-          <a:p>
-            <a:pPr algn="ctr"/>
-          </a:p>
-        </p:txBody>
-      </p:sp>
-      <p:sp>
-        <p:nvSpPr>
-          <p:cNvPr id="20" name="TextBox 19"/>
-          <p:cNvSpPr txBox="1"/>
-          <p:nvPr/>
-        </p:nvSpPr>
-        <p:spPr>
-          <a:xfrm>
-            <a:off x="932688" y="5550408"/>
-            <a:ext cx="10607040" cy="777240"/>
-          </a:xfrm>
-          <a:prstGeom prst="rect">
-            <a:avLst/>
-          </a:prstGeom>
-          <a:noFill/>
-        </p:spPr>
-        <p:txBody>
-          <a:bodyPr wrap="square" anchor="t" lIns="0" rIns="0" tIns="0" bIns="0">
-            <a:spAutoFit/>
-          </a:bodyPr>
-          <a:lstStyle/>
-          <a:p>
-            <a:pPr algn="l">
-              <a:lnSpc>
-                <a:spcPct val="108000"/>
-              </a:lnSpc>
-              <a:spcAft>
-                <a:spcPts val="200"/>
-              </a:spcAft>
-            </a:pPr>
-            <a:r>
-              <a:rPr sz="1350" b="1" i="0">
-                <a:solidFill>
-                  <a:srgbClr val="0A2A1A"/>
-                </a:solidFill>
-                <a:latin typeface="Calibri"/>
-              </a:rPr>
-              <a:t>Read the caveats before quoting  </a:t>
-            </a:r>
-            <a:r>
-              <a:rPr sz="1250" b="0" i="0">
-                <a:solidFill>
-                  <a:srgbClr val="6B7280"/>
-                </a:solidFill>
-                <a:latin typeface="Calibri"/>
-              </a:rPr>
-              <a:t>'Led' minutes include bench-heavy and garbage-time units, and 2025-26 is an injury-season shard (204 Tatum-led minutes). The 2024-25 comparison is the clean one — and it still favors the hierarchy.</a:t>
-            </a:r>
-          </a:p>
-        </p:txBody>
-      </p:sp>
-      <p:sp>
-        <p:nvSpPr>
-          <p:cNvPr id="21" name="TextBox 20"/>
+              <a:t>Honesty flag: Brown's own 7-game solo cell was the best in the matrix (6-1, +15.8) — small sample, printed anyway. See slide 8.</a:t>
+            </a:r>
+          </a:p>
+        </p:txBody>
+      </p:sp>
+      <p:sp>
+        <p:nvSpPr>
+          <p:cNvPr id="13" name="TextBox 12"/>
           <p:cNvSpPr txBox="1"/>
           <p:nvPr/>
         </p:nvSpPr>
@@ -7810,7 +7497,7 @@
                 </a:solidFill>
                 <a:latin typeface="Cambria"/>
               </a:rPr>
-              <a:t>The Tatum confound</a:t>
+              <a:t>Brown could carry</a:t>
             </a:r>
           </a:p>
         </p:txBody>
@@ -7852,7 +7539,7 @@
                 </a:solidFill>
                 <a:latin typeface="Calibri"/>
               </a:rPr>
-              <a:t>The 2025-26 with/without splits are contaminated by Tatum's injury absence. The direction survives; the magnitude is uncertain.</a:t>
+              <a:t>His 7-game solo cell was the best in the 2024-25 matrix (6-1, +15.8), and he carried 58 games alone in 2025-26 at 28.9 ppg (36-22, +5.7). The man can be a first option — just not here.</a:t>
             </a:r>
           </a:p>
         </p:txBody>
@@ -7995,7 +7682,7 @@
                 </a:solidFill>
                 <a:latin typeface="Cambria"/>
               </a:rPr>
-              <a:t>Win Shares are blunt</a:t>
+              <a:t>The defense is a real loss</a:t>
             </a:r>
           </a:p>
         </p:txBody>
@@ -8037,7 +7724,7 @@
                 </a:solidFill>
                 <a:latin typeface="Calibri"/>
               </a:rPr>
-              <a:t>Cost-per-WS is a crude value metric — it's used because it spans both seasons and the full comp cohort, not because it's perfect.</a:t>
+              <a:t>Brown took 19% of his defended possessions against opponents' #1 options (Tatum: 8%) at better points-allowed, with -4.2/-5.7 defended-FG% margins. Boston traded its toughest assignment.</a:t>
             </a:r>
           </a:p>
         </p:txBody>
@@ -8180,7 +7867,7 @@
                 </a:solidFill>
                 <a:latin typeface="Cambria"/>
               </a:rPr>
-              <a:t>The market disagrees</a:t>
+              <a:t>The turnover tax wasn't his</a:t>
             </a:r>
           </a:p>
         </p:txBody>
@@ -8222,7 +7909,7 @@
                 </a:solidFill>
                 <a:latin typeface="Calibri"/>
               </a:rPr>
-              <a:t>Media consensus graded the real trade for Philadelphia. Raw production loss is real; this deck argues fit and optionality, and says so openly.</a:t>
+              <a:t>Play-by-play says Brown's live-ball TO rate (1.75/36) was LOWER than Tatum's (1.84) in 2024-25. That angle exonerates him — and the media consensus graded the trade for Philadelphia.</a:t>
             </a:r>
           </a:p>
         </p:txBody>

</xml_diff>

<commit_message>
Deck: add three-point identity slide, update hierarchy with pooled 2023-present data
New game-plan slide: Boston #1/#1/#4 in 3PA volume with top-2 offense,
Brown last of 7 perimeter players in 3PT rate and first in long twos,
and the honestly-priced diet-swap wash. Hierarchy slide now carries the
pooled 25-4 (86.2%, +13.3) sample including 10-0 in the title year, the
TS .593->.572 usage-cost correction, and the Wilson-overlap honesty flag.
10 slides.

Co-Authored-By: Claude Fable 5 <noreply@anthropic.com>
</commit_message>
<xml_diff>
--- a/outputs/Fit_Check_Jaylen_Brown.pptx
+++ b/outputs/Fit_Check_Jaylen_Brown.pptx
@@ -14,6 +14,7 @@
     <p:sldId id="262" r:id="rId13"/>
     <p:sldId id="263" r:id="rId14"/>
     <p:sldId id="264" r:id="rId15"/>
+    <p:sldId id="265" r:id="rId16"/>
   </p:sldIdLst>
   <p:sldSz cx="12191695" cy="6858000" type="screen4x3"/>
   <p:notesSz cx="6858000" cy="9144000"/>
@@ -3343,6 +3344,454 @@
 </p:sld>
 </file>
 
+<file path=ppt/slides/slide10.xml><?xml version="1.0" encoding="utf-8"?>
+<p:sld xmlns:a="http://schemas.openxmlformats.org/drawingml/2006/main" xmlns:p="http://schemas.openxmlformats.org/presentationml/2006/main" xmlns:r="http://schemas.openxmlformats.org/officeDocument/2006/relationships">
+  <p:cSld>
+    <p:bg>
+      <p:bgPr>
+        <a:solidFill>
+          <a:srgbClr val="0A2A1A"/>
+        </a:solidFill>
+        <a:effectLst/>
+      </p:bgPr>
+    </p:bg>
+    <p:spTree>
+      <p:nvGrpSpPr>
+        <p:cNvPr id="1" name=""/>
+        <p:cNvGrpSpPr/>
+        <p:nvPr/>
+      </p:nvGrpSpPr>
+      <p:grpSpPr/>
+      <p:sp>
+        <p:nvSpPr>
+          <p:cNvPr id="2" name="Oval 1"/>
+          <p:cNvSpPr/>
+          <p:nvPr/>
+        </p:nvSpPr>
+        <p:spPr>
+          <a:xfrm>
+            <a:off x="566928" y="640080"/>
+            <a:ext cx="310896" cy="310896"/>
+          </a:xfrm>
+          <a:prstGeom prst="ellipse">
+            <a:avLst/>
+          </a:prstGeom>
+          <a:solidFill>
+            <a:srgbClr val="BA9653"/>
+          </a:solidFill>
+          <a:ln>
+            <a:noFill/>
+          </a:ln>
+          <a:effectLst/>
+        </p:spPr>
+        <p:style>
+          <a:lnRef idx="1">
+            <a:schemeClr val="accent1"/>
+          </a:lnRef>
+          <a:fillRef idx="3">
+            <a:schemeClr val="accent1"/>
+          </a:fillRef>
+          <a:effectRef idx="2">
+            <a:schemeClr val="accent1"/>
+          </a:effectRef>
+          <a:fontRef idx="minor">
+            <a:schemeClr val="lt1"/>
+          </a:fontRef>
+        </p:style>
+        <p:txBody>
+          <a:bodyPr rtlCol="0" anchor="ctr"/>
+          <a:lstStyle/>
+          <a:p>
+            <a:pPr algn="ctr"/>
+          </a:p>
+        </p:txBody>
+      </p:sp>
+      <p:sp>
+        <p:nvSpPr>
+          <p:cNvPr id="3" name="TextBox 2"/>
+          <p:cNvSpPr txBox="1"/>
+          <p:nvPr/>
+        </p:nvSpPr>
+        <p:spPr>
+          <a:xfrm>
+            <a:off x="960120" y="621792"/>
+            <a:ext cx="9144000" cy="365760"/>
+          </a:xfrm>
+          <a:prstGeom prst="rect">
+            <a:avLst/>
+          </a:prstGeom>
+          <a:noFill/>
+        </p:spPr>
+        <p:txBody>
+          <a:bodyPr wrap="square" anchor="t" lIns="0" rIns="0" tIns="0" bIns="0">
+            <a:spAutoFit/>
+          </a:bodyPr>
+          <a:lstStyle/>
+          <a:p>
+            <a:pPr algn="l">
+              <a:lnSpc>
+                <a:spcPct val="100000"/>
+              </a:lnSpc>
+              <a:spcAft>
+                <a:spcPts val="0"/>
+              </a:spcAft>
+            </a:pPr>
+            <a:r>
+              <a:rPr sz="1300" b="1" i="0">
+                <a:solidFill>
+                  <a:srgbClr val="BCD3C6"/>
+                </a:solidFill>
+                <a:latin typeface="Calibri"/>
+              </a:rPr>
+              <a:t>BOTTOM LINE</a:t>
+            </a:r>
+          </a:p>
+        </p:txBody>
+      </p:sp>
+      <p:sp>
+        <p:nvSpPr>
+          <p:cNvPr id="4" name="Oval 3"/>
+          <p:cNvSpPr/>
+          <p:nvPr/>
+        </p:nvSpPr>
+        <p:spPr>
+          <a:xfrm>
+            <a:off x="640080" y="1837943"/>
+            <a:ext cx="164592" cy="164592"/>
+          </a:xfrm>
+          <a:prstGeom prst="ellipse">
+            <a:avLst/>
+          </a:prstGeom>
+          <a:solidFill>
+            <a:srgbClr val="BA9653"/>
+          </a:solidFill>
+          <a:ln>
+            <a:noFill/>
+          </a:ln>
+          <a:effectLst/>
+        </p:spPr>
+        <p:style>
+          <a:lnRef idx="1">
+            <a:schemeClr val="accent1"/>
+          </a:lnRef>
+          <a:fillRef idx="3">
+            <a:schemeClr val="accent1"/>
+          </a:fillRef>
+          <a:effectRef idx="2">
+            <a:schemeClr val="accent1"/>
+          </a:effectRef>
+          <a:fontRef idx="minor">
+            <a:schemeClr val="lt1"/>
+          </a:fontRef>
+        </p:style>
+        <p:txBody>
+          <a:bodyPr rtlCol="0" anchor="ctr"/>
+          <a:lstStyle/>
+          <a:p>
+            <a:pPr algn="ctr"/>
+          </a:p>
+        </p:txBody>
+      </p:sp>
+      <p:sp>
+        <p:nvSpPr>
+          <p:cNvPr id="5" name="TextBox 4"/>
+          <p:cNvSpPr txBox="1"/>
+          <p:nvPr/>
+        </p:nvSpPr>
+        <p:spPr>
+          <a:xfrm>
+            <a:off x="960120" y="1783080"/>
+            <a:ext cx="10424160" cy="914400"/>
+          </a:xfrm>
+          <a:prstGeom prst="rect">
+            <a:avLst/>
+          </a:prstGeom>
+          <a:noFill/>
+        </p:spPr>
+        <p:txBody>
+          <a:bodyPr wrap="square" anchor="t" lIns="0" rIns="0" tIns="0" bIns="0">
+            <a:spAutoFit/>
+          </a:bodyPr>
+          <a:lstStyle/>
+          <a:p>
+            <a:pPr algn="l">
+              <a:lnSpc>
+                <a:spcPct val="110000"/>
+              </a:lnSpc>
+              <a:spcAft>
+                <a:spcPts val="200"/>
+              </a:spcAft>
+            </a:pPr>
+            <a:r>
+              <a:rPr sz="2100" b="1" i="0">
+                <a:solidFill>
+                  <a:srgbClr val="FFFFFF"/>
+                </a:solidFill>
+                <a:latin typeface="Cambria"/>
+              </a:rPr>
+              <a:t>The fit was real and it was drifting.  </a:t>
+            </a:r>
+            <a:r>
+              <a:rPr sz="1500" b="0" i="0">
+                <a:solidFill>
+                  <a:srgbClr val="CFE0D6"/>
+                </a:solidFill>
+                <a:latin typeface="Calibri"/>
+              </a:rPr>
+              <a:t>Fewer threes, doubled long twos, two-thirds self-created — with no shot-making premium to pay for it.</a:t>
+            </a:r>
+          </a:p>
+        </p:txBody>
+      </p:sp>
+      <p:sp>
+        <p:nvSpPr>
+          <p:cNvPr id="6" name="Oval 5"/>
+          <p:cNvSpPr/>
+          <p:nvPr/>
+        </p:nvSpPr>
+        <p:spPr>
+          <a:xfrm>
+            <a:off x="640080" y="3072384"/>
+            <a:ext cx="164592" cy="164592"/>
+          </a:xfrm>
+          <a:prstGeom prst="ellipse">
+            <a:avLst/>
+          </a:prstGeom>
+          <a:solidFill>
+            <a:srgbClr val="BA9653"/>
+          </a:solidFill>
+          <a:ln>
+            <a:noFill/>
+          </a:ln>
+          <a:effectLst/>
+        </p:spPr>
+        <p:style>
+          <a:lnRef idx="1">
+            <a:schemeClr val="accent1"/>
+          </a:lnRef>
+          <a:fillRef idx="3">
+            <a:schemeClr val="accent1"/>
+          </a:fillRef>
+          <a:effectRef idx="2">
+            <a:schemeClr val="accent1"/>
+          </a:effectRef>
+          <a:fontRef idx="minor">
+            <a:schemeClr val="lt1"/>
+          </a:fontRef>
+        </p:style>
+        <p:txBody>
+          <a:bodyPr rtlCol="0" anchor="ctr"/>
+          <a:lstStyle/>
+          <a:p>
+            <a:pPr algn="ctr"/>
+          </a:p>
+        </p:txBody>
+      </p:sp>
+      <p:sp>
+        <p:nvSpPr>
+          <p:cNvPr id="7" name="TextBox 6"/>
+          <p:cNvSpPr txBox="1"/>
+          <p:nvPr/>
+        </p:nvSpPr>
+        <p:spPr>
+          <a:xfrm>
+            <a:off x="960120" y="3017520"/>
+            <a:ext cx="10424160" cy="914400"/>
+          </a:xfrm>
+          <a:prstGeom prst="rect">
+            <a:avLst/>
+          </a:prstGeom>
+          <a:noFill/>
+        </p:spPr>
+        <p:txBody>
+          <a:bodyPr wrap="square" anchor="t" lIns="0" rIns="0" tIns="0" bIns="0">
+            <a:spAutoFit/>
+          </a:bodyPr>
+          <a:lstStyle/>
+          <a:p>
+            <a:pPr algn="l">
+              <a:lnSpc>
+                <a:spcPct val="110000"/>
+              </a:lnSpc>
+              <a:spcAft>
+                <a:spcPts val="200"/>
+              </a:spcAft>
+            </a:pPr>
+            <a:r>
+              <a:rPr sz="2100" b="1" i="0">
+                <a:solidFill>
+                  <a:srgbClr val="FFFFFF"/>
+                </a:solidFill>
+                <a:latin typeface="Cambria"/>
+              </a:rPr>
+              <a:t>The value was contingent.  </a:t>
+            </a:r>
+            <a:r>
+              <a:rPr sz="1500" b="0" i="0">
+                <a:solidFill>
+                  <a:srgbClr val="CFE0D6"/>
+                </a:solidFill>
+                <a:latin typeface="Calibri"/>
+              </a:rPr>
+              <a:t>Brown-led lineups needed Tatum and White on the floor; at 34% of the cap, contingent is expensive.</a:t>
+            </a:r>
+          </a:p>
+        </p:txBody>
+      </p:sp>
+      <p:sp>
+        <p:nvSpPr>
+          <p:cNvPr id="8" name="Oval 7"/>
+          <p:cNvSpPr/>
+          <p:nvPr/>
+        </p:nvSpPr>
+        <p:spPr>
+          <a:xfrm>
+            <a:off x="640080" y="4306824"/>
+            <a:ext cx="164592" cy="164592"/>
+          </a:xfrm>
+          <a:prstGeom prst="ellipse">
+            <a:avLst/>
+          </a:prstGeom>
+          <a:solidFill>
+            <a:srgbClr val="BA9653"/>
+          </a:solidFill>
+          <a:ln>
+            <a:noFill/>
+          </a:ln>
+          <a:effectLst/>
+        </p:spPr>
+        <p:style>
+          <a:lnRef idx="1">
+            <a:schemeClr val="accent1"/>
+          </a:lnRef>
+          <a:fillRef idx="3">
+            <a:schemeClr val="accent1"/>
+          </a:fillRef>
+          <a:effectRef idx="2">
+            <a:schemeClr val="accent1"/>
+          </a:effectRef>
+          <a:fontRef idx="minor">
+            <a:schemeClr val="lt1"/>
+          </a:fontRef>
+        </p:style>
+        <p:txBody>
+          <a:bodyPr rtlCol="0" anchor="ctr"/>
+          <a:lstStyle/>
+          <a:p>
+            <a:pPr algn="ctr"/>
+          </a:p>
+        </p:txBody>
+      </p:sp>
+      <p:sp>
+        <p:nvSpPr>
+          <p:cNvPr id="9" name="TextBox 8"/>
+          <p:cNvSpPr txBox="1"/>
+          <p:nvPr/>
+        </p:nvSpPr>
+        <p:spPr>
+          <a:xfrm>
+            <a:off x="960120" y="4251960"/>
+            <a:ext cx="10424160" cy="914400"/>
+          </a:xfrm>
+          <a:prstGeom prst="rect">
+            <a:avLst/>
+          </a:prstGeom>
+          <a:noFill/>
+        </p:spPr>
+        <p:txBody>
+          <a:bodyPr wrap="square" anchor="t" lIns="0" rIns="0" tIns="0" bIns="0">
+            <a:spAutoFit/>
+          </a:bodyPr>
+          <a:lstStyle/>
+          <a:p>
+            <a:pPr algn="l">
+              <a:lnSpc>
+                <a:spcPct val="110000"/>
+              </a:lnSpc>
+              <a:spcAft>
+                <a:spcPts val="200"/>
+              </a:spcAft>
+            </a:pPr>
+            <a:r>
+              <a:rPr sz="2100" b="1" i="0">
+                <a:solidFill>
+                  <a:srgbClr val="FFFFFF"/>
+                </a:solidFill>
+                <a:latin typeface="Cambria"/>
+              </a:rPr>
+              <a:t>The return buys identity and optionality.  </a:t>
+            </a:r>
+            <a:r>
+              <a:rPr sz="1500" b="0" i="0">
+                <a:solidFill>
+                  <a:srgbClr val="CFE0D6"/>
+                </a:solidFill>
+                <a:latin typeface="Calibri"/>
+              </a:rPr>
+              <a:t>George takes the system's shots; two firsts add the cheap, controllable assets a capped roster can't otherwise acquire.</a:t>
+            </a:r>
+          </a:p>
+        </p:txBody>
+      </p:sp>
+      <p:sp>
+        <p:nvSpPr>
+          <p:cNvPr id="10" name="TextBox 9"/>
+          <p:cNvSpPr txBox="1"/>
+          <p:nvPr/>
+        </p:nvSpPr>
+        <p:spPr>
+          <a:xfrm>
+            <a:off x="960120" y="5623560"/>
+            <a:ext cx="10424160" cy="731520"/>
+          </a:xfrm>
+          <a:prstGeom prst="rect">
+            <a:avLst/>
+          </a:prstGeom>
+          <a:noFill/>
+        </p:spPr>
+        <p:txBody>
+          <a:bodyPr wrap="square" anchor="t" lIns="0" rIns="0" tIns="0" bIns="0">
+            <a:spAutoFit/>
+          </a:bodyPr>
+          <a:lstStyle/>
+          <a:p>
+            <a:pPr algn="l">
+              <a:lnSpc>
+                <a:spcPct val="112000"/>
+              </a:lnSpc>
+              <a:spcAft>
+                <a:spcPts val="400"/>
+              </a:spcAft>
+            </a:pPr>
+            <a:r>
+              <a:rPr sz="1250" b="1" i="0">
+                <a:solidFill>
+                  <a:srgbClr val="8FA89B"/>
+                </a:solidFill>
+                <a:latin typeface="Calibri"/>
+              </a:rPr>
+              <a:t>Honesty note: </a:t>
+            </a:r>
+            <a:r>
+              <a:rPr sz="1250" b="0" i="1">
+                <a:solidFill>
+                  <a:srgbClr val="8FA89B"/>
+                </a:solidFill>
+                <a:latin typeface="Calibri"/>
+              </a:rPr>
+              <a:t>this deck argues Boston's side on purpose; the neutral scorecard, the Tatum-injury confound, and the media's pro-Philadelphia consensus are all documented in the repo.</a:t>
+            </a:r>
+          </a:p>
+        </p:txBody>
+      </p:sp>
+    </p:spTree>
+  </p:cSld>
+  <p:clrMapOvr>
+    <a:masterClrMapping/>
+  </p:clrMapOvr>
+</p:sld>
+</file>
+
 <file path=ppt/slides/slide2.xml><?xml version="1.0" encoding="utf-8"?>
 <p:sld xmlns:a="http://schemas.openxmlformats.org/drawingml/2006/main" xmlns:p="http://schemas.openxmlformats.org/presentationml/2006/main" xmlns:r="http://schemas.openxmlformats.org/officeDocument/2006/relationships">
   <p:cSld>
@@ -4692,7 +5141,7 @@
                 </a:solidFill>
                 <a:latin typeface="Calibri"/>
               </a:rPr>
-              <a:t>CONTINGENT VALUE</a:t>
+              <a:t>THE GAME PLAN</a:t>
             </a:r>
           </a:p>
         </p:txBody>
@@ -4734,14 +5183,14 @@
                 </a:solidFill>
                 <a:latin typeface="Cambria"/>
               </a:rPr>
-              <a:t>The production needed Tatum and White to prop it up</a:t>
+              <a:t>Boston's identity is math — and Brown was its one outlier</a:t>
             </a:r>
           </a:p>
         </p:txBody>
       </p:sp>
       <p:pic>
         <p:nvPicPr>
-          <p:cNvPr id="4" name="Picture 3" descr="with_without_net_2025-26.png"/>
+          <p:cNvPr id="4" name="Picture 3" descr="three_point_identity.png"/>
           <p:cNvPicPr>
             <a:picLocks noChangeAspect="1"/>
           </p:cNvPicPr>
@@ -4755,8 +5204,8 @@
         </p:blipFill>
         <p:spPr>
           <a:xfrm>
-            <a:off x="457200" y="1554480"/>
-            <a:ext cx="6035040" cy="3871096"/>
+            <a:off x="640080" y="1554480"/>
+            <a:ext cx="10881360" cy="3942521"/>
           </a:xfrm>
           <a:prstGeom prst="rect">
             <a:avLst/>
@@ -4765,58 +5214,14 @@
       </p:pic>
       <p:sp>
         <p:nvSpPr>
-          <p:cNvPr id="5" name="Oval 4"/>
-          <p:cNvSpPr/>
-          <p:nvPr/>
-        </p:nvSpPr>
-        <p:spPr>
-          <a:xfrm>
-            <a:off x="6858000" y="1819656"/>
-            <a:ext cx="146304" cy="146304"/>
-          </a:xfrm>
-          <a:prstGeom prst="ellipse">
-            <a:avLst/>
-          </a:prstGeom>
-          <a:solidFill>
-            <a:srgbClr val="0A2A1A"/>
-          </a:solidFill>
-          <a:ln>
-            <a:noFill/>
-          </a:ln>
-          <a:effectLst/>
-        </p:spPr>
-        <p:style>
-          <a:lnRef idx="1">
-            <a:schemeClr val="accent1"/>
-          </a:lnRef>
-          <a:fillRef idx="3">
-            <a:schemeClr val="accent1"/>
-          </a:fillRef>
-          <a:effectRef idx="2">
-            <a:schemeClr val="accent1"/>
-          </a:effectRef>
-          <a:fontRef idx="minor">
-            <a:schemeClr val="lt1"/>
-          </a:fontRef>
-        </p:style>
-        <p:txBody>
-          <a:bodyPr rtlCol="0" anchor="ctr"/>
-          <a:lstStyle/>
-          <a:p>
-            <a:pPr algn="ctr"/>
-          </a:p>
-        </p:txBody>
-      </p:sp>
-      <p:sp>
-        <p:nvSpPr>
-          <p:cNvPr id="6" name="TextBox 5"/>
+          <p:cNvPr id="5" name="TextBox 4"/>
           <p:cNvSpPr txBox="1"/>
           <p:nvPr/>
         </p:nvSpPr>
         <p:spPr>
           <a:xfrm>
-            <a:off x="7150608" y="1783080"/>
-            <a:ext cx="4754880" cy="1188720"/>
+            <a:off x="566928" y="5532120"/>
+            <a:ext cx="11064240" cy="914400"/>
           </a:xfrm>
           <a:prstGeom prst="rect">
             <a:avLst/>
@@ -4831,298 +5236,45 @@
           <a:p>
             <a:pPr algn="l">
               <a:lnSpc>
-                <a:spcPct val="108000"/>
-              </a:lnSpc>
-              <a:spcAft>
-                <a:spcPts val="200"/>
-              </a:spcAft>
-            </a:pPr>
-            <a:r>
-              <a:rPr sz="1450" b="1" i="0">
-                <a:solidFill>
-                  <a:srgbClr val="0A2A1A"/>
-                </a:solidFill>
-                <a:latin typeface="Calibri"/>
-              </a:rPr>
-              <a:t>With Tatum: +16.2 · without: +4.8</a:t>
-            </a:r>
-          </a:p>
-          <a:p>
-            <a:pPr algn="l">
-              <a:lnSpc>
-                <a:spcPct val="108000"/>
-              </a:lnSpc>
-              <a:spcAft>
-                <a:spcPts val="200"/>
-              </a:spcAft>
-            </a:pPr>
-            <a:r>
-              <a:rPr sz="1280" b="0" i="0">
+                <a:spcPct val="115000"/>
+              </a:lnSpc>
+              <a:spcAft>
+                <a:spcPts val="400"/>
+              </a:spcAft>
+            </a:pPr>
+            <a:r>
+              <a:rPr sz="1300" b="0" i="0">
+                <a:solidFill>
+                  <a:srgbClr val="20232A"/>
+                </a:solidFill>
+                <a:latin typeface="Calibri"/>
+              </a:rPr>
+              <a:t>#1 · #1 · #4 in three-point volume and a top-2 offense all three years — threes returned 1.10 points per shot vs 0.97 for twos. </a:t>
+            </a:r>
+            <a:r>
+              <a:rPr sz="1300" b="1" i="0">
+                <a:solidFill>
+                  <a:srgbClr val="B3403A"/>
+                </a:solidFill>
+                <a:latin typeface="Calibri"/>
+              </a:rPr>
+              <a:t>Brown: last of 7 perimeter players in 3PT rate (.263 vs team .467), first in long twos. </a:t>
+            </a:r>
+            <a:r>
+              <a:rPr sz="1300" b="0" i="0">
                 <a:solidFill>
                   <a:srgbClr val="6B7280"/>
                 </a:solidFill>
                 <a:latin typeface="Calibri"/>
               </a:rPr>
-              <a:t>An 11.3-point swing in 2025-26. Brown's lineups won when the infrastructure was on the floor.</a:t>
-            </a:r>
-          </a:p>
-        </p:txBody>
-      </p:sp>
-      <p:sp>
-        <p:nvSpPr>
-          <p:cNvPr id="7" name="Oval 6"/>
-          <p:cNvSpPr/>
-          <p:nvPr/>
-        </p:nvSpPr>
-        <p:spPr>
-          <a:xfrm>
-            <a:off x="6858000" y="3191256"/>
-            <a:ext cx="146304" cy="146304"/>
-          </a:xfrm>
-          <a:prstGeom prst="ellipse">
-            <a:avLst/>
-          </a:prstGeom>
-          <a:solidFill>
-            <a:srgbClr val="0A2A1A"/>
-          </a:solidFill>
-          <a:ln>
-            <a:noFill/>
-          </a:ln>
-          <a:effectLst/>
-        </p:spPr>
-        <p:style>
-          <a:lnRef idx="1">
-            <a:schemeClr val="accent1"/>
-          </a:lnRef>
-          <a:fillRef idx="3">
-            <a:schemeClr val="accent1"/>
-          </a:fillRef>
-          <a:effectRef idx="2">
-            <a:schemeClr val="accent1"/>
-          </a:effectRef>
-          <a:fontRef idx="minor">
-            <a:schemeClr val="lt1"/>
-          </a:fontRef>
-        </p:style>
-        <p:txBody>
-          <a:bodyPr rtlCol="0" anchor="ctr"/>
-          <a:lstStyle/>
-          <a:p>
-            <a:pPr algn="ctr"/>
-          </a:p>
-        </p:txBody>
-      </p:sp>
-      <p:sp>
-        <p:nvSpPr>
-          <p:cNvPr id="8" name="TextBox 7"/>
-          <p:cNvSpPr txBox="1"/>
-          <p:nvPr/>
-        </p:nvSpPr>
-        <p:spPr>
-          <a:xfrm>
-            <a:off x="7150608" y="3154680"/>
-            <a:ext cx="4754880" cy="1188720"/>
-          </a:xfrm>
-          <a:prstGeom prst="rect">
-            <a:avLst/>
-          </a:prstGeom>
-          <a:noFill/>
-        </p:spPr>
-        <p:txBody>
-          <a:bodyPr wrap="square" anchor="t" lIns="0" rIns="0" tIns="0" bIns="0">
-            <a:spAutoFit/>
-          </a:bodyPr>
-          <a:lstStyle/>
-          <a:p>
-            <a:pPr algn="l">
-              <a:lnSpc>
-                <a:spcPct val="108000"/>
-              </a:lnSpc>
-              <a:spcAft>
-                <a:spcPts val="200"/>
-              </a:spcAft>
-            </a:pPr>
-            <a:r>
-              <a:rPr sz="1450" b="1" i="0">
-                <a:solidFill>
-                  <a:srgbClr val="0A2A1A"/>
-                </a:solidFill>
-                <a:latin typeface="Calibri"/>
-              </a:rPr>
-              <a:t>With White: +9.4 · without: −1.0</a:t>
-            </a:r>
-          </a:p>
-          <a:p>
-            <a:pPr algn="l">
-              <a:lnSpc>
-                <a:spcPct val="108000"/>
-              </a:lnSpc>
-              <a:spcAft>
-                <a:spcPts val="200"/>
-              </a:spcAft>
-            </a:pPr>
-            <a:r>
-              <a:rPr sz="1280" b="0" i="0">
-                <a:solidFill>
-                  <a:srgbClr val="6B7280"/>
-                </a:solidFill>
-                <a:latin typeface="Calibri"/>
-              </a:rPr>
-              <a:t>Same story with the other connector — Brown-led lineups without White were underwater.</a:t>
-            </a:r>
-          </a:p>
-        </p:txBody>
-      </p:sp>
-      <p:sp>
-        <p:nvSpPr>
-          <p:cNvPr id="9" name="Oval 8"/>
-          <p:cNvSpPr/>
-          <p:nvPr/>
-        </p:nvSpPr>
-        <p:spPr>
-          <a:xfrm>
-            <a:off x="6858000" y="4562856"/>
-            <a:ext cx="146304" cy="146304"/>
-          </a:xfrm>
-          <a:prstGeom prst="ellipse">
-            <a:avLst/>
-          </a:prstGeom>
-          <a:solidFill>
-            <a:srgbClr val="BA9653"/>
-          </a:solidFill>
-          <a:ln>
-            <a:noFill/>
-          </a:ln>
-          <a:effectLst/>
-        </p:spPr>
-        <p:style>
-          <a:lnRef idx="1">
-            <a:schemeClr val="accent1"/>
-          </a:lnRef>
-          <a:fillRef idx="3">
-            <a:schemeClr val="accent1"/>
-          </a:fillRef>
-          <a:effectRef idx="2">
-            <a:schemeClr val="accent1"/>
-          </a:effectRef>
-          <a:fontRef idx="minor">
-            <a:schemeClr val="lt1"/>
-          </a:fontRef>
-        </p:style>
-        <p:txBody>
-          <a:bodyPr rtlCol="0" anchor="ctr"/>
-          <a:lstStyle/>
-          <a:p>
-            <a:pPr algn="ctr"/>
-          </a:p>
-        </p:txBody>
-      </p:sp>
-      <p:sp>
-        <p:nvSpPr>
-          <p:cNvPr id="10" name="TextBox 9"/>
-          <p:cNvSpPr txBox="1"/>
-          <p:nvPr/>
-        </p:nvSpPr>
-        <p:spPr>
-          <a:xfrm>
-            <a:off x="7150608" y="4526280"/>
-            <a:ext cx="4754880" cy="1188720"/>
-          </a:xfrm>
-          <a:prstGeom prst="rect">
-            <a:avLst/>
-          </a:prstGeom>
-          <a:noFill/>
-        </p:spPr>
-        <p:txBody>
-          <a:bodyPr wrap="square" anchor="t" lIns="0" rIns="0" tIns="0" bIns="0">
-            <a:spAutoFit/>
-          </a:bodyPr>
-          <a:lstStyle/>
-          <a:p>
-            <a:pPr algn="l">
-              <a:lnSpc>
-                <a:spcPct val="108000"/>
-              </a:lnSpc>
-              <a:spcAft>
-                <a:spcPts val="200"/>
-              </a:spcAft>
-            </a:pPr>
-            <a:r>
-              <a:rPr sz="1450" b="1" i="0">
-                <a:solidFill>
-                  <a:srgbClr val="0A2A1A"/>
-                </a:solidFill>
-                <a:latin typeface="Calibri"/>
-              </a:rPr>
-              <a:t>The honest caveat</a:t>
-            </a:r>
-          </a:p>
-          <a:p>
-            <a:pPr algn="l">
-              <a:lnSpc>
-                <a:spcPct val="108000"/>
-              </a:lnSpc>
-              <a:spcAft>
-                <a:spcPts val="200"/>
-              </a:spcAft>
-            </a:pPr>
-            <a:r>
-              <a:rPr sz="1280" b="0" i="0">
-                <a:solidFill>
-                  <a:srgbClr val="6B7280"/>
-                </a:solidFill>
-                <a:latin typeface="Calibri"/>
-              </a:rPr>
-              <a:t>Tatum's injury contaminates the 2025-26 split; the confound is documented, not hidden. It softens — but doesn't reverse — the pattern.</a:t>
-            </a:r>
-          </a:p>
-        </p:txBody>
-      </p:sp>
-      <p:sp>
-        <p:nvSpPr>
-          <p:cNvPr id="11" name="TextBox 10"/>
-          <p:cNvSpPr txBox="1"/>
-          <p:nvPr/>
-        </p:nvSpPr>
-        <p:spPr>
-          <a:xfrm>
-            <a:off x="6858000" y="5943600"/>
-            <a:ext cx="4754880" cy="548640"/>
-          </a:xfrm>
-          <a:prstGeom prst="rect">
-            <a:avLst/>
-          </a:prstGeom>
-          <a:noFill/>
-        </p:spPr>
-        <p:txBody>
-          <a:bodyPr wrap="square" anchor="t" lIns="0" rIns="0" tIns="0" bIns="0">
-            <a:spAutoFit/>
-          </a:bodyPr>
-          <a:lstStyle/>
-          <a:p>
-            <a:pPr algn="l">
-              <a:lnSpc>
-                <a:spcPct val="105000"/>
-              </a:lnSpc>
-              <a:spcAft>
-                <a:spcPts val="400"/>
-              </a:spcAft>
-            </a:pPr>
-            <a:r>
-              <a:rPr sz="1300" b="1" i="1">
-                <a:solidFill>
-                  <a:srgbClr val="007A33"/>
-                </a:solidFill>
-                <a:latin typeface="Calibri"/>
-              </a:rPr>
-              <a:t>A $53M player whose value is contingent on his co-stars is a fit problem, not a star.</a:t>
-            </a:r>
-          </a:p>
-        </p:txBody>
-      </p:sp>
-      <p:sp>
-        <p:nvSpPr>
-          <p:cNvPr id="12" name="TextBox 11"/>
+              <a:t>A shot-mix problem, not a finishing one (his 1.046 PPS vs 1.101) — and honestly priced, swapping his diet for George's is roughly a wash after creation and aging discounts. The offense case supports; it doesn't headline.</a:t>
+            </a:r>
+          </a:p>
+        </p:txBody>
+      </p:sp>
+      <p:sp>
+        <p:nvSpPr>
+          <p:cNvPr id="6" name="TextBox 5"/>
           <p:cNvSpPr txBox="1"/>
           <p:nvPr/>
         </p:nvSpPr>
@@ -5234,7 +5386,7 @@
                 </a:solidFill>
                 <a:latin typeface="Calibri"/>
               </a:rPr>
-              <a:t>THE HIERARCHY TEST</a:t>
+              <a:t>CONTINGENT VALUE</a:t>
             </a:r>
           </a:p>
         </p:txBody>
@@ -5276,14 +5428,14 @@
                 </a:solidFill>
                 <a:latin typeface="Cambria"/>
               </a:rPr>
-              <a:t>First-option Tatum beat load-sharing — on the floor and in the standings</a:t>
+              <a:t>The production needed Tatum and White to prop it up</a:t>
             </a:r>
           </a:p>
         </p:txBody>
       </p:sp>
       <p:pic>
         <p:nvPicPr>
-          <p:cNvPr id="4" name="Picture 3" descr="tatum_first_option.png"/>
+          <p:cNvPr id="4" name="Picture 3" descr="with_without_net_2025-26.png"/>
           <p:cNvPicPr>
             <a:picLocks noChangeAspect="1"/>
           </p:cNvPicPr>
@@ -5298,7 +5450,7 @@
         <p:spPr>
           <a:xfrm>
             <a:off x="457200" y="1554480"/>
-            <a:ext cx="6766560" cy="2783447"/>
+            <a:ext cx="6035040" cy="3871096"/>
           </a:xfrm>
           <a:prstGeom prst="rect">
             <a:avLst/>
@@ -5313,14 +5465,14 @@
         </p:nvSpPr>
         <p:spPr>
           <a:xfrm>
-            <a:off x="7589520" y="1773936"/>
+            <a:off x="6858000" y="1819656"/>
             <a:ext cx="146304" cy="146304"/>
           </a:xfrm>
           <a:prstGeom prst="ellipse">
             <a:avLst/>
           </a:prstGeom>
           <a:solidFill>
-            <a:srgbClr val="007A33"/>
+            <a:srgbClr val="0A2A1A"/>
           </a:solidFill>
           <a:ln>
             <a:noFill/>
@@ -5357,8 +5509,8 @@
         </p:nvSpPr>
         <p:spPr>
           <a:xfrm>
-            <a:off x="7882128" y="1737360"/>
-            <a:ext cx="4069080" cy="1143000"/>
+            <a:off x="7150608" y="1783080"/>
+            <a:ext cx="4754880" cy="1188720"/>
           </a:xfrm>
           <a:prstGeom prst="rect">
             <a:avLst/>
@@ -5373,39 +5525,39 @@
           <a:p>
             <a:pPr algn="l">
               <a:lnSpc>
-                <a:spcPct val="106000"/>
+                <a:spcPct val="108000"/>
               </a:lnSpc>
               <a:spcAft>
                 <a:spcPts val="200"/>
               </a:spcAft>
             </a:pPr>
             <a:r>
-              <a:rPr sz="1400" b="1" i="0">
+              <a:rPr sz="1450" b="1" i="0">
                 <a:solidFill>
                   <a:srgbClr val="0A2A1A"/>
                 </a:solidFill>
                 <a:latin typeface="Calibri"/>
               </a:rPr>
-              <a:t>13-3 (+11.8) when Brown sat</a:t>
-            </a:r>
-          </a:p>
-          <a:p>
-            <a:pPr algn="l">
-              <a:lnSpc>
-                <a:spcPct val="106000"/>
+              <a:t>With Tatum: +16.2 · without: +4.8</a:t>
+            </a:r>
+          </a:p>
+          <a:p>
+            <a:pPr algn="l">
+              <a:lnSpc>
+                <a:spcPct val="108000"/>
               </a:lnSpc>
               <a:spcAft>
                 <a:spcPts val="200"/>
               </a:spcAft>
             </a:pPr>
             <a:r>
-              <a:rPr sz="1220" b="0" i="0">
+              <a:rPr sz="1280" b="0" i="0">
                 <a:solidFill>
                   <a:srgbClr val="6B7280"/>
                 </a:solidFill>
                 <a:latin typeface="Calibri"/>
               </a:rPr>
-              <a:t>16 games in 2024-25. Full 2×2: Tatum-led lineups +11.9 &gt; Brown-led +9.8 &gt; together +7.6 &gt; neither +3.5 (control).</a:t>
+              <a:t>An 11.3-point swing in 2025-26. Brown's lineups won when the infrastructure was on the floor.</a:t>
             </a:r>
           </a:p>
         </p:txBody>
@@ -5418,7 +5570,7 @@
         </p:nvSpPr>
         <p:spPr>
           <a:xfrm>
-            <a:off x="7589520" y="3090672"/>
+            <a:off x="6858000" y="3191256"/>
             <a:ext cx="146304" cy="146304"/>
           </a:xfrm>
           <a:prstGeom prst="ellipse">
@@ -5462,8 +5614,8 @@
         </p:nvSpPr>
         <p:spPr>
           <a:xfrm>
-            <a:off x="7882128" y="3054096"/>
-            <a:ext cx="4069080" cy="1143000"/>
+            <a:off x="7150608" y="3154680"/>
+            <a:ext cx="4754880" cy="1188720"/>
           </a:xfrm>
           <a:prstGeom prst="rect">
             <a:avLst/>
@@ -5478,39 +5630,39 @@
           <a:p>
             <a:pPr algn="l">
               <a:lnSpc>
-                <a:spcPct val="106000"/>
+                <a:spcPct val="108000"/>
               </a:lnSpc>
               <a:spcAft>
                 <a:spcPts val="200"/>
               </a:spcAft>
             </a:pPr>
             <a:r>
-              <a:rPr sz="1400" b="1" i="0">
+              <a:rPr sz="1450" b="1" i="0">
                 <a:solidFill>
                   <a:srgbClr val="0A2A1A"/>
                 </a:solidFill>
                 <a:latin typeface="Calibri"/>
               </a:rPr>
-              <a:t>Usage up, efficiency flat</a:t>
-            </a:r>
-          </a:p>
-          <a:p>
-            <a:pPr algn="l">
-              <a:lnSpc>
-                <a:spcPct val="106000"/>
+              <a:t>With White: +9.4 · without: −1.0</a:t>
+            </a:r>
+          </a:p>
+          <a:p>
+            <a:pPr algn="l">
+              <a:lnSpc>
+                <a:spcPct val="108000"/>
               </a:lnSpc>
               <a:spcAft>
                 <a:spcPts val="200"/>
               </a:spcAft>
             </a:pPr>
             <a:r>
-              <a:rPr sz="1220" b="0" i="0">
+              <a:rPr sz="1280" b="0" i="0">
                 <a:solidFill>
                   <a:srgbClr val="6B7280"/>
                 </a:solidFill>
                 <a:latin typeface="Calibri"/>
               </a:rPr>
-              <a:t>Tatum without Brown: 28.8 pts / 7.8 reb on .584 TS at 34.5% usage — he absorbed +4.1 usage points and lost nothing.</a:t>
+              <a:t>Same story with the other connector — Brown-led lineups without White were underwater.</a:t>
             </a:r>
           </a:p>
         </p:txBody>
@@ -5523,7 +5675,7 @@
         </p:nvSpPr>
         <p:spPr>
           <a:xfrm>
-            <a:off x="7589520" y="4407407"/>
+            <a:off x="6858000" y="4562856"/>
             <a:ext cx="146304" cy="146304"/>
           </a:xfrm>
           <a:prstGeom prst="ellipse">
@@ -5567,8 +5719,8 @@
         </p:nvSpPr>
         <p:spPr>
           <a:xfrm>
-            <a:off x="7882128" y="4370831"/>
-            <a:ext cx="4069080" cy="1143000"/>
+            <a:off x="7150608" y="4526280"/>
+            <a:ext cx="4754880" cy="1188720"/>
           </a:xfrm>
           <a:prstGeom prst="rect">
             <a:avLst/>
@@ -5583,39 +5735,39 @@
           <a:p>
             <a:pPr algn="l">
               <a:lnSpc>
-                <a:spcPct val="106000"/>
+                <a:spcPct val="108000"/>
               </a:lnSpc>
               <a:spcAft>
                 <a:spcPts val="200"/>
               </a:spcAft>
             </a:pPr>
             <a:r>
-              <a:rPr sz="1400" b="1" i="0">
+              <a:rPr sz="1450" b="1" i="0">
                 <a:solidFill>
                   <a:srgbClr val="0A2A1A"/>
                 </a:solidFill>
                 <a:latin typeface="Calibri"/>
               </a:rPr>
-              <a:t>Worth ~5-7 wins a season</a:t>
-            </a:r>
-          </a:p>
-          <a:p>
-            <a:pPr algn="l">
-              <a:lnSpc>
-                <a:spcPct val="106000"/>
+              <a:t>The honest caveat</a:t>
+            </a:r>
+          </a:p>
+          <a:p>
+            <a:pPr algn="l">
+              <a:lnSpc>
+                <a:spcPct val="108000"/>
               </a:lnSpc>
               <a:spcAft>
                 <a:spcPts val="200"/>
               </a:spcAft>
             </a:pPr>
             <a:r>
-              <a:rPr sz="1220" b="0" i="0">
+              <a:rPr sz="1280" b="0" i="0">
                 <a:solidFill>
                   <a:srgbClr val="6B7280"/>
                 </a:solidFill>
                 <a:latin typeface="Calibri"/>
               </a:rPr>
-              <a:t>Projection, not observation: the +4.3 lineup gap, shrunk 40-60% for bench/garbage contamination → +1.7-2.6 team net → +4.7-7.0 wins. Assumptions documented in the memo.</a:t>
+              <a:t>Tatum's injury contaminates the 2025-26 split; the confound is documented, not hidden. It softens — but doesn't reverse — the pattern.</a:t>
             </a:r>
           </a:p>
         </p:txBody>
@@ -5628,8 +5780,8 @@
         </p:nvSpPr>
         <p:spPr>
           <a:xfrm>
-            <a:off x="566928" y="4617720"/>
-            <a:ext cx="6766560" cy="1188720"/>
+            <a:off x="6858000" y="5943600"/>
+            <a:ext cx="4754880" cy="548640"/>
           </a:xfrm>
           <a:prstGeom prst="rect">
             <a:avLst/>
@@ -5644,38 +5796,20 @@
           <a:p>
             <a:pPr algn="l">
               <a:lnSpc>
-                <a:spcPct val="112000"/>
+                <a:spcPct val="105000"/>
               </a:lnSpc>
               <a:spcAft>
                 <a:spcPts val="400"/>
               </a:spcAft>
             </a:pPr>
             <a:r>
-              <a:rPr sz="1300" b="0" i="0">
-                <a:solidFill>
-                  <a:srgbClr val="20232A"/>
-                </a:solidFill>
-                <a:latin typeface="Calibri"/>
-              </a:rPr>
-              <a:t>Tatum's projected solo season: </a:t>
-            </a:r>
-            <a:r>
-              <a:rPr sz="1300" b="1" i="0">
+              <a:rPr sz="1300" b="1" i="1">
                 <a:solidFill>
                   <a:srgbClr val="007A33"/>
                 </a:solidFill>
                 <a:latin typeface="Calibri"/>
               </a:rPr>
-              <a:t>27.2-28.8 pts · 7.8-8.9 reb · 5.1-6.2 ast · .566-.584 TS </a:t>
-            </a:r>
-            <a:r>
-              <a:rPr sz="1300" b="0" i="0">
-                <a:solidFill>
-                  <a:srgbClr val="6B7280"/>
-                </a:solidFill>
-                <a:latin typeface="Calibri"/>
-              </a:rPr>
-              <a:t>— stated as a range from the observed 16-game sample and a documented usage-tradeoff model, because false precision is how decks lie.</a:t>
+              <a:t>A $53M player whose value is contingent on his co-stars is a fit problem, not a star.</a:t>
             </a:r>
           </a:p>
         </p:txBody>
@@ -5683,48 +5817,6 @@
       <p:sp>
         <p:nvSpPr>
           <p:cNvPr id="12" name="TextBox 11"/>
-          <p:cNvSpPr txBox="1"/>
-          <p:nvPr/>
-        </p:nvSpPr>
-        <p:spPr>
-          <a:xfrm>
-            <a:off x="566928" y="5989320"/>
-            <a:ext cx="11064240" cy="411480"/>
-          </a:xfrm>
-          <a:prstGeom prst="rect">
-            <a:avLst/>
-          </a:prstGeom>
-          <a:noFill/>
-        </p:spPr>
-        <p:txBody>
-          <a:bodyPr wrap="square" anchor="t" lIns="0" rIns="0" tIns="0" bIns="0">
-            <a:spAutoFit/>
-          </a:bodyPr>
-          <a:lstStyle/>
-          <a:p>
-            <a:pPr algn="l">
-              <a:lnSpc>
-                <a:spcPct val="105000"/>
-              </a:lnSpc>
-              <a:spcAft>
-                <a:spcPts val="400"/>
-              </a:spcAft>
-            </a:pPr>
-            <a:r>
-              <a:rPr sz="1150" b="0" i="1">
-                <a:solidFill>
-                  <a:srgbClr val="6B7280"/>
-                </a:solidFill>
-                <a:latin typeface="Calibri"/>
-              </a:rPr>
-              <a:t>Honesty flag: Brown's own 7-game solo cell was the best in the matrix (6-1, +15.8) — small sample, printed anyway. See slide 8.</a:t>
-            </a:r>
-          </a:p>
-        </p:txBody>
-      </p:sp>
-      <p:sp>
-        <p:nvSpPr>
-          <p:cNvPr id="13" name="TextBox 12"/>
           <p:cNvSpPr txBox="1"/>
           <p:nvPr/>
         </p:nvSpPr>
@@ -5836,7 +5928,7 @@
                 </a:solidFill>
                 <a:latin typeface="Calibri"/>
               </a:rPr>
-              <a:t>THE CONTRACT</a:t>
+              <a:t>THE HIERARCHY TEST</a:t>
             </a:r>
           </a:p>
         </p:txBody>
@@ -5878,14 +5970,14 @@
                 </a:solidFill>
                 <a:latin typeface="Cambria"/>
               </a:rPr>
-              <a:t>Max-contract price, below-median-efficiency production</a:t>
+              <a:t>First-option Tatum beat load-sharing — on the floor and in the standings</a:t>
             </a:r>
           </a:p>
         </p:txBody>
       </p:sp>
       <p:pic>
         <p:nvPicPr>
-          <p:cNvPr id="4" name="Picture 3" descr="efficiency_comps.png"/>
+          <p:cNvPr id="4" name="Picture 3" descr="tatum_first_option.png"/>
           <p:cNvPicPr>
             <a:picLocks noChangeAspect="1"/>
           </p:cNvPicPr>
@@ -5899,8 +5991,8 @@
         </p:blipFill>
         <p:spPr>
           <a:xfrm>
-            <a:off x="1097280" y="1508760"/>
-            <a:ext cx="9966960" cy="4111782"/>
+            <a:off x="457200" y="1554480"/>
+            <a:ext cx="6766560" cy="2783447"/>
           </a:xfrm>
           <a:prstGeom prst="rect">
             <a:avLst/>
@@ -5909,14 +6001,58 @@
       </p:pic>
       <p:sp>
         <p:nvSpPr>
-          <p:cNvPr id="5" name="TextBox 4"/>
+          <p:cNvPr id="5" name="Oval 4"/>
+          <p:cNvSpPr/>
+          <p:nvPr/>
+        </p:nvSpPr>
+        <p:spPr>
+          <a:xfrm>
+            <a:off x="7589520" y="1773936"/>
+            <a:ext cx="146304" cy="146304"/>
+          </a:xfrm>
+          <a:prstGeom prst="ellipse">
+            <a:avLst/>
+          </a:prstGeom>
+          <a:solidFill>
+            <a:srgbClr val="007A33"/>
+          </a:solidFill>
+          <a:ln>
+            <a:noFill/>
+          </a:ln>
+          <a:effectLst/>
+        </p:spPr>
+        <p:style>
+          <a:lnRef idx="1">
+            <a:schemeClr val="accent1"/>
+          </a:lnRef>
+          <a:fillRef idx="3">
+            <a:schemeClr val="accent1"/>
+          </a:fillRef>
+          <a:effectRef idx="2">
+            <a:schemeClr val="accent1"/>
+          </a:effectRef>
+          <a:fontRef idx="minor">
+            <a:schemeClr val="lt1"/>
+          </a:fontRef>
+        </p:style>
+        <p:txBody>
+          <a:bodyPr rtlCol="0" anchor="ctr"/>
+          <a:lstStyle/>
+          <a:p>
+            <a:pPr algn="ctr"/>
+          </a:p>
+        </p:txBody>
+      </p:sp>
+      <p:sp>
+        <p:nvSpPr>
+          <p:cNvPr id="6" name="TextBox 5"/>
           <p:cNvSpPr txBox="1"/>
           <p:nvPr/>
         </p:nvSpPr>
         <p:spPr>
           <a:xfrm>
-            <a:off x="566928" y="5806440"/>
-            <a:ext cx="11064240" cy="640080"/>
+            <a:off x="7882128" y="1737360"/>
+            <a:ext cx="4069080" cy="1143000"/>
           </a:xfrm>
           <a:prstGeom prst="rect">
             <a:avLst/>
@@ -5931,36 +6067,358 @@
           <a:p>
             <a:pPr algn="l">
               <a:lnSpc>
-                <a:spcPct val="110000"/>
+                <a:spcPct val="106000"/>
+              </a:lnSpc>
+              <a:spcAft>
+                <a:spcPts val="200"/>
+              </a:spcAft>
+            </a:pPr>
+            <a:r>
+              <a:rPr sz="1400" b="1" i="0">
+                <a:solidFill>
+                  <a:srgbClr val="0A2A1A"/>
+                </a:solidFill>
+                <a:latin typeface="Calibri"/>
+              </a:rPr>
+              <a:t>25-4 (86.2%) when Brown sat</a:t>
+            </a:r>
+          </a:p>
+          <a:p>
+            <a:pPr algn="l">
+              <a:lnSpc>
+                <a:spcPct val="106000"/>
+              </a:lnSpc>
+              <a:spcAft>
+                <a:spcPts val="200"/>
+              </a:spcAft>
+            </a:pPr>
+            <a:r>
+              <a:rPr sz="1220" b="0" i="0">
+                <a:solidFill>
+                  <a:srgbClr val="6B7280"/>
+                </a:solidFill>
+                <a:latin typeface="Calibri"/>
+              </a:rPr>
+              <a:t>29 games, 2023-present, +13.3/game — including 10-0 in the title year. Both healthy: 73.7%. Lineups: Tatum-led +11.9 &gt; together +7.6 &gt; neither +3.5 (control).</a:t>
+            </a:r>
+          </a:p>
+        </p:txBody>
+      </p:sp>
+      <p:sp>
+        <p:nvSpPr>
+          <p:cNvPr id="7" name="Oval 6"/>
+          <p:cNvSpPr/>
+          <p:nvPr/>
+        </p:nvSpPr>
+        <p:spPr>
+          <a:xfrm>
+            <a:off x="7589520" y="3090672"/>
+            <a:ext cx="146304" cy="146304"/>
+          </a:xfrm>
+          <a:prstGeom prst="ellipse">
+            <a:avLst/>
+          </a:prstGeom>
+          <a:solidFill>
+            <a:srgbClr val="0A2A1A"/>
+          </a:solidFill>
+          <a:ln>
+            <a:noFill/>
+          </a:ln>
+          <a:effectLst/>
+        </p:spPr>
+        <p:style>
+          <a:lnRef idx="1">
+            <a:schemeClr val="accent1"/>
+          </a:lnRef>
+          <a:fillRef idx="3">
+            <a:schemeClr val="accent1"/>
+          </a:fillRef>
+          <a:effectRef idx="2">
+            <a:schemeClr val="accent1"/>
+          </a:effectRef>
+          <a:fontRef idx="minor">
+            <a:schemeClr val="lt1"/>
+          </a:fontRef>
+        </p:style>
+        <p:txBody>
+          <a:bodyPr rtlCol="0" anchor="ctr"/>
+          <a:lstStyle/>
+          <a:p>
+            <a:pPr algn="ctr"/>
+          </a:p>
+        </p:txBody>
+      </p:sp>
+      <p:sp>
+        <p:nvSpPr>
+          <p:cNvPr id="8" name="TextBox 7"/>
+          <p:cNvSpPr txBox="1"/>
+          <p:nvPr/>
+        </p:nvSpPr>
+        <p:spPr>
+          <a:xfrm>
+            <a:off x="7882128" y="3054096"/>
+            <a:ext cx="4069080" cy="1143000"/>
+          </a:xfrm>
+          <a:prstGeom prst="rect">
+            <a:avLst/>
+          </a:prstGeom>
+          <a:noFill/>
+        </p:spPr>
+        <p:txBody>
+          <a:bodyPr wrap="square" anchor="t" lIns="0" rIns="0" tIns="0" bIns="0">
+            <a:spAutoFit/>
+          </a:bodyPr>
+          <a:lstStyle/>
+          <a:p>
+            <a:pPr algn="l">
+              <a:lnSpc>
+                <a:spcPct val="106000"/>
+              </a:lnSpc>
+              <a:spcAft>
+                <a:spcPts val="200"/>
+              </a:spcAft>
+            </a:pPr>
+            <a:r>
+              <a:rPr sz="1400" b="1" i="0">
+                <a:solidFill>
+                  <a:srgbClr val="0A2A1A"/>
+                </a:solidFill>
+                <a:latin typeface="Calibri"/>
+              </a:rPr>
+              <a:t>Usage up, efficiency mostly holds</a:t>
+            </a:r>
+          </a:p>
+          <a:p>
+            <a:pPr algn="l">
+              <a:lnSpc>
+                <a:spcPct val="106000"/>
+              </a:lnSpc>
+              <a:spcAft>
+                <a:spcPts val="200"/>
+              </a:spcAft>
+            </a:pPr>
+            <a:r>
+              <a:rPr sz="1220" b="0" i="0">
+                <a:solidFill>
+                  <a:srgbClr val="6B7280"/>
+                </a:solidFill>
+                <a:latin typeface="Calibri"/>
+              </a:rPr>
+              <a:t>Pooled: 28.0/7.9/5.7 at 34.6% usage (+4.7 pts of usage), TS .593 → .572 — a modest efficiency dip, printed, not hidden.</a:t>
+            </a:r>
+          </a:p>
+        </p:txBody>
+      </p:sp>
+      <p:sp>
+        <p:nvSpPr>
+          <p:cNvPr id="9" name="Oval 8"/>
+          <p:cNvSpPr/>
+          <p:nvPr/>
+        </p:nvSpPr>
+        <p:spPr>
+          <a:xfrm>
+            <a:off x="7589520" y="4407407"/>
+            <a:ext cx="146304" cy="146304"/>
+          </a:xfrm>
+          <a:prstGeom prst="ellipse">
+            <a:avLst/>
+          </a:prstGeom>
+          <a:solidFill>
+            <a:srgbClr val="BA9653"/>
+          </a:solidFill>
+          <a:ln>
+            <a:noFill/>
+          </a:ln>
+          <a:effectLst/>
+        </p:spPr>
+        <p:style>
+          <a:lnRef idx="1">
+            <a:schemeClr val="accent1"/>
+          </a:lnRef>
+          <a:fillRef idx="3">
+            <a:schemeClr val="accent1"/>
+          </a:fillRef>
+          <a:effectRef idx="2">
+            <a:schemeClr val="accent1"/>
+          </a:effectRef>
+          <a:fontRef idx="minor">
+            <a:schemeClr val="lt1"/>
+          </a:fontRef>
+        </p:style>
+        <p:txBody>
+          <a:bodyPr rtlCol="0" anchor="ctr"/>
+          <a:lstStyle/>
+          <a:p>
+            <a:pPr algn="ctr"/>
+          </a:p>
+        </p:txBody>
+      </p:sp>
+      <p:sp>
+        <p:nvSpPr>
+          <p:cNvPr id="10" name="TextBox 9"/>
+          <p:cNvSpPr txBox="1"/>
+          <p:nvPr/>
+        </p:nvSpPr>
+        <p:spPr>
+          <a:xfrm>
+            <a:off x="7882128" y="4370831"/>
+            <a:ext cx="4069080" cy="1143000"/>
+          </a:xfrm>
+          <a:prstGeom prst="rect">
+            <a:avLst/>
+          </a:prstGeom>
+          <a:noFill/>
+        </p:spPr>
+        <p:txBody>
+          <a:bodyPr wrap="square" anchor="t" lIns="0" rIns="0" tIns="0" bIns="0">
+            <a:spAutoFit/>
+          </a:bodyPr>
+          <a:lstStyle/>
+          <a:p>
+            <a:pPr algn="l">
+              <a:lnSpc>
+                <a:spcPct val="106000"/>
+              </a:lnSpc>
+              <a:spcAft>
+                <a:spcPts val="200"/>
+              </a:spcAft>
+            </a:pPr>
+            <a:r>
+              <a:rPr sz="1400" b="1" i="0">
+                <a:solidFill>
+                  <a:srgbClr val="0A2A1A"/>
+                </a:solidFill>
+                <a:latin typeface="Calibri"/>
+              </a:rPr>
+              <a:t>Worth ~5-7 wins a season</a:t>
+            </a:r>
+          </a:p>
+          <a:p>
+            <a:pPr algn="l">
+              <a:lnSpc>
+                <a:spcPct val="106000"/>
+              </a:lnSpc>
+              <a:spcAft>
+                <a:spcPts val="200"/>
+              </a:spcAft>
+            </a:pPr>
+            <a:r>
+              <a:rPr sz="1220" b="0" i="0">
+                <a:solidFill>
+                  <a:srgbClr val="6B7280"/>
+                </a:solidFill>
+                <a:latin typeface="Calibri"/>
+              </a:rPr>
+              <a:t>Projection, not observation: the +4.3 lineup gap, shrunk 40-60% for bench/garbage contamination → +1.7-2.6 team net → +4.7-7.0 wins. Assumptions documented in the memo.</a:t>
+            </a:r>
+          </a:p>
+        </p:txBody>
+      </p:sp>
+      <p:sp>
+        <p:nvSpPr>
+          <p:cNvPr id="11" name="TextBox 10"/>
+          <p:cNvSpPr txBox="1"/>
+          <p:nvPr/>
+        </p:nvSpPr>
+        <p:spPr>
+          <a:xfrm>
+            <a:off x="566928" y="4617720"/>
+            <a:ext cx="6766560" cy="1188720"/>
+          </a:xfrm>
+          <a:prstGeom prst="rect">
+            <a:avLst/>
+          </a:prstGeom>
+          <a:noFill/>
+        </p:spPr>
+        <p:txBody>
+          <a:bodyPr wrap="square" anchor="t" lIns="0" rIns="0" tIns="0" bIns="0">
+            <a:spAutoFit/>
+          </a:bodyPr>
+          <a:lstStyle/>
+          <a:p>
+            <a:pPr algn="l">
+              <a:lnSpc>
+                <a:spcPct val="112000"/>
               </a:lnSpc>
               <a:spcAft>
                 <a:spcPts val="400"/>
               </a:spcAft>
             </a:pPr>
             <a:r>
-              <a:rPr sz="1400" b="0" i="0">
+              <a:rPr sz="1300" b="0" i="0">
                 <a:solidFill>
                   <a:srgbClr val="20232A"/>
                 </a:solidFill>
                 <a:latin typeface="Calibri"/>
               </a:rPr>
-              <a:t>6.9 WS on $53.1M = $7.7M per win share at 34% of the cap, with a 0.573 TS% — below the max-wing median. </a:t>
-            </a:r>
-            <a:r>
-              <a:rPr sz="1400" b="1" i="0">
+              <a:t>Tatum's projected solo season: </a:t>
+            </a:r>
+            <a:r>
+              <a:rPr sz="1300" b="1" i="0">
                 <a:solidFill>
                   <a:srgbClr val="007A33"/>
                 </a:solidFill>
                 <a:latin typeface="Calibri"/>
               </a:rPr>
-              <a:t>Picks 15-30 buy the same wins at ~$2.1M/WS on rookie deals.</a:t>
-            </a:r>
-          </a:p>
-        </p:txBody>
-      </p:sp>
-      <p:sp>
-        <p:nvSpPr>
-          <p:cNvPr id="6" name="TextBox 5"/>
+              <a:t>27.2-28.8 pts · 7.8-8.9 reb · 5.1-6.2 ast · .566-.584 TS </a:t>
+            </a:r>
+            <a:r>
+              <a:rPr sz="1300" b="0" i="0">
+                <a:solidFill>
+                  <a:srgbClr val="6B7280"/>
+                </a:solidFill>
+                <a:latin typeface="Calibri"/>
+              </a:rPr>
+              <a:t>— stated as a range from the observed 16-game sample and a documented usage-tradeoff model, because false precision is how decks lie.</a:t>
+            </a:r>
+          </a:p>
+        </p:txBody>
+      </p:sp>
+      <p:sp>
+        <p:nvSpPr>
+          <p:cNvPr id="12" name="TextBox 11"/>
+          <p:cNvSpPr txBox="1"/>
+          <p:nvPr/>
+        </p:nvSpPr>
+        <p:spPr>
+          <a:xfrm>
+            <a:off x="566928" y="5989320"/>
+            <a:ext cx="11064240" cy="411480"/>
+          </a:xfrm>
+          <a:prstGeom prst="rect">
+            <a:avLst/>
+          </a:prstGeom>
+          <a:noFill/>
+        </p:spPr>
+        <p:txBody>
+          <a:bodyPr wrap="square" anchor="t" lIns="0" rIns="0" tIns="0" bIns="0">
+            <a:spAutoFit/>
+          </a:bodyPr>
+          <a:lstStyle/>
+          <a:p>
+            <a:pPr algn="l">
+              <a:lnSpc>
+                <a:spcPct val="105000"/>
+              </a:lnSpc>
+              <a:spcAft>
+                <a:spcPts val="400"/>
+              </a:spcAft>
+            </a:pPr>
+            <a:r>
+              <a:rPr sz="1150" b="0" i="1">
+                <a:solidFill>
+                  <a:srgbClr val="6B7280"/>
+                </a:solidFill>
+                <a:latin typeface="Calibri"/>
+              </a:rPr>
+              <a:t>Honesty flags: Wilson intervals on the win rates overlap — claim is 'no evidence of drop-off,' not proof. And Brown's own 7-game solo cell was the matrix's best (6-1, +15.8). See slide 9.</a:t>
+            </a:r>
+          </a:p>
+        </p:txBody>
+      </p:sp>
+      <p:sp>
+        <p:nvSpPr>
+          <p:cNvPr id="13" name="TextBox 12"/>
           <p:cNvSpPr txBox="1"/>
           <p:nvPr/>
         </p:nvSpPr>
@@ -6072,7 +6530,7 @@
                 </a:solidFill>
                 <a:latin typeface="Calibri"/>
               </a:rPr>
-              <a:t>THE RETURN</a:t>
+              <a:t>THE CONTRACT</a:t>
             </a:r>
           </a:p>
         </p:txBody>
@@ -6114,59 +6572,35 @@
                 </a:solidFill>
                 <a:latin typeface="Cambria"/>
               </a:rPr>
-              <a:t>George is the cleaner stylistic fit — and the picks are the point</a:t>
-            </a:r>
-          </a:p>
-        </p:txBody>
-      </p:sp>
-      <p:sp>
-        <p:nvSpPr>
-          <p:cNvPr id="4" name="Rounded Rectangle 3"/>
-          <p:cNvSpPr/>
-          <p:nvPr/>
-        </p:nvSpPr>
-        <p:spPr>
-          <a:xfrm>
-            <a:off x="566928" y="1783080"/>
-            <a:ext cx="6583680" cy="3977639"/>
-          </a:xfrm>
-          <a:prstGeom prst="roundRect">
-            <a:avLst>
-              <a:gd name="adj" fmla="val 8000"/>
-            </a:avLst>
-          </a:prstGeom>
-          <a:solidFill>
-            <a:srgbClr val="FFFFFF"/>
-          </a:solidFill>
-          <a:ln w="12700">
-            <a:solidFill>
-              <a:srgbClr val="D7DAE0"/>
-            </a:solidFill>
-          </a:ln>
-          <a:effectLst/>
-        </p:spPr>
-        <p:style>
-          <a:lnRef idx="1">
-            <a:schemeClr val="accent1"/>
-          </a:lnRef>
-          <a:fillRef idx="3">
-            <a:schemeClr val="accent1"/>
-          </a:fillRef>
-          <a:effectRef idx="2">
-            <a:schemeClr val="accent1"/>
-          </a:effectRef>
-          <a:fontRef idx="minor">
-            <a:schemeClr val="lt1"/>
-          </a:fontRef>
-        </p:style>
-        <p:txBody>
-          <a:bodyPr rtlCol="0" anchor="ctr"/>
-          <a:lstStyle/>
-          <a:p>
-            <a:pPr algn="ctr"/>
-          </a:p>
-        </p:txBody>
-      </p:sp>
+              <a:t>Max-contract price, below-median-efficiency production</a:t>
+            </a:r>
+          </a:p>
+        </p:txBody>
+      </p:sp>
+      <p:pic>
+        <p:nvPicPr>
+          <p:cNvPr id="4" name="Picture 3" descr="efficiency_comps.png"/>
+          <p:cNvPicPr>
+            <a:picLocks noChangeAspect="1"/>
+          </p:cNvPicPr>
+          <p:nvPr/>
+        </p:nvPicPr>
+        <p:blipFill>
+          <a:blip r:embed="rId2"/>
+          <a:stretch>
+            <a:fillRect/>
+          </a:stretch>
+        </p:blipFill>
+        <p:spPr>
+          <a:xfrm>
+            <a:off x="1097280" y="1508760"/>
+            <a:ext cx="9966960" cy="4111782"/>
+          </a:xfrm>
+          <a:prstGeom prst="rect">
+            <a:avLst/>
+          </a:prstGeom>
+        </p:spPr>
+      </p:pic>
       <p:sp>
         <p:nvSpPr>
           <p:cNvPr id="5" name="TextBox 4"/>
@@ -6175,8 +6609,8 @@
         </p:nvSpPr>
         <p:spPr>
           <a:xfrm>
-            <a:off x="859536" y="1993392"/>
-            <a:ext cx="6035040" cy="365760"/>
+            <a:off x="566928" y="5806440"/>
+            <a:ext cx="11064240" cy="640080"/>
           </a:xfrm>
           <a:prstGeom prst="rect">
             <a:avLst/>
@@ -6191,20 +6625,29 @@
           <a:p>
             <a:pPr algn="l">
               <a:lnSpc>
-                <a:spcPct val="100000"/>
-              </a:lnSpc>
-              <a:spcAft>
-                <a:spcPts val="0"/>
-              </a:spcAft>
-            </a:pPr>
-            <a:r>
-              <a:rPr sz="1500" b="1" i="0">
-                <a:solidFill>
-                  <a:srgbClr val="0A2A1A"/>
-                </a:solidFill>
-                <a:latin typeface="Cambria"/>
-              </a:rPr>
-              <a:t>2025-26 shot profile</a:t>
+                <a:spcPct val="110000"/>
+              </a:lnSpc>
+              <a:spcAft>
+                <a:spcPts val="400"/>
+              </a:spcAft>
+            </a:pPr>
+            <a:r>
+              <a:rPr sz="1400" b="0" i="0">
+                <a:solidFill>
+                  <a:srgbClr val="20232A"/>
+                </a:solidFill>
+                <a:latin typeface="Calibri"/>
+              </a:rPr>
+              <a:t>6.9 WS on $53.1M = $7.7M per win share at 34% of the cap, with a 0.573 TS% — below the max-wing median. </a:t>
+            </a:r>
+            <a:r>
+              <a:rPr sz="1400" b="1" i="0">
+                <a:solidFill>
+                  <a:srgbClr val="007A33"/>
+                </a:solidFill>
+                <a:latin typeface="Calibri"/>
+              </a:rPr>
+              <a:t>Picks 15-30 buy the same wins at ~$2.1M/WS on rookie deals.</a:t>
             </a:r>
           </a:p>
         </p:txBody>
@@ -6212,995 +6655,6 @@
       <p:sp>
         <p:nvSpPr>
           <p:cNvPr id="6" name="TextBox 5"/>
-          <p:cNvSpPr txBox="1"/>
-          <p:nvPr/>
-        </p:nvSpPr>
-        <p:spPr>
-          <a:xfrm>
-            <a:off x="3566160" y="2395728"/>
-            <a:ext cx="1737360" cy="274320"/>
-          </a:xfrm>
-          <a:prstGeom prst="rect">
-            <a:avLst/>
-          </a:prstGeom>
-          <a:noFill/>
-        </p:spPr>
-        <p:txBody>
-          <a:bodyPr wrap="square" anchor="t" lIns="0" rIns="0" tIns="0" bIns="0">
-            <a:spAutoFit/>
-          </a:bodyPr>
-          <a:lstStyle/>
-          <a:p>
-            <a:pPr algn="l">
-              <a:lnSpc>
-                <a:spcPct val="100000"/>
-              </a:lnSpc>
-              <a:spcAft>
-                <a:spcPts val="0"/>
-              </a:spcAft>
-            </a:pPr>
-            <a:r>
-              <a:rPr sz="1150" b="1" i="0">
-                <a:solidFill>
-                  <a:srgbClr val="6B7280"/>
-                </a:solidFill>
-                <a:latin typeface="Calibri"/>
-              </a:rPr>
-              <a:t>BROWN</a:t>
-            </a:r>
-          </a:p>
-        </p:txBody>
-      </p:sp>
-      <p:sp>
-        <p:nvSpPr>
-          <p:cNvPr id="7" name="TextBox 6"/>
-          <p:cNvSpPr txBox="1"/>
-          <p:nvPr/>
-        </p:nvSpPr>
-        <p:spPr>
-          <a:xfrm>
-            <a:off x="5394960" y="2395728"/>
-            <a:ext cx="1737360" cy="274320"/>
-          </a:xfrm>
-          <a:prstGeom prst="rect">
-            <a:avLst/>
-          </a:prstGeom>
-          <a:noFill/>
-        </p:spPr>
-        <p:txBody>
-          <a:bodyPr wrap="square" anchor="t" lIns="0" rIns="0" tIns="0" bIns="0">
-            <a:spAutoFit/>
-          </a:bodyPr>
-          <a:lstStyle/>
-          <a:p>
-            <a:pPr algn="l">
-              <a:lnSpc>
-                <a:spcPct val="100000"/>
-              </a:lnSpc>
-              <a:spcAft>
-                <a:spcPts val="0"/>
-              </a:spcAft>
-            </a:pPr>
-            <a:r>
-              <a:rPr sz="1150" b="1" i="0">
-                <a:solidFill>
-                  <a:srgbClr val="007A33"/>
-                </a:solidFill>
-                <a:latin typeface="Calibri"/>
-              </a:rPr>
-              <a:t>GEORGE</a:t>
-            </a:r>
-          </a:p>
-        </p:txBody>
-      </p:sp>
-      <p:sp>
-        <p:nvSpPr>
-          <p:cNvPr id="8" name="TextBox 7"/>
-          <p:cNvSpPr txBox="1"/>
-          <p:nvPr/>
-        </p:nvSpPr>
-        <p:spPr>
-          <a:xfrm>
-            <a:off x="859536" y="2743200"/>
-            <a:ext cx="2651760" cy="320040"/>
-          </a:xfrm>
-          <a:prstGeom prst="rect">
-            <a:avLst/>
-          </a:prstGeom>
-          <a:noFill/>
-        </p:spPr>
-        <p:txBody>
-          <a:bodyPr wrap="square" anchor="t" lIns="0" rIns="0" tIns="0" bIns="0">
-            <a:spAutoFit/>
-          </a:bodyPr>
-          <a:lstStyle/>
-          <a:p>
-            <a:pPr algn="l">
-              <a:lnSpc>
-                <a:spcPct val="100000"/>
-              </a:lnSpc>
-              <a:spcAft>
-                <a:spcPts val="0"/>
-              </a:spcAft>
-            </a:pPr>
-            <a:r>
-              <a:rPr sz="1300" b="0" i="0">
-                <a:solidFill>
-                  <a:srgbClr val="20232A"/>
-                </a:solidFill>
-                <a:latin typeface="Calibri"/>
-              </a:rPr>
-              <a:t>3PT rate</a:t>
-            </a:r>
-          </a:p>
-        </p:txBody>
-      </p:sp>
-      <p:sp>
-        <p:nvSpPr>
-          <p:cNvPr id="9" name="TextBox 8"/>
-          <p:cNvSpPr txBox="1"/>
-          <p:nvPr/>
-        </p:nvSpPr>
-        <p:spPr>
-          <a:xfrm>
-            <a:off x="3566160" y="2743200"/>
-            <a:ext cx="1737360" cy="320040"/>
-          </a:xfrm>
-          <a:prstGeom prst="rect">
-            <a:avLst/>
-          </a:prstGeom>
-          <a:noFill/>
-        </p:spPr>
-        <p:txBody>
-          <a:bodyPr wrap="square" anchor="t" lIns="0" rIns="0" tIns="0" bIns="0">
-            <a:spAutoFit/>
-          </a:bodyPr>
-          <a:lstStyle/>
-          <a:p>
-            <a:pPr algn="l">
-              <a:lnSpc>
-                <a:spcPct val="100000"/>
-              </a:lnSpc>
-              <a:spcAft>
-                <a:spcPts val="0"/>
-              </a:spcAft>
-            </a:pPr>
-            <a:r>
-              <a:rPr sz="1350" b="1" i="0">
-                <a:solidFill>
-                  <a:srgbClr val="6B7280"/>
-                </a:solidFill>
-                <a:latin typeface="Calibri"/>
-              </a:rPr>
-              <a:t>0.262</a:t>
-            </a:r>
-          </a:p>
-        </p:txBody>
-      </p:sp>
-      <p:sp>
-        <p:nvSpPr>
-          <p:cNvPr id="10" name="TextBox 9"/>
-          <p:cNvSpPr txBox="1"/>
-          <p:nvPr/>
-        </p:nvSpPr>
-        <p:spPr>
-          <a:xfrm>
-            <a:off x="5394960" y="2743200"/>
-            <a:ext cx="1737360" cy="320040"/>
-          </a:xfrm>
-          <a:prstGeom prst="rect">
-            <a:avLst/>
-          </a:prstGeom>
-          <a:noFill/>
-        </p:spPr>
-        <p:txBody>
-          <a:bodyPr wrap="square" anchor="t" lIns="0" rIns="0" tIns="0" bIns="0">
-            <a:spAutoFit/>
-          </a:bodyPr>
-          <a:lstStyle/>
-          <a:p>
-            <a:pPr algn="l">
-              <a:lnSpc>
-                <a:spcPct val="100000"/>
-              </a:lnSpc>
-              <a:spcAft>
-                <a:spcPts val="0"/>
-              </a:spcAft>
-            </a:pPr>
-            <a:r>
-              <a:rPr sz="1350" b="1" i="0">
-                <a:solidFill>
-                  <a:srgbClr val="007A33"/>
-                </a:solidFill>
-                <a:latin typeface="Calibri"/>
-              </a:rPr>
-              <a:t>0.497</a:t>
-            </a:r>
-          </a:p>
-        </p:txBody>
-      </p:sp>
-      <p:sp>
-        <p:nvSpPr>
-          <p:cNvPr id="11" name="TextBox 10"/>
-          <p:cNvSpPr txBox="1"/>
-          <p:nvPr/>
-        </p:nvSpPr>
-        <p:spPr>
-          <a:xfrm>
-            <a:off x="859536" y="3291840"/>
-            <a:ext cx="2651760" cy="320040"/>
-          </a:xfrm>
-          <a:prstGeom prst="rect">
-            <a:avLst/>
-          </a:prstGeom>
-          <a:noFill/>
-        </p:spPr>
-        <p:txBody>
-          <a:bodyPr wrap="square" anchor="t" lIns="0" rIns="0" tIns="0" bIns="0">
-            <a:spAutoFit/>
-          </a:bodyPr>
-          <a:lstStyle/>
-          <a:p>
-            <a:pPr algn="l">
-              <a:lnSpc>
-                <a:spcPct val="100000"/>
-              </a:lnSpc>
-              <a:spcAft>
-                <a:spcPts val="0"/>
-              </a:spcAft>
-            </a:pPr>
-            <a:r>
-              <a:rPr sz="1300" b="0" i="0">
-                <a:solidFill>
-                  <a:srgbClr val="20232A"/>
-                </a:solidFill>
-                <a:latin typeface="Calibri"/>
-              </a:rPr>
-              <a:t>Catch-&amp;-shoot rate</a:t>
-            </a:r>
-          </a:p>
-        </p:txBody>
-      </p:sp>
-      <p:sp>
-        <p:nvSpPr>
-          <p:cNvPr id="12" name="TextBox 11"/>
-          <p:cNvSpPr txBox="1"/>
-          <p:nvPr/>
-        </p:nvSpPr>
-        <p:spPr>
-          <a:xfrm>
-            <a:off x="3566160" y="3291840"/>
-            <a:ext cx="1737360" cy="320040"/>
-          </a:xfrm>
-          <a:prstGeom prst="rect">
-            <a:avLst/>
-          </a:prstGeom>
-          <a:noFill/>
-        </p:spPr>
-        <p:txBody>
-          <a:bodyPr wrap="square" anchor="t" lIns="0" rIns="0" tIns="0" bIns="0">
-            <a:spAutoFit/>
-          </a:bodyPr>
-          <a:lstStyle/>
-          <a:p>
-            <a:pPr algn="l">
-              <a:lnSpc>
-                <a:spcPct val="100000"/>
-              </a:lnSpc>
-              <a:spcAft>
-                <a:spcPts val="0"/>
-              </a:spcAft>
-            </a:pPr>
-            <a:r>
-              <a:rPr sz="1350" b="1" i="0">
-                <a:solidFill>
-                  <a:srgbClr val="6B7280"/>
-                </a:solidFill>
-                <a:latin typeface="Calibri"/>
-              </a:rPr>
-              <a:t>0.163</a:t>
-            </a:r>
-          </a:p>
-        </p:txBody>
-      </p:sp>
-      <p:sp>
-        <p:nvSpPr>
-          <p:cNvPr id="13" name="TextBox 12"/>
-          <p:cNvSpPr txBox="1"/>
-          <p:nvPr/>
-        </p:nvSpPr>
-        <p:spPr>
-          <a:xfrm>
-            <a:off x="5394960" y="3291840"/>
-            <a:ext cx="1737360" cy="320040"/>
-          </a:xfrm>
-          <a:prstGeom prst="rect">
-            <a:avLst/>
-          </a:prstGeom>
-          <a:noFill/>
-        </p:spPr>
-        <p:txBody>
-          <a:bodyPr wrap="square" anchor="t" lIns="0" rIns="0" tIns="0" bIns="0">
-            <a:spAutoFit/>
-          </a:bodyPr>
-          <a:lstStyle/>
-          <a:p>
-            <a:pPr algn="l">
-              <a:lnSpc>
-                <a:spcPct val="100000"/>
-              </a:lnSpc>
-              <a:spcAft>
-                <a:spcPts val="0"/>
-              </a:spcAft>
-            </a:pPr>
-            <a:r>
-              <a:rPr sz="1350" b="1" i="0">
-                <a:solidFill>
-                  <a:srgbClr val="007A33"/>
-                </a:solidFill>
-                <a:latin typeface="Calibri"/>
-              </a:rPr>
-              <a:t>0.409</a:t>
-            </a:r>
-          </a:p>
-        </p:txBody>
-      </p:sp>
-      <p:sp>
-        <p:nvSpPr>
-          <p:cNvPr id="14" name="TextBox 13"/>
-          <p:cNvSpPr txBox="1"/>
-          <p:nvPr/>
-        </p:nvSpPr>
-        <p:spPr>
-          <a:xfrm>
-            <a:off x="859536" y="3840480"/>
-            <a:ext cx="2651760" cy="320040"/>
-          </a:xfrm>
-          <a:prstGeom prst="rect">
-            <a:avLst/>
-          </a:prstGeom>
-          <a:noFill/>
-        </p:spPr>
-        <p:txBody>
-          <a:bodyPr wrap="square" anchor="t" lIns="0" rIns="0" tIns="0" bIns="0">
-            <a:spAutoFit/>
-          </a:bodyPr>
-          <a:lstStyle/>
-          <a:p>
-            <a:pPr algn="l">
-              <a:lnSpc>
-                <a:spcPct val="100000"/>
-              </a:lnSpc>
-              <a:spcAft>
-                <a:spcPts val="0"/>
-              </a:spcAft>
-            </a:pPr>
-            <a:r>
-              <a:rPr sz="1300" b="0" i="0">
-                <a:solidFill>
-                  <a:srgbClr val="20232A"/>
-                </a:solidFill>
-                <a:latin typeface="Calibri"/>
-              </a:rPr>
-              <a:t>Iso / 3+ dribble rate</a:t>
-            </a:r>
-          </a:p>
-        </p:txBody>
-      </p:sp>
-      <p:sp>
-        <p:nvSpPr>
-          <p:cNvPr id="15" name="TextBox 14"/>
-          <p:cNvSpPr txBox="1"/>
-          <p:nvPr/>
-        </p:nvSpPr>
-        <p:spPr>
-          <a:xfrm>
-            <a:off x="3566160" y="3840480"/>
-            <a:ext cx="1737360" cy="320040"/>
-          </a:xfrm>
-          <a:prstGeom prst="rect">
-            <a:avLst/>
-          </a:prstGeom>
-          <a:noFill/>
-        </p:spPr>
-        <p:txBody>
-          <a:bodyPr wrap="square" anchor="t" lIns="0" rIns="0" tIns="0" bIns="0">
-            <a:spAutoFit/>
-          </a:bodyPr>
-          <a:lstStyle/>
-          <a:p>
-            <a:pPr algn="l">
-              <a:lnSpc>
-                <a:spcPct val="100000"/>
-              </a:lnSpc>
-              <a:spcAft>
-                <a:spcPts val="0"/>
-              </a:spcAft>
-            </a:pPr>
-            <a:r>
-              <a:rPr sz="1350" b="1" i="0">
-                <a:solidFill>
-                  <a:srgbClr val="6B7280"/>
-                </a:solidFill>
-                <a:latin typeface="Calibri"/>
-              </a:rPr>
-              <a:t>0.639</a:t>
-            </a:r>
-          </a:p>
-        </p:txBody>
-      </p:sp>
-      <p:sp>
-        <p:nvSpPr>
-          <p:cNvPr id="16" name="TextBox 15"/>
-          <p:cNvSpPr txBox="1"/>
-          <p:nvPr/>
-        </p:nvSpPr>
-        <p:spPr>
-          <a:xfrm>
-            <a:off x="5394960" y="3840480"/>
-            <a:ext cx="1737360" cy="320040"/>
-          </a:xfrm>
-          <a:prstGeom prst="rect">
-            <a:avLst/>
-          </a:prstGeom>
-          <a:noFill/>
-        </p:spPr>
-        <p:txBody>
-          <a:bodyPr wrap="square" anchor="t" lIns="0" rIns="0" tIns="0" bIns="0">
-            <a:spAutoFit/>
-          </a:bodyPr>
-          <a:lstStyle/>
-          <a:p>
-            <a:pPr algn="l">
-              <a:lnSpc>
-                <a:spcPct val="100000"/>
-              </a:lnSpc>
-              <a:spcAft>
-                <a:spcPts val="0"/>
-              </a:spcAft>
-            </a:pPr>
-            <a:r>
-              <a:rPr sz="1350" b="1" i="0">
-                <a:solidFill>
-                  <a:srgbClr val="007A33"/>
-                </a:solidFill>
-                <a:latin typeface="Calibri"/>
-              </a:rPr>
-              <a:t>0.404</a:t>
-            </a:r>
-          </a:p>
-        </p:txBody>
-      </p:sp>
-      <p:sp>
-        <p:nvSpPr>
-          <p:cNvPr id="17" name="TextBox 16"/>
-          <p:cNvSpPr txBox="1"/>
-          <p:nvPr/>
-        </p:nvSpPr>
-        <p:spPr>
-          <a:xfrm>
-            <a:off x="859536" y="4389120"/>
-            <a:ext cx="2651760" cy="320040"/>
-          </a:xfrm>
-          <a:prstGeom prst="rect">
-            <a:avLst/>
-          </a:prstGeom>
-          <a:noFill/>
-        </p:spPr>
-        <p:txBody>
-          <a:bodyPr wrap="square" anchor="t" lIns="0" rIns="0" tIns="0" bIns="0">
-            <a:spAutoFit/>
-          </a:bodyPr>
-          <a:lstStyle/>
-          <a:p>
-            <a:pPr algn="l">
-              <a:lnSpc>
-                <a:spcPct val="100000"/>
-              </a:lnSpc>
-              <a:spcAft>
-                <a:spcPts val="0"/>
-              </a:spcAft>
-            </a:pPr>
-            <a:r>
-              <a:rPr sz="1300" b="0" i="0">
-                <a:solidFill>
-                  <a:srgbClr val="20232A"/>
-                </a:solidFill>
-                <a:latin typeface="Calibri"/>
-              </a:rPr>
-              <a:t>Contested-shot rate</a:t>
-            </a:r>
-          </a:p>
-        </p:txBody>
-      </p:sp>
-      <p:sp>
-        <p:nvSpPr>
-          <p:cNvPr id="18" name="TextBox 17"/>
-          <p:cNvSpPr txBox="1"/>
-          <p:nvPr/>
-        </p:nvSpPr>
-        <p:spPr>
-          <a:xfrm>
-            <a:off x="3566160" y="4389120"/>
-            <a:ext cx="1737360" cy="320040"/>
-          </a:xfrm>
-          <a:prstGeom prst="rect">
-            <a:avLst/>
-          </a:prstGeom>
-          <a:noFill/>
-        </p:spPr>
-        <p:txBody>
-          <a:bodyPr wrap="square" anchor="t" lIns="0" rIns="0" tIns="0" bIns="0">
-            <a:spAutoFit/>
-          </a:bodyPr>
-          <a:lstStyle/>
-          <a:p>
-            <a:pPr algn="l">
-              <a:lnSpc>
-                <a:spcPct val="100000"/>
-              </a:lnSpc>
-              <a:spcAft>
-                <a:spcPts val="0"/>
-              </a:spcAft>
-            </a:pPr>
-            <a:r>
-              <a:rPr sz="1350" b="1" i="0">
-                <a:solidFill>
-                  <a:srgbClr val="6B7280"/>
-                </a:solidFill>
-                <a:latin typeface="Calibri"/>
-              </a:rPr>
-              <a:t>0.517</a:t>
-            </a:r>
-          </a:p>
-        </p:txBody>
-      </p:sp>
-      <p:sp>
-        <p:nvSpPr>
-          <p:cNvPr id="19" name="TextBox 18"/>
-          <p:cNvSpPr txBox="1"/>
-          <p:nvPr/>
-        </p:nvSpPr>
-        <p:spPr>
-          <a:xfrm>
-            <a:off x="5394960" y="4389120"/>
-            <a:ext cx="1737360" cy="320040"/>
-          </a:xfrm>
-          <a:prstGeom prst="rect">
-            <a:avLst/>
-          </a:prstGeom>
-          <a:noFill/>
-        </p:spPr>
-        <p:txBody>
-          <a:bodyPr wrap="square" anchor="t" lIns="0" rIns="0" tIns="0" bIns="0">
-            <a:spAutoFit/>
-          </a:bodyPr>
-          <a:lstStyle/>
-          <a:p>
-            <a:pPr algn="l">
-              <a:lnSpc>
-                <a:spcPct val="100000"/>
-              </a:lnSpc>
-              <a:spcAft>
-                <a:spcPts val="0"/>
-              </a:spcAft>
-            </a:pPr>
-            <a:r>
-              <a:rPr sz="1350" b="1" i="0">
-                <a:solidFill>
-                  <a:srgbClr val="007A33"/>
-                </a:solidFill>
-                <a:latin typeface="Calibri"/>
-              </a:rPr>
-              <a:t>0.370</a:t>
-            </a:r>
-          </a:p>
-        </p:txBody>
-      </p:sp>
-      <p:sp>
-        <p:nvSpPr>
-          <p:cNvPr id="20" name="TextBox 19"/>
-          <p:cNvSpPr txBox="1"/>
-          <p:nvPr/>
-        </p:nvSpPr>
-        <p:spPr>
-          <a:xfrm>
-            <a:off x="859536" y="4937759"/>
-            <a:ext cx="2651760" cy="320040"/>
-          </a:xfrm>
-          <a:prstGeom prst="rect">
-            <a:avLst/>
-          </a:prstGeom>
-          <a:noFill/>
-        </p:spPr>
-        <p:txBody>
-          <a:bodyPr wrap="square" anchor="t" lIns="0" rIns="0" tIns="0" bIns="0">
-            <a:spAutoFit/>
-          </a:bodyPr>
-          <a:lstStyle/>
-          <a:p>
-            <a:pPr algn="l">
-              <a:lnSpc>
-                <a:spcPct val="100000"/>
-              </a:lnSpc>
-              <a:spcAft>
-                <a:spcPts val="0"/>
-              </a:spcAft>
-            </a:pPr>
-            <a:r>
-              <a:rPr sz="1300" b="0" i="0">
-                <a:solidFill>
-                  <a:srgbClr val="20232A"/>
-                </a:solidFill>
-                <a:latin typeface="Calibri"/>
-              </a:rPr>
-              <a:t>Bad-shot index</a:t>
-            </a:r>
-          </a:p>
-        </p:txBody>
-      </p:sp>
-      <p:sp>
-        <p:nvSpPr>
-          <p:cNvPr id="21" name="TextBox 20"/>
-          <p:cNvSpPr txBox="1"/>
-          <p:nvPr/>
-        </p:nvSpPr>
-        <p:spPr>
-          <a:xfrm>
-            <a:off x="3566160" y="4937759"/>
-            <a:ext cx="1737360" cy="320040"/>
-          </a:xfrm>
-          <a:prstGeom prst="rect">
-            <a:avLst/>
-          </a:prstGeom>
-          <a:noFill/>
-        </p:spPr>
-        <p:txBody>
-          <a:bodyPr wrap="square" anchor="t" lIns="0" rIns="0" tIns="0" bIns="0">
-            <a:spAutoFit/>
-          </a:bodyPr>
-          <a:lstStyle/>
-          <a:p>
-            <a:pPr algn="l">
-              <a:lnSpc>
-                <a:spcPct val="100000"/>
-              </a:lnSpc>
-              <a:spcAft>
-                <a:spcPts val="0"/>
-              </a:spcAft>
-            </a:pPr>
-            <a:r>
-              <a:rPr sz="1350" b="1" i="0">
-                <a:solidFill>
-                  <a:srgbClr val="6B7280"/>
-                </a:solidFill>
-                <a:latin typeface="Calibri"/>
-              </a:rPr>
-              <a:t>0.379</a:t>
-            </a:r>
-          </a:p>
-        </p:txBody>
-      </p:sp>
-      <p:sp>
-        <p:nvSpPr>
-          <p:cNvPr id="22" name="TextBox 21"/>
-          <p:cNvSpPr txBox="1"/>
-          <p:nvPr/>
-        </p:nvSpPr>
-        <p:spPr>
-          <a:xfrm>
-            <a:off x="5394960" y="4937759"/>
-            <a:ext cx="1737360" cy="320040"/>
-          </a:xfrm>
-          <a:prstGeom prst="rect">
-            <a:avLst/>
-          </a:prstGeom>
-          <a:noFill/>
-        </p:spPr>
-        <p:txBody>
-          <a:bodyPr wrap="square" anchor="t" lIns="0" rIns="0" tIns="0" bIns="0">
-            <a:spAutoFit/>
-          </a:bodyPr>
-          <a:lstStyle/>
-          <a:p>
-            <a:pPr algn="l">
-              <a:lnSpc>
-                <a:spcPct val="100000"/>
-              </a:lnSpc>
-              <a:spcAft>
-                <a:spcPts val="0"/>
-              </a:spcAft>
-            </a:pPr>
-            <a:r>
-              <a:rPr sz="1350" b="1" i="0">
-                <a:solidFill>
-                  <a:srgbClr val="007A33"/>
-                </a:solidFill>
-                <a:latin typeface="Calibri"/>
-              </a:rPr>
-              <a:t>0.273</a:t>
-            </a:r>
-          </a:p>
-        </p:txBody>
-      </p:sp>
-      <p:sp>
-        <p:nvSpPr>
-          <p:cNvPr id="23" name="TextBox 22"/>
-          <p:cNvSpPr txBox="1"/>
-          <p:nvPr/>
-        </p:nvSpPr>
-        <p:spPr>
-          <a:xfrm>
-            <a:off x="859536" y="5138928"/>
-            <a:ext cx="6035040" cy="457200"/>
-          </a:xfrm>
-          <a:prstGeom prst="rect">
-            <a:avLst/>
-          </a:prstGeom>
-          <a:noFill/>
-        </p:spPr>
-        <p:txBody>
-          <a:bodyPr wrap="square" anchor="t" lIns="0" rIns="0" tIns="0" bIns="0">
-            <a:spAutoFit/>
-          </a:bodyPr>
-          <a:lstStyle/>
-          <a:p>
-            <a:pPr algn="l">
-              <a:lnSpc>
-                <a:spcPct val="105000"/>
-              </a:lnSpc>
-              <a:spcAft>
-                <a:spcPts val="400"/>
-              </a:spcAft>
-            </a:pPr>
-            <a:r>
-              <a:rPr sz="1150" b="0" i="1">
-                <a:solidFill>
-                  <a:srgbClr val="6B7280"/>
-                </a:solidFill>
-                <a:latin typeface="Calibri"/>
-              </a:rPr>
-              <a:t>George takes the shots the system is built to generate — he plugs in instead of stopping it.</a:t>
-            </a:r>
-          </a:p>
-        </p:txBody>
-      </p:sp>
-      <p:sp>
-        <p:nvSpPr>
-          <p:cNvPr id="24" name="Rounded Rectangle 23"/>
-          <p:cNvSpPr/>
-          <p:nvPr/>
-        </p:nvSpPr>
-        <p:spPr>
-          <a:xfrm>
-            <a:off x="7452360" y="1783080"/>
-            <a:ext cx="4160520" cy="3977639"/>
-          </a:xfrm>
-          <a:prstGeom prst="roundRect">
-            <a:avLst>
-              <a:gd name="adj" fmla="val 8000"/>
-            </a:avLst>
-          </a:prstGeom>
-          <a:solidFill>
-            <a:srgbClr val="0A2A1A"/>
-          </a:solidFill>
-          <a:ln>
-            <a:noFill/>
-          </a:ln>
-          <a:effectLst/>
-        </p:spPr>
-        <p:style>
-          <a:lnRef idx="1">
-            <a:schemeClr val="accent1"/>
-          </a:lnRef>
-          <a:fillRef idx="3">
-            <a:schemeClr val="accent1"/>
-          </a:fillRef>
-          <a:effectRef idx="2">
-            <a:schemeClr val="accent1"/>
-          </a:effectRef>
-          <a:fontRef idx="minor">
-            <a:schemeClr val="lt1"/>
-          </a:fontRef>
-        </p:style>
-        <p:txBody>
-          <a:bodyPr rtlCol="0" anchor="ctr"/>
-          <a:lstStyle/>
-          <a:p>
-            <a:pPr algn="ctr"/>
-          </a:p>
-        </p:txBody>
-      </p:sp>
-      <p:sp>
-        <p:nvSpPr>
-          <p:cNvPr id="25" name="TextBox 24"/>
-          <p:cNvSpPr txBox="1"/>
-          <p:nvPr/>
-        </p:nvSpPr>
-        <p:spPr>
-          <a:xfrm>
-            <a:off x="7726679" y="2011680"/>
-            <a:ext cx="3657600" cy="365760"/>
-          </a:xfrm>
-          <a:prstGeom prst="rect">
-            <a:avLst/>
-          </a:prstGeom>
-          <a:noFill/>
-        </p:spPr>
-        <p:txBody>
-          <a:bodyPr wrap="square" anchor="t" lIns="0" rIns="0" tIns="0" bIns="0">
-            <a:spAutoFit/>
-          </a:bodyPr>
-          <a:lstStyle/>
-          <a:p>
-            <a:pPr algn="l">
-              <a:lnSpc>
-                <a:spcPct val="100000"/>
-              </a:lnSpc>
-              <a:spcAft>
-                <a:spcPts val="0"/>
-              </a:spcAft>
-            </a:pPr>
-            <a:r>
-              <a:rPr sz="1250" b="1" i="0">
-                <a:solidFill>
-                  <a:srgbClr val="BCD3C6"/>
-                </a:solidFill>
-                <a:latin typeface="Calibri"/>
-              </a:rPr>
-              <a:t>PLUS THE PICKS</a:t>
-            </a:r>
-          </a:p>
-        </p:txBody>
-      </p:sp>
-      <p:sp>
-        <p:nvSpPr>
-          <p:cNvPr id="26" name="TextBox 25"/>
-          <p:cNvSpPr txBox="1"/>
-          <p:nvPr/>
-        </p:nvSpPr>
-        <p:spPr>
-          <a:xfrm>
-            <a:off x="7726679" y="2468880"/>
-            <a:ext cx="3657600" cy="914400"/>
-          </a:xfrm>
-          <a:prstGeom prst="rect">
-            <a:avLst/>
-          </a:prstGeom>
-          <a:noFill/>
-        </p:spPr>
-        <p:txBody>
-          <a:bodyPr wrap="square" anchor="t" lIns="0" rIns="0" tIns="0" bIns="0">
-            <a:spAutoFit/>
-          </a:bodyPr>
-          <a:lstStyle/>
-          <a:p>
-            <a:pPr algn="l">
-              <a:lnSpc>
-                <a:spcPct val="105000"/>
-              </a:lnSpc>
-              <a:spcAft>
-                <a:spcPts val="200"/>
-              </a:spcAft>
-            </a:pPr>
-            <a:r>
-              <a:rPr sz="2000" b="1" i="0">
-                <a:solidFill>
-                  <a:srgbClr val="FFFFFF"/>
-                </a:solidFill>
-                <a:latin typeface="Cambria"/>
-              </a:rPr>
-              <a:t>2028 first + 2031</a:t>
-            </a:r>
-          </a:p>
-          <a:p>
-            <a:pPr algn="l">
-              <a:lnSpc>
-                <a:spcPct val="105000"/>
-              </a:lnSpc>
-              <a:spcAft>
-                <a:spcPts val="200"/>
-              </a:spcAft>
-            </a:pPr>
-            <a:r>
-              <a:rPr sz="2000" b="1" i="0">
-                <a:solidFill>
-                  <a:srgbClr val="FFFFFF"/>
-                </a:solidFill>
-                <a:latin typeface="Cambria"/>
-              </a:rPr>
-              <a:t>unprotected first</a:t>
-            </a:r>
-          </a:p>
-        </p:txBody>
-      </p:sp>
-      <p:sp>
-        <p:nvSpPr>
-          <p:cNvPr id="27" name="TextBox 26"/>
-          <p:cNvSpPr txBox="1"/>
-          <p:nvPr/>
-        </p:nvSpPr>
-        <p:spPr>
-          <a:xfrm>
-            <a:off x="7726679" y="3520440"/>
-            <a:ext cx="3657600" cy="1463040"/>
-          </a:xfrm>
-          <a:prstGeom prst="rect">
-            <a:avLst/>
-          </a:prstGeom>
-          <a:noFill/>
-        </p:spPr>
-        <p:txBody>
-          <a:bodyPr wrap="square" anchor="t" lIns="0" rIns="0" tIns="0" bIns="0">
-            <a:spAutoFit/>
-          </a:bodyPr>
-          <a:lstStyle/>
-          <a:p>
-            <a:pPr algn="l">
-              <a:lnSpc>
-                <a:spcPct val="115000"/>
-              </a:lnSpc>
-              <a:spcAft>
-                <a:spcPts val="400"/>
-              </a:spcAft>
-            </a:pPr>
-            <a:r>
-              <a:rPr sz="1250" b="0" i="0">
-                <a:solidFill>
-                  <a:srgbClr val="CFE0D6"/>
-                </a:solidFill>
-                <a:latin typeface="Calibri"/>
-              </a:rPr>
-              <a:t>Under the post-2019 flattened lottery — exact odds enumerated across all 24,024 seed permutations — late-lottery firsts convey materially more top-4 equity than the old system.</a:t>
-            </a:r>
-          </a:p>
-        </p:txBody>
-      </p:sp>
-      <p:sp>
-        <p:nvSpPr>
-          <p:cNvPr id="28" name="TextBox 27"/>
-          <p:cNvSpPr txBox="1"/>
-          <p:nvPr/>
-        </p:nvSpPr>
-        <p:spPr>
-          <a:xfrm>
-            <a:off x="7726679" y="5074920"/>
-            <a:ext cx="3657600" cy="548640"/>
-          </a:xfrm>
-          <a:prstGeom prst="rect">
-            <a:avLst/>
-          </a:prstGeom>
-          <a:noFill/>
-        </p:spPr>
-        <p:txBody>
-          <a:bodyPr wrap="square" anchor="t" lIns="0" rIns="0" tIns="0" bIns="0">
-            <a:spAutoFit/>
-          </a:bodyPr>
-          <a:lstStyle/>
-          <a:p>
-            <a:pPr algn="l">
-              <a:lnSpc>
-                <a:spcPct val="108000"/>
-              </a:lnSpc>
-              <a:spcAft>
-                <a:spcPts val="400"/>
-              </a:spcAft>
-            </a:pPr>
-            <a:r>
-              <a:rPr sz="1150" b="0" i="1">
-                <a:solidFill>
-                  <a:srgbClr val="9AB2A4"/>
-                </a:solidFill>
-                <a:latin typeface="Calibri"/>
-              </a:rPr>
-              <a:t>Cheap, controllable, tradeable — the assets a capped-out roster can't otherwise get.</a:t>
-            </a:r>
-          </a:p>
-        </p:txBody>
-      </p:sp>
-      <p:sp>
-        <p:nvSpPr>
-          <p:cNvPr id="29" name="TextBox 28"/>
           <p:cNvSpPr txBox="1"/>
           <p:nvPr/>
         </p:nvSpPr>
@@ -7312,7 +6766,7 @@
                 </a:solidFill>
                 <a:latin typeface="Calibri"/>
               </a:rPr>
-              <a:t>WHERE THE CASE IS WEAKEST</a:t>
+              <a:t>THE RETURN</a:t>
             </a:r>
           </a:p>
         </p:txBody>
@@ -7354,7 +6808,7 @@
                 </a:solidFill>
                 <a:latin typeface="Cambria"/>
               </a:rPr>
-              <a:t>The counter-evidence, on the record</a:t>
+              <a:t>George is the cleaner stylistic fit — and the picks are the point</a:t>
             </a:r>
           </a:p>
         </p:txBody>
@@ -7367,8 +6821,8 @@
         </p:nvSpPr>
         <p:spPr>
           <a:xfrm>
-            <a:off x="566928" y="1874519"/>
-            <a:ext cx="3502152" cy="3017520"/>
+            <a:off x="566928" y="1783080"/>
+            <a:ext cx="6583680" cy="3977639"/>
           </a:xfrm>
           <a:prstGeom prst="roundRect">
             <a:avLst>
@@ -7409,20 +6863,820 @@
       </p:sp>
       <p:sp>
         <p:nvSpPr>
-          <p:cNvPr id="5" name="Oval 4"/>
+          <p:cNvPr id="5" name="TextBox 4"/>
+          <p:cNvSpPr txBox="1"/>
+          <p:nvPr/>
+        </p:nvSpPr>
+        <p:spPr>
+          <a:xfrm>
+            <a:off x="859536" y="1993392"/>
+            <a:ext cx="6035040" cy="365760"/>
+          </a:xfrm>
+          <a:prstGeom prst="rect">
+            <a:avLst/>
+          </a:prstGeom>
+          <a:noFill/>
+        </p:spPr>
+        <p:txBody>
+          <a:bodyPr wrap="square" anchor="t" lIns="0" rIns="0" tIns="0" bIns="0">
+            <a:spAutoFit/>
+          </a:bodyPr>
+          <a:lstStyle/>
+          <a:p>
+            <a:pPr algn="l">
+              <a:lnSpc>
+                <a:spcPct val="100000"/>
+              </a:lnSpc>
+              <a:spcAft>
+                <a:spcPts val="0"/>
+              </a:spcAft>
+            </a:pPr>
+            <a:r>
+              <a:rPr sz="1500" b="1" i="0">
+                <a:solidFill>
+                  <a:srgbClr val="0A2A1A"/>
+                </a:solidFill>
+                <a:latin typeface="Cambria"/>
+              </a:rPr>
+              <a:t>2025-26 shot profile</a:t>
+            </a:r>
+          </a:p>
+        </p:txBody>
+      </p:sp>
+      <p:sp>
+        <p:nvSpPr>
+          <p:cNvPr id="6" name="TextBox 5"/>
+          <p:cNvSpPr txBox="1"/>
+          <p:nvPr/>
+        </p:nvSpPr>
+        <p:spPr>
+          <a:xfrm>
+            <a:off x="3566160" y="2395728"/>
+            <a:ext cx="1737360" cy="274320"/>
+          </a:xfrm>
+          <a:prstGeom prst="rect">
+            <a:avLst/>
+          </a:prstGeom>
+          <a:noFill/>
+        </p:spPr>
+        <p:txBody>
+          <a:bodyPr wrap="square" anchor="t" lIns="0" rIns="0" tIns="0" bIns="0">
+            <a:spAutoFit/>
+          </a:bodyPr>
+          <a:lstStyle/>
+          <a:p>
+            <a:pPr algn="l">
+              <a:lnSpc>
+                <a:spcPct val="100000"/>
+              </a:lnSpc>
+              <a:spcAft>
+                <a:spcPts val="0"/>
+              </a:spcAft>
+            </a:pPr>
+            <a:r>
+              <a:rPr sz="1150" b="1" i="0">
+                <a:solidFill>
+                  <a:srgbClr val="6B7280"/>
+                </a:solidFill>
+                <a:latin typeface="Calibri"/>
+              </a:rPr>
+              <a:t>BROWN</a:t>
+            </a:r>
+          </a:p>
+        </p:txBody>
+      </p:sp>
+      <p:sp>
+        <p:nvSpPr>
+          <p:cNvPr id="7" name="TextBox 6"/>
+          <p:cNvSpPr txBox="1"/>
+          <p:nvPr/>
+        </p:nvSpPr>
+        <p:spPr>
+          <a:xfrm>
+            <a:off x="5394960" y="2395728"/>
+            <a:ext cx="1737360" cy="274320"/>
+          </a:xfrm>
+          <a:prstGeom prst="rect">
+            <a:avLst/>
+          </a:prstGeom>
+          <a:noFill/>
+        </p:spPr>
+        <p:txBody>
+          <a:bodyPr wrap="square" anchor="t" lIns="0" rIns="0" tIns="0" bIns="0">
+            <a:spAutoFit/>
+          </a:bodyPr>
+          <a:lstStyle/>
+          <a:p>
+            <a:pPr algn="l">
+              <a:lnSpc>
+                <a:spcPct val="100000"/>
+              </a:lnSpc>
+              <a:spcAft>
+                <a:spcPts val="0"/>
+              </a:spcAft>
+            </a:pPr>
+            <a:r>
+              <a:rPr sz="1150" b="1" i="0">
+                <a:solidFill>
+                  <a:srgbClr val="007A33"/>
+                </a:solidFill>
+                <a:latin typeface="Calibri"/>
+              </a:rPr>
+              <a:t>GEORGE</a:t>
+            </a:r>
+          </a:p>
+        </p:txBody>
+      </p:sp>
+      <p:sp>
+        <p:nvSpPr>
+          <p:cNvPr id="8" name="TextBox 7"/>
+          <p:cNvSpPr txBox="1"/>
+          <p:nvPr/>
+        </p:nvSpPr>
+        <p:spPr>
+          <a:xfrm>
+            <a:off x="859536" y="2743200"/>
+            <a:ext cx="2651760" cy="320040"/>
+          </a:xfrm>
+          <a:prstGeom prst="rect">
+            <a:avLst/>
+          </a:prstGeom>
+          <a:noFill/>
+        </p:spPr>
+        <p:txBody>
+          <a:bodyPr wrap="square" anchor="t" lIns="0" rIns="0" tIns="0" bIns="0">
+            <a:spAutoFit/>
+          </a:bodyPr>
+          <a:lstStyle/>
+          <a:p>
+            <a:pPr algn="l">
+              <a:lnSpc>
+                <a:spcPct val="100000"/>
+              </a:lnSpc>
+              <a:spcAft>
+                <a:spcPts val="0"/>
+              </a:spcAft>
+            </a:pPr>
+            <a:r>
+              <a:rPr sz="1300" b="0" i="0">
+                <a:solidFill>
+                  <a:srgbClr val="20232A"/>
+                </a:solidFill>
+                <a:latin typeface="Calibri"/>
+              </a:rPr>
+              <a:t>3PT rate</a:t>
+            </a:r>
+          </a:p>
+        </p:txBody>
+      </p:sp>
+      <p:sp>
+        <p:nvSpPr>
+          <p:cNvPr id="9" name="TextBox 8"/>
+          <p:cNvSpPr txBox="1"/>
+          <p:nvPr/>
+        </p:nvSpPr>
+        <p:spPr>
+          <a:xfrm>
+            <a:off x="3566160" y="2743200"/>
+            <a:ext cx="1737360" cy="320040"/>
+          </a:xfrm>
+          <a:prstGeom prst="rect">
+            <a:avLst/>
+          </a:prstGeom>
+          <a:noFill/>
+        </p:spPr>
+        <p:txBody>
+          <a:bodyPr wrap="square" anchor="t" lIns="0" rIns="0" tIns="0" bIns="0">
+            <a:spAutoFit/>
+          </a:bodyPr>
+          <a:lstStyle/>
+          <a:p>
+            <a:pPr algn="l">
+              <a:lnSpc>
+                <a:spcPct val="100000"/>
+              </a:lnSpc>
+              <a:spcAft>
+                <a:spcPts val="0"/>
+              </a:spcAft>
+            </a:pPr>
+            <a:r>
+              <a:rPr sz="1350" b="1" i="0">
+                <a:solidFill>
+                  <a:srgbClr val="6B7280"/>
+                </a:solidFill>
+                <a:latin typeface="Calibri"/>
+              </a:rPr>
+              <a:t>0.262</a:t>
+            </a:r>
+          </a:p>
+        </p:txBody>
+      </p:sp>
+      <p:sp>
+        <p:nvSpPr>
+          <p:cNvPr id="10" name="TextBox 9"/>
+          <p:cNvSpPr txBox="1"/>
+          <p:nvPr/>
+        </p:nvSpPr>
+        <p:spPr>
+          <a:xfrm>
+            <a:off x="5394960" y="2743200"/>
+            <a:ext cx="1737360" cy="320040"/>
+          </a:xfrm>
+          <a:prstGeom prst="rect">
+            <a:avLst/>
+          </a:prstGeom>
+          <a:noFill/>
+        </p:spPr>
+        <p:txBody>
+          <a:bodyPr wrap="square" anchor="t" lIns="0" rIns="0" tIns="0" bIns="0">
+            <a:spAutoFit/>
+          </a:bodyPr>
+          <a:lstStyle/>
+          <a:p>
+            <a:pPr algn="l">
+              <a:lnSpc>
+                <a:spcPct val="100000"/>
+              </a:lnSpc>
+              <a:spcAft>
+                <a:spcPts val="0"/>
+              </a:spcAft>
+            </a:pPr>
+            <a:r>
+              <a:rPr sz="1350" b="1" i="0">
+                <a:solidFill>
+                  <a:srgbClr val="007A33"/>
+                </a:solidFill>
+                <a:latin typeface="Calibri"/>
+              </a:rPr>
+              <a:t>0.497</a:t>
+            </a:r>
+          </a:p>
+        </p:txBody>
+      </p:sp>
+      <p:sp>
+        <p:nvSpPr>
+          <p:cNvPr id="11" name="TextBox 10"/>
+          <p:cNvSpPr txBox="1"/>
+          <p:nvPr/>
+        </p:nvSpPr>
+        <p:spPr>
+          <a:xfrm>
+            <a:off x="859536" y="3291840"/>
+            <a:ext cx="2651760" cy="320040"/>
+          </a:xfrm>
+          <a:prstGeom prst="rect">
+            <a:avLst/>
+          </a:prstGeom>
+          <a:noFill/>
+        </p:spPr>
+        <p:txBody>
+          <a:bodyPr wrap="square" anchor="t" lIns="0" rIns="0" tIns="0" bIns="0">
+            <a:spAutoFit/>
+          </a:bodyPr>
+          <a:lstStyle/>
+          <a:p>
+            <a:pPr algn="l">
+              <a:lnSpc>
+                <a:spcPct val="100000"/>
+              </a:lnSpc>
+              <a:spcAft>
+                <a:spcPts val="0"/>
+              </a:spcAft>
+            </a:pPr>
+            <a:r>
+              <a:rPr sz="1300" b="0" i="0">
+                <a:solidFill>
+                  <a:srgbClr val="20232A"/>
+                </a:solidFill>
+                <a:latin typeface="Calibri"/>
+              </a:rPr>
+              <a:t>Catch-&amp;-shoot rate</a:t>
+            </a:r>
+          </a:p>
+        </p:txBody>
+      </p:sp>
+      <p:sp>
+        <p:nvSpPr>
+          <p:cNvPr id="12" name="TextBox 11"/>
+          <p:cNvSpPr txBox="1"/>
+          <p:nvPr/>
+        </p:nvSpPr>
+        <p:spPr>
+          <a:xfrm>
+            <a:off x="3566160" y="3291840"/>
+            <a:ext cx="1737360" cy="320040"/>
+          </a:xfrm>
+          <a:prstGeom prst="rect">
+            <a:avLst/>
+          </a:prstGeom>
+          <a:noFill/>
+        </p:spPr>
+        <p:txBody>
+          <a:bodyPr wrap="square" anchor="t" lIns="0" rIns="0" tIns="0" bIns="0">
+            <a:spAutoFit/>
+          </a:bodyPr>
+          <a:lstStyle/>
+          <a:p>
+            <a:pPr algn="l">
+              <a:lnSpc>
+                <a:spcPct val="100000"/>
+              </a:lnSpc>
+              <a:spcAft>
+                <a:spcPts val="0"/>
+              </a:spcAft>
+            </a:pPr>
+            <a:r>
+              <a:rPr sz="1350" b="1" i="0">
+                <a:solidFill>
+                  <a:srgbClr val="6B7280"/>
+                </a:solidFill>
+                <a:latin typeface="Calibri"/>
+              </a:rPr>
+              <a:t>0.163</a:t>
+            </a:r>
+          </a:p>
+        </p:txBody>
+      </p:sp>
+      <p:sp>
+        <p:nvSpPr>
+          <p:cNvPr id="13" name="TextBox 12"/>
+          <p:cNvSpPr txBox="1"/>
+          <p:nvPr/>
+        </p:nvSpPr>
+        <p:spPr>
+          <a:xfrm>
+            <a:off x="5394960" y="3291840"/>
+            <a:ext cx="1737360" cy="320040"/>
+          </a:xfrm>
+          <a:prstGeom prst="rect">
+            <a:avLst/>
+          </a:prstGeom>
+          <a:noFill/>
+        </p:spPr>
+        <p:txBody>
+          <a:bodyPr wrap="square" anchor="t" lIns="0" rIns="0" tIns="0" bIns="0">
+            <a:spAutoFit/>
+          </a:bodyPr>
+          <a:lstStyle/>
+          <a:p>
+            <a:pPr algn="l">
+              <a:lnSpc>
+                <a:spcPct val="100000"/>
+              </a:lnSpc>
+              <a:spcAft>
+                <a:spcPts val="0"/>
+              </a:spcAft>
+            </a:pPr>
+            <a:r>
+              <a:rPr sz="1350" b="1" i="0">
+                <a:solidFill>
+                  <a:srgbClr val="007A33"/>
+                </a:solidFill>
+                <a:latin typeface="Calibri"/>
+              </a:rPr>
+              <a:t>0.409</a:t>
+            </a:r>
+          </a:p>
+        </p:txBody>
+      </p:sp>
+      <p:sp>
+        <p:nvSpPr>
+          <p:cNvPr id="14" name="TextBox 13"/>
+          <p:cNvSpPr txBox="1"/>
+          <p:nvPr/>
+        </p:nvSpPr>
+        <p:spPr>
+          <a:xfrm>
+            <a:off x="859536" y="3840480"/>
+            <a:ext cx="2651760" cy="320040"/>
+          </a:xfrm>
+          <a:prstGeom prst="rect">
+            <a:avLst/>
+          </a:prstGeom>
+          <a:noFill/>
+        </p:spPr>
+        <p:txBody>
+          <a:bodyPr wrap="square" anchor="t" lIns="0" rIns="0" tIns="0" bIns="0">
+            <a:spAutoFit/>
+          </a:bodyPr>
+          <a:lstStyle/>
+          <a:p>
+            <a:pPr algn="l">
+              <a:lnSpc>
+                <a:spcPct val="100000"/>
+              </a:lnSpc>
+              <a:spcAft>
+                <a:spcPts val="0"/>
+              </a:spcAft>
+            </a:pPr>
+            <a:r>
+              <a:rPr sz="1300" b="0" i="0">
+                <a:solidFill>
+                  <a:srgbClr val="20232A"/>
+                </a:solidFill>
+                <a:latin typeface="Calibri"/>
+              </a:rPr>
+              <a:t>Iso / 3+ dribble rate</a:t>
+            </a:r>
+          </a:p>
+        </p:txBody>
+      </p:sp>
+      <p:sp>
+        <p:nvSpPr>
+          <p:cNvPr id="15" name="TextBox 14"/>
+          <p:cNvSpPr txBox="1"/>
+          <p:nvPr/>
+        </p:nvSpPr>
+        <p:spPr>
+          <a:xfrm>
+            <a:off x="3566160" y="3840480"/>
+            <a:ext cx="1737360" cy="320040"/>
+          </a:xfrm>
+          <a:prstGeom prst="rect">
+            <a:avLst/>
+          </a:prstGeom>
+          <a:noFill/>
+        </p:spPr>
+        <p:txBody>
+          <a:bodyPr wrap="square" anchor="t" lIns="0" rIns="0" tIns="0" bIns="0">
+            <a:spAutoFit/>
+          </a:bodyPr>
+          <a:lstStyle/>
+          <a:p>
+            <a:pPr algn="l">
+              <a:lnSpc>
+                <a:spcPct val="100000"/>
+              </a:lnSpc>
+              <a:spcAft>
+                <a:spcPts val="0"/>
+              </a:spcAft>
+            </a:pPr>
+            <a:r>
+              <a:rPr sz="1350" b="1" i="0">
+                <a:solidFill>
+                  <a:srgbClr val="6B7280"/>
+                </a:solidFill>
+                <a:latin typeface="Calibri"/>
+              </a:rPr>
+              <a:t>0.639</a:t>
+            </a:r>
+          </a:p>
+        </p:txBody>
+      </p:sp>
+      <p:sp>
+        <p:nvSpPr>
+          <p:cNvPr id="16" name="TextBox 15"/>
+          <p:cNvSpPr txBox="1"/>
+          <p:nvPr/>
+        </p:nvSpPr>
+        <p:spPr>
+          <a:xfrm>
+            <a:off x="5394960" y="3840480"/>
+            <a:ext cx="1737360" cy="320040"/>
+          </a:xfrm>
+          <a:prstGeom prst="rect">
+            <a:avLst/>
+          </a:prstGeom>
+          <a:noFill/>
+        </p:spPr>
+        <p:txBody>
+          <a:bodyPr wrap="square" anchor="t" lIns="0" rIns="0" tIns="0" bIns="0">
+            <a:spAutoFit/>
+          </a:bodyPr>
+          <a:lstStyle/>
+          <a:p>
+            <a:pPr algn="l">
+              <a:lnSpc>
+                <a:spcPct val="100000"/>
+              </a:lnSpc>
+              <a:spcAft>
+                <a:spcPts val="0"/>
+              </a:spcAft>
+            </a:pPr>
+            <a:r>
+              <a:rPr sz="1350" b="1" i="0">
+                <a:solidFill>
+                  <a:srgbClr val="007A33"/>
+                </a:solidFill>
+                <a:latin typeface="Calibri"/>
+              </a:rPr>
+              <a:t>0.404</a:t>
+            </a:r>
+          </a:p>
+        </p:txBody>
+      </p:sp>
+      <p:sp>
+        <p:nvSpPr>
+          <p:cNvPr id="17" name="TextBox 16"/>
+          <p:cNvSpPr txBox="1"/>
+          <p:nvPr/>
+        </p:nvSpPr>
+        <p:spPr>
+          <a:xfrm>
+            <a:off x="859536" y="4389120"/>
+            <a:ext cx="2651760" cy="320040"/>
+          </a:xfrm>
+          <a:prstGeom prst="rect">
+            <a:avLst/>
+          </a:prstGeom>
+          <a:noFill/>
+        </p:spPr>
+        <p:txBody>
+          <a:bodyPr wrap="square" anchor="t" lIns="0" rIns="0" tIns="0" bIns="0">
+            <a:spAutoFit/>
+          </a:bodyPr>
+          <a:lstStyle/>
+          <a:p>
+            <a:pPr algn="l">
+              <a:lnSpc>
+                <a:spcPct val="100000"/>
+              </a:lnSpc>
+              <a:spcAft>
+                <a:spcPts val="0"/>
+              </a:spcAft>
+            </a:pPr>
+            <a:r>
+              <a:rPr sz="1300" b="0" i="0">
+                <a:solidFill>
+                  <a:srgbClr val="20232A"/>
+                </a:solidFill>
+                <a:latin typeface="Calibri"/>
+              </a:rPr>
+              <a:t>Contested-shot rate</a:t>
+            </a:r>
+          </a:p>
+        </p:txBody>
+      </p:sp>
+      <p:sp>
+        <p:nvSpPr>
+          <p:cNvPr id="18" name="TextBox 17"/>
+          <p:cNvSpPr txBox="1"/>
+          <p:nvPr/>
+        </p:nvSpPr>
+        <p:spPr>
+          <a:xfrm>
+            <a:off x="3566160" y="4389120"/>
+            <a:ext cx="1737360" cy="320040"/>
+          </a:xfrm>
+          <a:prstGeom prst="rect">
+            <a:avLst/>
+          </a:prstGeom>
+          <a:noFill/>
+        </p:spPr>
+        <p:txBody>
+          <a:bodyPr wrap="square" anchor="t" lIns="0" rIns="0" tIns="0" bIns="0">
+            <a:spAutoFit/>
+          </a:bodyPr>
+          <a:lstStyle/>
+          <a:p>
+            <a:pPr algn="l">
+              <a:lnSpc>
+                <a:spcPct val="100000"/>
+              </a:lnSpc>
+              <a:spcAft>
+                <a:spcPts val="0"/>
+              </a:spcAft>
+            </a:pPr>
+            <a:r>
+              <a:rPr sz="1350" b="1" i="0">
+                <a:solidFill>
+                  <a:srgbClr val="6B7280"/>
+                </a:solidFill>
+                <a:latin typeface="Calibri"/>
+              </a:rPr>
+              <a:t>0.517</a:t>
+            </a:r>
+          </a:p>
+        </p:txBody>
+      </p:sp>
+      <p:sp>
+        <p:nvSpPr>
+          <p:cNvPr id="19" name="TextBox 18"/>
+          <p:cNvSpPr txBox="1"/>
+          <p:nvPr/>
+        </p:nvSpPr>
+        <p:spPr>
+          <a:xfrm>
+            <a:off x="5394960" y="4389120"/>
+            <a:ext cx="1737360" cy="320040"/>
+          </a:xfrm>
+          <a:prstGeom prst="rect">
+            <a:avLst/>
+          </a:prstGeom>
+          <a:noFill/>
+        </p:spPr>
+        <p:txBody>
+          <a:bodyPr wrap="square" anchor="t" lIns="0" rIns="0" tIns="0" bIns="0">
+            <a:spAutoFit/>
+          </a:bodyPr>
+          <a:lstStyle/>
+          <a:p>
+            <a:pPr algn="l">
+              <a:lnSpc>
+                <a:spcPct val="100000"/>
+              </a:lnSpc>
+              <a:spcAft>
+                <a:spcPts val="0"/>
+              </a:spcAft>
+            </a:pPr>
+            <a:r>
+              <a:rPr sz="1350" b="1" i="0">
+                <a:solidFill>
+                  <a:srgbClr val="007A33"/>
+                </a:solidFill>
+                <a:latin typeface="Calibri"/>
+              </a:rPr>
+              <a:t>0.370</a:t>
+            </a:r>
+          </a:p>
+        </p:txBody>
+      </p:sp>
+      <p:sp>
+        <p:nvSpPr>
+          <p:cNvPr id="20" name="TextBox 19"/>
+          <p:cNvSpPr txBox="1"/>
+          <p:nvPr/>
+        </p:nvSpPr>
+        <p:spPr>
+          <a:xfrm>
+            <a:off x="859536" y="4937759"/>
+            <a:ext cx="2651760" cy="320040"/>
+          </a:xfrm>
+          <a:prstGeom prst="rect">
+            <a:avLst/>
+          </a:prstGeom>
+          <a:noFill/>
+        </p:spPr>
+        <p:txBody>
+          <a:bodyPr wrap="square" anchor="t" lIns="0" rIns="0" tIns="0" bIns="0">
+            <a:spAutoFit/>
+          </a:bodyPr>
+          <a:lstStyle/>
+          <a:p>
+            <a:pPr algn="l">
+              <a:lnSpc>
+                <a:spcPct val="100000"/>
+              </a:lnSpc>
+              <a:spcAft>
+                <a:spcPts val="0"/>
+              </a:spcAft>
+            </a:pPr>
+            <a:r>
+              <a:rPr sz="1300" b="0" i="0">
+                <a:solidFill>
+                  <a:srgbClr val="20232A"/>
+                </a:solidFill>
+                <a:latin typeface="Calibri"/>
+              </a:rPr>
+              <a:t>Bad-shot index</a:t>
+            </a:r>
+          </a:p>
+        </p:txBody>
+      </p:sp>
+      <p:sp>
+        <p:nvSpPr>
+          <p:cNvPr id="21" name="TextBox 20"/>
+          <p:cNvSpPr txBox="1"/>
+          <p:nvPr/>
+        </p:nvSpPr>
+        <p:spPr>
+          <a:xfrm>
+            <a:off x="3566160" y="4937759"/>
+            <a:ext cx="1737360" cy="320040"/>
+          </a:xfrm>
+          <a:prstGeom prst="rect">
+            <a:avLst/>
+          </a:prstGeom>
+          <a:noFill/>
+        </p:spPr>
+        <p:txBody>
+          <a:bodyPr wrap="square" anchor="t" lIns="0" rIns="0" tIns="0" bIns="0">
+            <a:spAutoFit/>
+          </a:bodyPr>
+          <a:lstStyle/>
+          <a:p>
+            <a:pPr algn="l">
+              <a:lnSpc>
+                <a:spcPct val="100000"/>
+              </a:lnSpc>
+              <a:spcAft>
+                <a:spcPts val="0"/>
+              </a:spcAft>
+            </a:pPr>
+            <a:r>
+              <a:rPr sz="1350" b="1" i="0">
+                <a:solidFill>
+                  <a:srgbClr val="6B7280"/>
+                </a:solidFill>
+                <a:latin typeface="Calibri"/>
+              </a:rPr>
+              <a:t>0.379</a:t>
+            </a:r>
+          </a:p>
+        </p:txBody>
+      </p:sp>
+      <p:sp>
+        <p:nvSpPr>
+          <p:cNvPr id="22" name="TextBox 21"/>
+          <p:cNvSpPr txBox="1"/>
+          <p:nvPr/>
+        </p:nvSpPr>
+        <p:spPr>
+          <a:xfrm>
+            <a:off x="5394960" y="4937759"/>
+            <a:ext cx="1737360" cy="320040"/>
+          </a:xfrm>
+          <a:prstGeom prst="rect">
+            <a:avLst/>
+          </a:prstGeom>
+          <a:noFill/>
+        </p:spPr>
+        <p:txBody>
+          <a:bodyPr wrap="square" anchor="t" lIns="0" rIns="0" tIns="0" bIns="0">
+            <a:spAutoFit/>
+          </a:bodyPr>
+          <a:lstStyle/>
+          <a:p>
+            <a:pPr algn="l">
+              <a:lnSpc>
+                <a:spcPct val="100000"/>
+              </a:lnSpc>
+              <a:spcAft>
+                <a:spcPts val="0"/>
+              </a:spcAft>
+            </a:pPr>
+            <a:r>
+              <a:rPr sz="1350" b="1" i="0">
+                <a:solidFill>
+                  <a:srgbClr val="007A33"/>
+                </a:solidFill>
+                <a:latin typeface="Calibri"/>
+              </a:rPr>
+              <a:t>0.273</a:t>
+            </a:r>
+          </a:p>
+        </p:txBody>
+      </p:sp>
+      <p:sp>
+        <p:nvSpPr>
+          <p:cNvPr id="23" name="TextBox 22"/>
+          <p:cNvSpPr txBox="1"/>
+          <p:nvPr/>
+        </p:nvSpPr>
+        <p:spPr>
+          <a:xfrm>
+            <a:off x="859536" y="5138928"/>
+            <a:ext cx="6035040" cy="457200"/>
+          </a:xfrm>
+          <a:prstGeom prst="rect">
+            <a:avLst/>
+          </a:prstGeom>
+          <a:noFill/>
+        </p:spPr>
+        <p:txBody>
+          <a:bodyPr wrap="square" anchor="t" lIns="0" rIns="0" tIns="0" bIns="0">
+            <a:spAutoFit/>
+          </a:bodyPr>
+          <a:lstStyle/>
+          <a:p>
+            <a:pPr algn="l">
+              <a:lnSpc>
+                <a:spcPct val="105000"/>
+              </a:lnSpc>
+              <a:spcAft>
+                <a:spcPts val="400"/>
+              </a:spcAft>
+            </a:pPr>
+            <a:r>
+              <a:rPr sz="1150" b="0" i="1">
+                <a:solidFill>
+                  <a:srgbClr val="6B7280"/>
+                </a:solidFill>
+                <a:latin typeface="Calibri"/>
+              </a:rPr>
+              <a:t>George takes the shots the system is built to generate — he plugs in instead of stopping it.</a:t>
+            </a:r>
+          </a:p>
+        </p:txBody>
+      </p:sp>
+      <p:sp>
+        <p:nvSpPr>
+          <p:cNvPr id="24" name="Rounded Rectangle 23"/>
           <p:cNvSpPr/>
           <p:nvPr/>
         </p:nvSpPr>
         <p:spPr>
           <a:xfrm>
-            <a:off x="841247" y="2130552"/>
-            <a:ext cx="384048" cy="384048"/>
-          </a:xfrm>
-          <a:prstGeom prst="ellipse">
-            <a:avLst/>
+            <a:off x="7452360" y="1783080"/>
+            <a:ext cx="4160520" cy="3977639"/>
+          </a:xfrm>
+          <a:prstGeom prst="roundRect">
+            <a:avLst>
+              <a:gd name="adj" fmla="val 8000"/>
+            </a:avLst>
           </a:prstGeom>
           <a:solidFill>
-            <a:srgbClr val="BA9653"/>
+            <a:srgbClr val="0A2A1A"/>
           </a:solidFill>
           <a:ln>
             <a:noFill/>
@@ -7444,32 +7698,23 @@
           </a:fontRef>
         </p:style>
         <p:txBody>
-          <a:bodyPr rtlCol="0" anchor="ctr" wrap="none"/>
+          <a:bodyPr rtlCol="0" anchor="ctr"/>
           <a:lstStyle/>
           <a:p>
             <a:pPr algn="ctr"/>
-            <a:r>
-              <a:rPr sz="1600" b="1">
-                <a:solidFill>
-                  <a:srgbClr val="FFFFFF"/>
-                </a:solidFill>
-                <a:latin typeface="Cambria"/>
-              </a:rPr>
-              <a:t>1</a:t>
-            </a:r>
-          </a:p>
-        </p:txBody>
-      </p:sp>
-      <p:sp>
-        <p:nvSpPr>
-          <p:cNvPr id="6" name="TextBox 5"/>
+          </a:p>
+        </p:txBody>
+      </p:sp>
+      <p:sp>
+        <p:nvSpPr>
+          <p:cNvPr id="25" name="TextBox 24"/>
           <p:cNvSpPr txBox="1"/>
           <p:nvPr/>
         </p:nvSpPr>
         <p:spPr>
           <a:xfrm>
-            <a:off x="841247" y="2715768"/>
-            <a:ext cx="2999232" cy="457200"/>
+            <a:off x="7726679" y="2011680"/>
+            <a:ext cx="3657600" cy="365760"/>
           </a:xfrm>
           <a:prstGeom prst="rect">
             <a:avLst/>
@@ -7491,27 +7736,27 @@
               </a:spcAft>
             </a:pPr>
             <a:r>
-              <a:rPr sz="1600" b="1" i="0">
-                <a:solidFill>
-                  <a:srgbClr val="0A2A1A"/>
-                </a:solidFill>
-                <a:latin typeface="Cambria"/>
-              </a:rPr>
-              <a:t>Brown could carry</a:t>
-            </a:r>
-          </a:p>
-        </p:txBody>
-      </p:sp>
-      <p:sp>
-        <p:nvSpPr>
-          <p:cNvPr id="7" name="TextBox 6"/>
+              <a:rPr sz="1250" b="1" i="0">
+                <a:solidFill>
+                  <a:srgbClr val="BCD3C6"/>
+                </a:solidFill>
+                <a:latin typeface="Calibri"/>
+              </a:rPr>
+              <a:t>PLUS THE PICKS</a:t>
+            </a:r>
+          </a:p>
+        </p:txBody>
+      </p:sp>
+      <p:sp>
+        <p:nvSpPr>
+          <p:cNvPr id="26" name="TextBox 25"/>
           <p:cNvSpPr txBox="1"/>
           <p:nvPr/>
         </p:nvSpPr>
         <p:spPr>
           <a:xfrm>
-            <a:off x="841247" y="3200400"/>
-            <a:ext cx="2999232" cy="1554480"/>
+            <a:off x="7726679" y="2468880"/>
+            <a:ext cx="3657600" cy="914400"/>
           </a:xfrm>
           <a:prstGeom prst="rect">
             <a:avLst/>
@@ -7526,33 +7771,297 @@
           <a:p>
             <a:pPr algn="l">
               <a:lnSpc>
-                <a:spcPct val="112000"/>
+                <a:spcPct val="105000"/>
+              </a:lnSpc>
+              <a:spcAft>
+                <a:spcPts val="200"/>
+              </a:spcAft>
+            </a:pPr>
+            <a:r>
+              <a:rPr sz="2000" b="1" i="0">
+                <a:solidFill>
+                  <a:srgbClr val="FFFFFF"/>
+                </a:solidFill>
+                <a:latin typeface="Cambria"/>
+              </a:rPr>
+              <a:t>2028 first + 2031</a:t>
+            </a:r>
+          </a:p>
+          <a:p>
+            <a:pPr algn="l">
+              <a:lnSpc>
+                <a:spcPct val="105000"/>
+              </a:lnSpc>
+              <a:spcAft>
+                <a:spcPts val="200"/>
+              </a:spcAft>
+            </a:pPr>
+            <a:r>
+              <a:rPr sz="2000" b="1" i="0">
+                <a:solidFill>
+                  <a:srgbClr val="FFFFFF"/>
+                </a:solidFill>
+                <a:latin typeface="Cambria"/>
+              </a:rPr>
+              <a:t>unprotected first</a:t>
+            </a:r>
+          </a:p>
+        </p:txBody>
+      </p:sp>
+      <p:sp>
+        <p:nvSpPr>
+          <p:cNvPr id="27" name="TextBox 26"/>
+          <p:cNvSpPr txBox="1"/>
+          <p:nvPr/>
+        </p:nvSpPr>
+        <p:spPr>
+          <a:xfrm>
+            <a:off x="7726679" y="3520440"/>
+            <a:ext cx="3657600" cy="1463040"/>
+          </a:xfrm>
+          <a:prstGeom prst="rect">
+            <a:avLst/>
+          </a:prstGeom>
+          <a:noFill/>
+        </p:spPr>
+        <p:txBody>
+          <a:bodyPr wrap="square" anchor="t" lIns="0" rIns="0" tIns="0" bIns="0">
+            <a:spAutoFit/>
+          </a:bodyPr>
+          <a:lstStyle/>
+          <a:p>
+            <a:pPr algn="l">
+              <a:lnSpc>
+                <a:spcPct val="115000"/>
               </a:lnSpc>
               <a:spcAft>
                 <a:spcPts val="400"/>
               </a:spcAft>
             </a:pPr>
             <a:r>
-              <a:rPr sz="1280" b="0" i="0">
+              <a:rPr sz="1250" b="0" i="0">
+                <a:solidFill>
+                  <a:srgbClr val="CFE0D6"/>
+                </a:solidFill>
+                <a:latin typeface="Calibri"/>
+              </a:rPr>
+              <a:t>Under the post-2019 flattened lottery — exact odds enumerated across all 24,024 seed permutations — late-lottery firsts convey materially more top-4 equity than the old system.</a:t>
+            </a:r>
+          </a:p>
+        </p:txBody>
+      </p:sp>
+      <p:sp>
+        <p:nvSpPr>
+          <p:cNvPr id="28" name="TextBox 27"/>
+          <p:cNvSpPr txBox="1"/>
+          <p:nvPr/>
+        </p:nvSpPr>
+        <p:spPr>
+          <a:xfrm>
+            <a:off x="7726679" y="5074920"/>
+            <a:ext cx="3657600" cy="548640"/>
+          </a:xfrm>
+          <a:prstGeom prst="rect">
+            <a:avLst/>
+          </a:prstGeom>
+          <a:noFill/>
+        </p:spPr>
+        <p:txBody>
+          <a:bodyPr wrap="square" anchor="t" lIns="0" rIns="0" tIns="0" bIns="0">
+            <a:spAutoFit/>
+          </a:bodyPr>
+          <a:lstStyle/>
+          <a:p>
+            <a:pPr algn="l">
+              <a:lnSpc>
+                <a:spcPct val="108000"/>
+              </a:lnSpc>
+              <a:spcAft>
+                <a:spcPts val="400"/>
+              </a:spcAft>
+            </a:pPr>
+            <a:r>
+              <a:rPr sz="1150" b="0" i="1">
+                <a:solidFill>
+                  <a:srgbClr val="9AB2A4"/>
+                </a:solidFill>
+                <a:latin typeface="Calibri"/>
+              </a:rPr>
+              <a:t>Cheap, controllable, tradeable — the assets a capped-out roster can't otherwise get.</a:t>
+            </a:r>
+          </a:p>
+        </p:txBody>
+      </p:sp>
+      <p:sp>
+        <p:nvSpPr>
+          <p:cNvPr id="29" name="TextBox 28"/>
+          <p:cNvSpPr txBox="1"/>
+          <p:nvPr/>
+        </p:nvSpPr>
+        <p:spPr>
+          <a:xfrm>
+            <a:off x="566928" y="6510528"/>
+            <a:ext cx="11064240" cy="274320"/>
+          </a:xfrm>
+          <a:prstGeom prst="rect">
+            <a:avLst/>
+          </a:prstGeom>
+          <a:noFill/>
+        </p:spPr>
+        <p:txBody>
+          <a:bodyPr wrap="square" anchor="t" lIns="0" rIns="0" tIns="0" bIns="0">
+            <a:spAutoFit/>
+          </a:bodyPr>
+          <a:lstStyle/>
+          <a:p>
+            <a:pPr algn="l">
+              <a:lnSpc>
+                <a:spcPct val="100000"/>
+              </a:lnSpc>
+              <a:spcAft>
+                <a:spcPts val="0"/>
+              </a:spcAft>
+            </a:pPr>
+            <a:r>
+              <a:rPr sz="900" b="0" i="0">
                 <a:solidFill>
                   <a:srgbClr val="6B7280"/>
                 </a:solidFill>
                 <a:latin typeface="Calibri"/>
               </a:rPr>
-              <a:t>His 7-game solo cell was the best in the 2024-25 matrix (6-1, +15.8), and he carried 58 games alone in 2025-26 at 28.9 ppg (36-22, +5.7). The man can be a first option — just not here.</a:t>
-            </a:r>
-          </a:p>
-        </p:txBody>
-      </p:sp>
-      <p:sp>
-        <p:nvSpPr>
-          <p:cNvPr id="8" name="Rounded Rectangle 7"/>
+              <a:t>Fit Check · Jaylen Brown Trade Audit</a:t>
+            </a:r>
+            <a:r>
+              <a:rPr sz="900" b="0" i="0">
+                <a:solidFill>
+                  <a:srgbClr val="6B7280"/>
+                </a:solidFill>
+                <a:latin typeface="Calibri"/>
+              </a:rPr>
+              <a:t>      Data: nba_api / Basketball-Reference · 2024-25 &amp; 2025-26 · July 2026</a:t>
+            </a:r>
+          </a:p>
+        </p:txBody>
+      </p:sp>
+    </p:spTree>
+  </p:cSld>
+  <p:clrMapOvr>
+    <a:masterClrMapping/>
+  </p:clrMapOvr>
+</p:sld>
+</file>
+
+<file path=ppt/slides/slide9.xml><?xml version="1.0" encoding="utf-8"?>
+<p:sld xmlns:a="http://schemas.openxmlformats.org/drawingml/2006/main" xmlns:p="http://schemas.openxmlformats.org/presentationml/2006/main" xmlns:r="http://schemas.openxmlformats.org/officeDocument/2006/relationships">
+  <p:cSld>
+    <p:bg>
+      <p:bgPr>
+        <a:solidFill>
+          <a:srgbClr val="F4F5F7"/>
+        </a:solidFill>
+        <a:effectLst/>
+      </p:bgPr>
+    </p:bg>
+    <p:spTree>
+      <p:nvGrpSpPr>
+        <p:cNvPr id="1" name=""/>
+        <p:cNvGrpSpPr/>
+        <p:nvPr/>
+      </p:nvGrpSpPr>
+      <p:grpSpPr/>
+      <p:sp>
+        <p:nvSpPr>
+          <p:cNvPr id="2" name="TextBox 1"/>
+          <p:cNvSpPr txBox="1"/>
+          <p:nvPr/>
+        </p:nvSpPr>
+        <p:spPr>
+          <a:xfrm>
+            <a:off x="566928" y="384048"/>
+            <a:ext cx="10058400" cy="274320"/>
+          </a:xfrm>
+          <a:prstGeom prst="rect">
+            <a:avLst/>
+          </a:prstGeom>
+          <a:noFill/>
+        </p:spPr>
+        <p:txBody>
+          <a:bodyPr wrap="square" anchor="t" lIns="0" rIns="0" tIns="0" bIns="0">
+            <a:spAutoFit/>
+          </a:bodyPr>
+          <a:lstStyle/>
+          <a:p>
+            <a:pPr algn="l">
+              <a:lnSpc>
+                <a:spcPct val="100000"/>
+              </a:lnSpc>
+              <a:spcAft>
+                <a:spcPts val="0"/>
+              </a:spcAft>
+            </a:pPr>
+            <a:r>
+              <a:rPr sz="1250" b="1" i="0">
+                <a:solidFill>
+                  <a:srgbClr val="007A33"/>
+                </a:solidFill>
+                <a:latin typeface="Calibri"/>
+              </a:rPr>
+              <a:t>WHERE THE CASE IS WEAKEST</a:t>
+            </a:r>
+          </a:p>
+        </p:txBody>
+      </p:sp>
+      <p:sp>
+        <p:nvSpPr>
+          <p:cNvPr id="3" name="TextBox 2"/>
+          <p:cNvSpPr txBox="1"/>
+          <p:nvPr/>
+        </p:nvSpPr>
+        <p:spPr>
+          <a:xfrm>
+            <a:off x="566928" y="658368"/>
+            <a:ext cx="11064240" cy="868680"/>
+          </a:xfrm>
+          <a:prstGeom prst="rect">
+            <a:avLst/>
+          </a:prstGeom>
+          <a:noFill/>
+        </p:spPr>
+        <p:txBody>
+          <a:bodyPr wrap="square" anchor="t" lIns="0" rIns="0" tIns="0" bIns="0">
+            <a:spAutoFit/>
+          </a:bodyPr>
+          <a:lstStyle/>
+          <a:p>
+            <a:pPr algn="l">
+              <a:lnSpc>
+                <a:spcPct val="100000"/>
+              </a:lnSpc>
+              <a:spcAft>
+                <a:spcPts val="0"/>
+              </a:spcAft>
+            </a:pPr>
+            <a:r>
+              <a:rPr sz="3000" b="1" i="0">
+                <a:solidFill>
+                  <a:srgbClr val="0A2A1A"/>
+                </a:solidFill>
+                <a:latin typeface="Cambria"/>
+              </a:rPr>
+              <a:t>The counter-evidence, on the record</a:t>
+            </a:r>
+          </a:p>
+        </p:txBody>
+      </p:sp>
+      <p:sp>
+        <p:nvSpPr>
+          <p:cNvPr id="4" name="Rounded Rectangle 3"/>
           <p:cNvSpPr/>
           <p:nvPr/>
         </p:nvSpPr>
         <p:spPr>
           <a:xfrm>
-            <a:off x="4352544" y="1874519"/>
+            <a:off x="566928" y="1874519"/>
             <a:ext cx="3502152" cy="3017520"/>
           </a:xfrm>
           <a:prstGeom prst="roundRect">
@@ -7594,13 +8103,13 @@
       </p:sp>
       <p:sp>
         <p:nvSpPr>
-          <p:cNvPr id="9" name="Oval 8"/>
+          <p:cNvPr id="5" name="Oval 4"/>
           <p:cNvSpPr/>
           <p:nvPr/>
         </p:nvSpPr>
         <p:spPr>
           <a:xfrm>
-            <a:off x="4626864" y="2130552"/>
+            <a:off x="841247" y="2130552"/>
             <a:ext cx="384048" cy="384048"/>
           </a:xfrm>
           <a:prstGeom prst="ellipse">
@@ -7640,20 +8149,20 @@
                 </a:solidFill>
                 <a:latin typeface="Cambria"/>
               </a:rPr>
-              <a:t>2</a:t>
-            </a:r>
-          </a:p>
-        </p:txBody>
-      </p:sp>
-      <p:sp>
-        <p:nvSpPr>
-          <p:cNvPr id="10" name="TextBox 9"/>
+              <a:t>1</a:t>
+            </a:r>
+          </a:p>
+        </p:txBody>
+      </p:sp>
+      <p:sp>
+        <p:nvSpPr>
+          <p:cNvPr id="6" name="TextBox 5"/>
           <p:cNvSpPr txBox="1"/>
           <p:nvPr/>
         </p:nvSpPr>
         <p:spPr>
           <a:xfrm>
-            <a:off x="4626864" y="2715768"/>
+            <a:off x="841247" y="2715768"/>
             <a:ext cx="2999232" cy="457200"/>
           </a:xfrm>
           <a:prstGeom prst="rect">
@@ -7682,20 +8191,20 @@
                 </a:solidFill>
                 <a:latin typeface="Cambria"/>
               </a:rPr>
-              <a:t>The defense is a real loss</a:t>
-            </a:r>
-          </a:p>
-        </p:txBody>
-      </p:sp>
-      <p:sp>
-        <p:nvSpPr>
-          <p:cNvPr id="11" name="TextBox 10"/>
+              <a:t>Brown could carry</a:t>
+            </a:r>
+          </a:p>
+        </p:txBody>
+      </p:sp>
+      <p:sp>
+        <p:nvSpPr>
+          <p:cNvPr id="7" name="TextBox 6"/>
           <p:cNvSpPr txBox="1"/>
           <p:nvPr/>
         </p:nvSpPr>
         <p:spPr>
           <a:xfrm>
-            <a:off x="4626864" y="3200400"/>
+            <a:off x="841247" y="3200400"/>
             <a:ext cx="2999232" cy="1554480"/>
           </a:xfrm>
           <a:prstGeom prst="rect">
@@ -7724,20 +8233,20 @@
                 </a:solidFill>
                 <a:latin typeface="Calibri"/>
               </a:rPr>
-              <a:t>Brown took 19% of his defended possessions against opponents' #1 options (Tatum: 8%) at better points-allowed, with -4.2/-5.7 defended-FG% margins. Boston traded its toughest assignment.</a:t>
-            </a:r>
-          </a:p>
-        </p:txBody>
-      </p:sp>
-      <p:sp>
-        <p:nvSpPr>
-          <p:cNvPr id="12" name="Rounded Rectangle 11"/>
+              <a:t>His 7-game solo cell was the best in the 2024-25 matrix (6-1, +15.8), and he carried 58 games alone in 2025-26 at 28.9 ppg (36-22, +5.7). The man can be a first option — just not here.</a:t>
+            </a:r>
+          </a:p>
+        </p:txBody>
+      </p:sp>
+      <p:sp>
+        <p:nvSpPr>
+          <p:cNvPr id="8" name="Rounded Rectangle 7"/>
           <p:cNvSpPr/>
           <p:nvPr/>
         </p:nvSpPr>
         <p:spPr>
           <a:xfrm>
-            <a:off x="8138159" y="1874519"/>
+            <a:off x="4352544" y="1874519"/>
             <a:ext cx="3502152" cy="3017520"/>
           </a:xfrm>
           <a:prstGeom prst="roundRect">
@@ -7779,20 +8288,20 @@
       </p:sp>
       <p:sp>
         <p:nvSpPr>
-          <p:cNvPr id="13" name="Oval 12"/>
+          <p:cNvPr id="9" name="Oval 8"/>
           <p:cNvSpPr/>
           <p:nvPr/>
         </p:nvSpPr>
         <p:spPr>
           <a:xfrm>
-            <a:off x="8412480" y="2130552"/>
+            <a:off x="4626864" y="2130552"/>
             <a:ext cx="384048" cy="384048"/>
           </a:xfrm>
           <a:prstGeom prst="ellipse">
             <a:avLst/>
           </a:prstGeom>
           <a:solidFill>
-            <a:srgbClr val="B3403A"/>
+            <a:srgbClr val="BA9653"/>
           </a:solidFill>
           <a:ln>
             <a:noFill/>
@@ -7825,20 +8334,20 @@
                 </a:solidFill>
                 <a:latin typeface="Cambria"/>
               </a:rPr>
-              <a:t>3</a:t>
-            </a:r>
-          </a:p>
-        </p:txBody>
-      </p:sp>
-      <p:sp>
-        <p:nvSpPr>
-          <p:cNvPr id="14" name="TextBox 13"/>
+              <a:t>2</a:t>
+            </a:r>
+          </a:p>
+        </p:txBody>
+      </p:sp>
+      <p:sp>
+        <p:nvSpPr>
+          <p:cNvPr id="10" name="TextBox 9"/>
           <p:cNvSpPr txBox="1"/>
           <p:nvPr/>
         </p:nvSpPr>
         <p:spPr>
           <a:xfrm>
-            <a:off x="8412480" y="2715768"/>
+            <a:off x="4626864" y="2715768"/>
             <a:ext cx="2999232" cy="457200"/>
           </a:xfrm>
           <a:prstGeom prst="rect">
@@ -7867,20 +8376,20 @@
                 </a:solidFill>
                 <a:latin typeface="Cambria"/>
               </a:rPr>
-              <a:t>The turnover tax wasn't his</a:t>
-            </a:r>
-          </a:p>
-        </p:txBody>
-      </p:sp>
-      <p:sp>
-        <p:nvSpPr>
-          <p:cNvPr id="15" name="TextBox 14"/>
+              <a:t>The defense is a real loss</a:t>
+            </a:r>
+          </a:p>
+        </p:txBody>
+      </p:sp>
+      <p:sp>
+        <p:nvSpPr>
+          <p:cNvPr id="11" name="TextBox 10"/>
           <p:cNvSpPr txBox="1"/>
           <p:nvPr/>
         </p:nvSpPr>
         <p:spPr>
           <a:xfrm>
-            <a:off x="8412480" y="3200400"/>
+            <a:off x="4626864" y="3200400"/>
             <a:ext cx="2999232" cy="1554480"/>
           </a:xfrm>
           <a:prstGeom prst="rect">
@@ -7909,158 +8418,34 @@
                 </a:solidFill>
                 <a:latin typeface="Calibri"/>
               </a:rPr>
-              <a:t>Play-by-play says Brown's live-ball TO rate (1.75/36) was LOWER than Tatum's (1.84) in 2024-25. That angle exonerates him — and the media consensus graded the trade for Philadelphia.</a:t>
-            </a:r>
-          </a:p>
-        </p:txBody>
-      </p:sp>
-      <p:sp>
-        <p:nvSpPr>
-          <p:cNvPr id="16" name="TextBox 15"/>
-          <p:cNvSpPr txBox="1"/>
-          <p:nvPr/>
-        </p:nvSpPr>
-        <p:spPr>
-          <a:xfrm>
-            <a:off x="566928" y="5212080"/>
-            <a:ext cx="11064240" cy="548640"/>
-          </a:xfrm>
-          <a:prstGeom prst="rect">
-            <a:avLst/>
-          </a:prstGeom>
-          <a:noFill/>
-        </p:spPr>
-        <p:txBody>
-          <a:bodyPr wrap="square" anchor="t" lIns="0" rIns="0" tIns="0" bIns="0">
-            <a:spAutoFit/>
-          </a:bodyPr>
-          <a:lstStyle/>
-          <a:p>
-            <a:pPr algn="l">
-              <a:lnSpc>
-                <a:spcPct val="110000"/>
-              </a:lnSpc>
-              <a:spcAft>
-                <a:spcPts val="400"/>
-              </a:spcAft>
-            </a:pPr>
-            <a:r>
-              <a:rPr sz="1400" b="1" i="0">
-                <a:solidFill>
-                  <a:srgbClr val="0A2A1A"/>
-                </a:solidFill>
-                <a:latin typeface="Calibri"/>
-              </a:rPr>
-              <a:t>An argument that can't survive its own counter-evidence isn't worth presenting. </a:t>
-            </a:r>
-            <a:r>
-              <a:rPr sz="1400" b="0" i="0">
-                <a:solidFill>
-                  <a:srgbClr val="6B7280"/>
-                </a:solidFill>
-                <a:latin typeface="Calibri"/>
-              </a:rPr>
-              <a:t>Every brief in this project ships with its weakest points attached.</a:t>
-            </a:r>
-          </a:p>
-        </p:txBody>
-      </p:sp>
-      <p:sp>
-        <p:nvSpPr>
-          <p:cNvPr id="17" name="TextBox 16"/>
-          <p:cNvSpPr txBox="1"/>
-          <p:nvPr/>
-        </p:nvSpPr>
-        <p:spPr>
-          <a:xfrm>
-            <a:off x="566928" y="6510528"/>
-            <a:ext cx="11064240" cy="274320"/>
-          </a:xfrm>
-          <a:prstGeom prst="rect">
-            <a:avLst/>
-          </a:prstGeom>
-          <a:noFill/>
-        </p:spPr>
-        <p:txBody>
-          <a:bodyPr wrap="square" anchor="t" lIns="0" rIns="0" tIns="0" bIns="0">
-            <a:spAutoFit/>
-          </a:bodyPr>
-          <a:lstStyle/>
-          <a:p>
-            <a:pPr algn="l">
-              <a:lnSpc>
-                <a:spcPct val="100000"/>
-              </a:lnSpc>
-              <a:spcAft>
-                <a:spcPts val="0"/>
-              </a:spcAft>
-            </a:pPr>
-            <a:r>
-              <a:rPr sz="900" b="0" i="0">
-                <a:solidFill>
-                  <a:srgbClr val="6B7280"/>
-                </a:solidFill>
-                <a:latin typeface="Calibri"/>
-              </a:rPr>
-              <a:t>Fit Check · Jaylen Brown Trade Audit</a:t>
-            </a:r>
-            <a:r>
-              <a:rPr sz="900" b="0" i="0">
-                <a:solidFill>
-                  <a:srgbClr val="6B7280"/>
-                </a:solidFill>
-                <a:latin typeface="Calibri"/>
-              </a:rPr>
-              <a:t>      Data: nba_api / Basketball-Reference · 2024-25 &amp; 2025-26 · July 2026</a:t>
-            </a:r>
-          </a:p>
-        </p:txBody>
-      </p:sp>
-    </p:spTree>
-  </p:cSld>
-  <p:clrMapOvr>
-    <a:masterClrMapping/>
-  </p:clrMapOvr>
-</p:sld>
-</file>
-
-<file path=ppt/slides/slide9.xml><?xml version="1.0" encoding="utf-8"?>
-<p:sld xmlns:a="http://schemas.openxmlformats.org/drawingml/2006/main" xmlns:p="http://schemas.openxmlformats.org/presentationml/2006/main" xmlns:r="http://schemas.openxmlformats.org/officeDocument/2006/relationships">
-  <p:cSld>
-    <p:bg>
-      <p:bgPr>
-        <a:solidFill>
-          <a:srgbClr val="0A2A1A"/>
-        </a:solidFill>
-        <a:effectLst/>
-      </p:bgPr>
-    </p:bg>
-    <p:spTree>
-      <p:nvGrpSpPr>
-        <p:cNvPr id="1" name=""/>
-        <p:cNvGrpSpPr/>
-        <p:nvPr/>
-      </p:nvGrpSpPr>
-      <p:grpSpPr/>
-      <p:sp>
-        <p:nvSpPr>
-          <p:cNvPr id="2" name="Oval 1"/>
+              <a:t>Brown took 19% of his defended possessions against opponents' #1 options (Tatum: 8%) at better points-allowed, with -4.2/-5.7 defended-FG% margins. Boston traded its toughest assignment.</a:t>
+            </a:r>
+          </a:p>
+        </p:txBody>
+      </p:sp>
+      <p:sp>
+        <p:nvSpPr>
+          <p:cNvPr id="12" name="Rounded Rectangle 11"/>
           <p:cNvSpPr/>
           <p:nvPr/>
         </p:nvSpPr>
         <p:spPr>
           <a:xfrm>
-            <a:off x="566928" y="640080"/>
-            <a:ext cx="310896" cy="310896"/>
-          </a:xfrm>
-          <a:prstGeom prst="ellipse">
-            <a:avLst/>
+            <a:off x="8138159" y="1874519"/>
+            <a:ext cx="3502152" cy="3017520"/>
+          </a:xfrm>
+          <a:prstGeom prst="roundRect">
+            <a:avLst>
+              <a:gd name="adj" fmla="val 8000"/>
+            </a:avLst>
           </a:prstGeom>
           <a:solidFill>
-            <a:srgbClr val="BA9653"/>
+            <a:srgbClr val="FFFFFF"/>
           </a:solidFill>
-          <a:ln>
-            <a:noFill/>
+          <a:ln w="12700">
+            <a:solidFill>
+              <a:srgbClr val="D7DAE0"/>
+            </a:solidFill>
           </a:ln>
           <a:effectLst/>
         </p:spPr>
@@ -8088,62 +8473,20 @@
       </p:sp>
       <p:sp>
         <p:nvSpPr>
-          <p:cNvPr id="3" name="TextBox 2"/>
-          <p:cNvSpPr txBox="1"/>
-          <p:nvPr/>
-        </p:nvSpPr>
-        <p:spPr>
-          <a:xfrm>
-            <a:off x="960120" y="621792"/>
-            <a:ext cx="9144000" cy="365760"/>
-          </a:xfrm>
-          <a:prstGeom prst="rect">
-            <a:avLst/>
-          </a:prstGeom>
-          <a:noFill/>
-        </p:spPr>
-        <p:txBody>
-          <a:bodyPr wrap="square" anchor="t" lIns="0" rIns="0" tIns="0" bIns="0">
-            <a:spAutoFit/>
-          </a:bodyPr>
-          <a:lstStyle/>
-          <a:p>
-            <a:pPr algn="l">
-              <a:lnSpc>
-                <a:spcPct val="100000"/>
-              </a:lnSpc>
-              <a:spcAft>
-                <a:spcPts val="0"/>
-              </a:spcAft>
-            </a:pPr>
-            <a:r>
-              <a:rPr sz="1300" b="1" i="0">
-                <a:solidFill>
-                  <a:srgbClr val="BCD3C6"/>
-                </a:solidFill>
-                <a:latin typeface="Calibri"/>
-              </a:rPr>
-              <a:t>BOTTOM LINE</a:t>
-            </a:r>
-          </a:p>
-        </p:txBody>
-      </p:sp>
-      <p:sp>
-        <p:nvSpPr>
-          <p:cNvPr id="4" name="Oval 3"/>
+          <p:cNvPr id="13" name="Oval 12"/>
           <p:cNvSpPr/>
           <p:nvPr/>
         </p:nvSpPr>
         <p:spPr>
           <a:xfrm>
-            <a:off x="640080" y="1837943"/>
-            <a:ext cx="164592" cy="164592"/>
+            <a:off x="8412480" y="2130552"/>
+            <a:ext cx="384048" cy="384048"/>
           </a:xfrm>
           <a:prstGeom prst="ellipse">
             <a:avLst/>
           </a:prstGeom>
           <a:solidFill>
-            <a:srgbClr val="BA9653"/>
+            <a:srgbClr val="B3403A"/>
           </a:solidFill>
           <a:ln>
             <a:noFill/>
@@ -8165,23 +8508,32 @@
           </a:fontRef>
         </p:style>
         <p:txBody>
-          <a:bodyPr rtlCol="0" anchor="ctr"/>
+          <a:bodyPr rtlCol="0" anchor="ctr" wrap="none"/>
           <a:lstStyle/>
           <a:p>
             <a:pPr algn="ctr"/>
-          </a:p>
-        </p:txBody>
-      </p:sp>
-      <p:sp>
-        <p:nvSpPr>
-          <p:cNvPr id="5" name="TextBox 4"/>
+            <a:r>
+              <a:rPr sz="1600" b="1">
+                <a:solidFill>
+                  <a:srgbClr val="FFFFFF"/>
+                </a:solidFill>
+                <a:latin typeface="Cambria"/>
+              </a:rPr>
+              <a:t>3</a:t>
+            </a:r>
+          </a:p>
+        </p:txBody>
+      </p:sp>
+      <p:sp>
+        <p:nvSpPr>
+          <p:cNvPr id="14" name="TextBox 13"/>
           <p:cNvSpPr txBox="1"/>
           <p:nvPr/>
         </p:nvSpPr>
         <p:spPr>
           <a:xfrm>
-            <a:off x="960120" y="1783080"/>
-            <a:ext cx="10424160" cy="914400"/>
+            <a:off x="8412480" y="2715768"/>
+            <a:ext cx="2999232" cy="457200"/>
           </a:xfrm>
           <a:prstGeom prst="rect">
             <a:avLst/>
@@ -8196,87 +8548,34 @@
           <a:p>
             <a:pPr algn="l">
               <a:lnSpc>
-                <a:spcPct val="110000"/>
-              </a:lnSpc>
-              <a:spcAft>
-                <a:spcPts val="200"/>
-              </a:spcAft>
-            </a:pPr>
-            <a:r>
-              <a:rPr sz="2100" b="1" i="0">
-                <a:solidFill>
-                  <a:srgbClr val="FFFFFF"/>
+                <a:spcPct val="100000"/>
+              </a:lnSpc>
+              <a:spcAft>
+                <a:spcPts val="0"/>
+              </a:spcAft>
+            </a:pPr>
+            <a:r>
+              <a:rPr sz="1600" b="1" i="0">
+                <a:solidFill>
+                  <a:srgbClr val="0A2A1A"/>
                 </a:solidFill>
                 <a:latin typeface="Cambria"/>
               </a:rPr>
-              <a:t>The fit was real and it was drifting.  </a:t>
-            </a:r>
-            <a:r>
-              <a:rPr sz="1500" b="0" i="0">
-                <a:solidFill>
-                  <a:srgbClr val="CFE0D6"/>
-                </a:solidFill>
-                <a:latin typeface="Calibri"/>
-              </a:rPr>
-              <a:t>Fewer threes, doubled long twos, two-thirds self-created — with no shot-making premium to pay for it.</a:t>
-            </a:r>
-          </a:p>
-        </p:txBody>
-      </p:sp>
-      <p:sp>
-        <p:nvSpPr>
-          <p:cNvPr id="6" name="Oval 5"/>
-          <p:cNvSpPr/>
-          <p:nvPr/>
-        </p:nvSpPr>
-        <p:spPr>
-          <a:xfrm>
-            <a:off x="640080" y="3072384"/>
-            <a:ext cx="164592" cy="164592"/>
-          </a:xfrm>
-          <a:prstGeom prst="ellipse">
-            <a:avLst/>
-          </a:prstGeom>
-          <a:solidFill>
-            <a:srgbClr val="BA9653"/>
-          </a:solidFill>
-          <a:ln>
-            <a:noFill/>
-          </a:ln>
-          <a:effectLst/>
-        </p:spPr>
-        <p:style>
-          <a:lnRef idx="1">
-            <a:schemeClr val="accent1"/>
-          </a:lnRef>
-          <a:fillRef idx="3">
-            <a:schemeClr val="accent1"/>
-          </a:fillRef>
-          <a:effectRef idx="2">
-            <a:schemeClr val="accent1"/>
-          </a:effectRef>
-          <a:fontRef idx="minor">
-            <a:schemeClr val="lt1"/>
-          </a:fontRef>
-        </p:style>
-        <p:txBody>
-          <a:bodyPr rtlCol="0" anchor="ctr"/>
-          <a:lstStyle/>
-          <a:p>
-            <a:pPr algn="ctr"/>
-          </a:p>
-        </p:txBody>
-      </p:sp>
-      <p:sp>
-        <p:nvSpPr>
-          <p:cNvPr id="7" name="TextBox 6"/>
+              <a:t>The turnover tax wasn't his</a:t>
+            </a:r>
+          </a:p>
+        </p:txBody>
+      </p:sp>
+      <p:sp>
+        <p:nvSpPr>
+          <p:cNvPr id="15" name="TextBox 14"/>
           <p:cNvSpPr txBox="1"/>
           <p:nvPr/>
         </p:nvSpPr>
         <p:spPr>
           <a:xfrm>
-            <a:off x="960120" y="3017520"/>
-            <a:ext cx="10424160" cy="914400"/>
+            <a:off x="8412480" y="3200400"/>
+            <a:ext cx="2999232" cy="1554480"/>
           </a:xfrm>
           <a:prstGeom prst="rect">
             <a:avLst/>
@@ -8291,87 +8590,34 @@
           <a:p>
             <a:pPr algn="l">
               <a:lnSpc>
-                <a:spcPct val="110000"/>
-              </a:lnSpc>
-              <a:spcAft>
-                <a:spcPts val="200"/>
-              </a:spcAft>
-            </a:pPr>
-            <a:r>
-              <a:rPr sz="2100" b="1" i="0">
-                <a:solidFill>
-                  <a:srgbClr val="FFFFFF"/>
-                </a:solidFill>
-                <a:latin typeface="Cambria"/>
-              </a:rPr>
-              <a:t>The value was contingent.  </a:t>
-            </a:r>
-            <a:r>
-              <a:rPr sz="1500" b="0" i="0">
-                <a:solidFill>
-                  <a:srgbClr val="CFE0D6"/>
-                </a:solidFill>
-                <a:latin typeface="Calibri"/>
-              </a:rPr>
-              <a:t>Brown-led lineups needed Tatum and White on the floor; at 34% of the cap, contingent is expensive.</a:t>
-            </a:r>
-          </a:p>
-        </p:txBody>
-      </p:sp>
-      <p:sp>
-        <p:nvSpPr>
-          <p:cNvPr id="8" name="Oval 7"/>
-          <p:cNvSpPr/>
-          <p:nvPr/>
-        </p:nvSpPr>
-        <p:spPr>
-          <a:xfrm>
-            <a:off x="640080" y="4306824"/>
-            <a:ext cx="164592" cy="164592"/>
-          </a:xfrm>
-          <a:prstGeom prst="ellipse">
-            <a:avLst/>
-          </a:prstGeom>
-          <a:solidFill>
-            <a:srgbClr val="BA9653"/>
-          </a:solidFill>
-          <a:ln>
-            <a:noFill/>
-          </a:ln>
-          <a:effectLst/>
-        </p:spPr>
-        <p:style>
-          <a:lnRef idx="1">
-            <a:schemeClr val="accent1"/>
-          </a:lnRef>
-          <a:fillRef idx="3">
-            <a:schemeClr val="accent1"/>
-          </a:fillRef>
-          <a:effectRef idx="2">
-            <a:schemeClr val="accent1"/>
-          </a:effectRef>
-          <a:fontRef idx="minor">
-            <a:schemeClr val="lt1"/>
-          </a:fontRef>
-        </p:style>
-        <p:txBody>
-          <a:bodyPr rtlCol="0" anchor="ctr"/>
-          <a:lstStyle/>
-          <a:p>
-            <a:pPr algn="ctr"/>
-          </a:p>
-        </p:txBody>
-      </p:sp>
-      <p:sp>
-        <p:nvSpPr>
-          <p:cNvPr id="9" name="TextBox 8"/>
+                <a:spcPct val="112000"/>
+              </a:lnSpc>
+              <a:spcAft>
+                <a:spcPts val="400"/>
+              </a:spcAft>
+            </a:pPr>
+            <a:r>
+              <a:rPr sz="1280" b="0" i="0">
+                <a:solidFill>
+                  <a:srgbClr val="6B7280"/>
+                </a:solidFill>
+                <a:latin typeface="Calibri"/>
+              </a:rPr>
+              <a:t>Play-by-play says Brown's live-ball TO rate (1.75/36) was LOWER than Tatum's (1.84) in 2024-25. That angle exonerates him — and the media consensus graded the trade for Philadelphia.</a:t>
+            </a:r>
+          </a:p>
+        </p:txBody>
+      </p:sp>
+      <p:sp>
+        <p:nvSpPr>
+          <p:cNvPr id="16" name="TextBox 15"/>
           <p:cNvSpPr txBox="1"/>
           <p:nvPr/>
         </p:nvSpPr>
         <p:spPr>
           <a:xfrm>
-            <a:off x="960120" y="4251960"/>
-            <a:ext cx="10424160" cy="914400"/>
+            <a:off x="566928" y="5212080"/>
+            <a:ext cx="11064240" cy="548640"/>
           </a:xfrm>
           <a:prstGeom prst="rect">
             <a:avLst/>
@@ -8389,40 +8635,40 @@
                 <a:spcPct val="110000"/>
               </a:lnSpc>
               <a:spcAft>
-                <a:spcPts val="200"/>
-              </a:spcAft>
-            </a:pPr>
-            <a:r>
-              <a:rPr sz="2100" b="1" i="0">
-                <a:solidFill>
-                  <a:srgbClr val="FFFFFF"/>
-                </a:solidFill>
-                <a:latin typeface="Cambria"/>
-              </a:rPr>
-              <a:t>The return buys identity and optionality.  </a:t>
-            </a:r>
-            <a:r>
-              <a:rPr sz="1500" b="0" i="0">
-                <a:solidFill>
-                  <a:srgbClr val="CFE0D6"/>
-                </a:solidFill>
-                <a:latin typeface="Calibri"/>
-              </a:rPr>
-              <a:t>George takes the system's shots; two firsts add the cheap, controllable assets a capped roster can't otherwise acquire.</a:t>
-            </a:r>
-          </a:p>
-        </p:txBody>
-      </p:sp>
-      <p:sp>
-        <p:nvSpPr>
-          <p:cNvPr id="10" name="TextBox 9"/>
+                <a:spcPts val="400"/>
+              </a:spcAft>
+            </a:pPr>
+            <a:r>
+              <a:rPr sz="1400" b="1" i="0">
+                <a:solidFill>
+                  <a:srgbClr val="0A2A1A"/>
+                </a:solidFill>
+                <a:latin typeface="Calibri"/>
+              </a:rPr>
+              <a:t>An argument that can't survive its own counter-evidence isn't worth presenting. </a:t>
+            </a:r>
+            <a:r>
+              <a:rPr sz="1400" b="0" i="0">
+                <a:solidFill>
+                  <a:srgbClr val="6B7280"/>
+                </a:solidFill>
+                <a:latin typeface="Calibri"/>
+              </a:rPr>
+              <a:t>Every brief in this project ships with its weakest points attached.</a:t>
+            </a:r>
+          </a:p>
+        </p:txBody>
+      </p:sp>
+      <p:sp>
+        <p:nvSpPr>
+          <p:cNvPr id="17" name="TextBox 16"/>
           <p:cNvSpPr txBox="1"/>
           <p:nvPr/>
         </p:nvSpPr>
         <p:spPr>
           <a:xfrm>
-            <a:off x="960120" y="5623560"/>
-            <a:ext cx="10424160" cy="731520"/>
+            <a:off x="566928" y="6510528"/>
+            <a:ext cx="11064240" cy="274320"/>
           </a:xfrm>
           <a:prstGeom prst="rect">
             <a:avLst/>
@@ -8437,29 +8683,29 @@
           <a:p>
             <a:pPr algn="l">
               <a:lnSpc>
-                <a:spcPct val="112000"/>
-              </a:lnSpc>
-              <a:spcAft>
-                <a:spcPts val="400"/>
-              </a:spcAft>
-            </a:pPr>
-            <a:r>
-              <a:rPr sz="1250" b="1" i="0">
-                <a:solidFill>
-                  <a:srgbClr val="8FA89B"/>
-                </a:solidFill>
-                <a:latin typeface="Calibri"/>
-              </a:rPr>
-              <a:t>Honesty note: </a:t>
-            </a:r>
-            <a:r>
-              <a:rPr sz="1250" b="0" i="1">
-                <a:solidFill>
-                  <a:srgbClr val="8FA89B"/>
-                </a:solidFill>
-                <a:latin typeface="Calibri"/>
-              </a:rPr>
-              <a:t>this deck argues Boston's side on purpose; the neutral scorecard, the Tatum-injury confound, and the media's pro-Philadelphia consensus are all documented in the repo.</a:t>
+                <a:spcPct val="100000"/>
+              </a:lnSpc>
+              <a:spcAft>
+                <a:spcPts val="0"/>
+              </a:spcAft>
+            </a:pPr>
+            <a:r>
+              <a:rPr sz="900" b="0" i="0">
+                <a:solidFill>
+                  <a:srgbClr val="6B7280"/>
+                </a:solidFill>
+                <a:latin typeface="Calibri"/>
+              </a:rPr>
+              <a:t>Fit Check · Jaylen Brown Trade Audit</a:t>
+            </a:r>
+            <a:r>
+              <a:rPr sz="900" b="0" i="0">
+                <a:solidFill>
+                  <a:srgbClr val="6B7280"/>
+                </a:solidFill>
+                <a:latin typeface="Calibri"/>
+              </a:rPr>
+              <a:t>      Data: nba_api / Basketball-Reference · 2024-25 &amp; 2025-26 · July 2026</a:t>
             </a:r>
           </a:p>
         </p:txBody>

</xml_diff>